<commit_message>
Add hyperlinked source footnotes to data slides
Each slide that carries hard external data (2 acquisition, 3 course
specs, 4 acreage, 6 Critical Area math, 7 distances, 8 South River) now
shows a small 'Sources:' footnote above the footer with clickable
hyperlinks to the underlying public sources. Adds a SRC map + footnote()
helper; updates README.
</commit_message>
<xml_diff>
--- a/JAL_Queenstown_Harbor_Proposal.pptx
+++ b/JAL_Queenstown_Harbor_Proposal.pptx
@@ -11381,6 +11381,101 @@
           </a:p>
         </p:txBody>
       </p:sp>
+      <p:sp>
+        <p:nvSpPr>
+          <p:cNvPr id="35" name="Text 33"/>
+          <p:cNvSpPr/>
+          <p:nvPr/>
+        </p:nvSpPr>
+        <p:spPr>
+          <a:xfrm>
+            <a:off x="457200" y="6089904"/>
+            <a:ext cx="11274552" cy="237744"/>
+          </a:xfrm>
+          <a:prstGeom prst="rect">
+            <a:avLst/>
+          </a:prstGeom>
+          <a:noFill/>
+          <a:ln/>
+        </p:spPr>
+        <p:txBody>
+          <a:bodyPr wrap="square" lIns="0" tIns="0" rIns="0" bIns="0" rtlCol="0" anchor="ctr"/>
+          <a:lstStyle/>
+          <a:p>
+            <a:pPr algn="l" indent="0" marL="0">
+              <a:buNone/>
+            </a:pPr>
+            <a:r>
+              <a:rPr lang="en-US" sz="700" b="1" dirty="0">
+                <a:solidFill>
+                  <a:srgbClr val="6B5A6B"/>
+                </a:solidFill>
+                <a:latin typeface="DM Sans" pitchFamily="34" charset="0"/>
+                <a:ea typeface="DM Sans" pitchFamily="34" charset="-122"/>
+                <a:cs typeface="DM Sans" pitchFamily="34" charset="-120"/>
+              </a:rPr>
+              <a:t>Sources:  </a:t>
+            </a:r>
+            <a:pPr algn="l" indent="0" marL="0">
+              <a:buNone/>
+            </a:pPr>
+            <a:r>
+              <a:rPr lang="en-US" sz="700" u="sng" dirty="0">
+                <a:solidFill>
+                  <a:srgbClr val="3A243A"/>
+                </a:solidFill>
+                <a:latin typeface="DM Sans" pitchFamily="34" charset="0"/>
+                <a:ea typeface="DM Sans" pitchFamily="34" charset="-122"/>
+                <a:cs typeface="DM Sans" pitchFamily="34" charset="-120"/>
+                <a:hlinkClick r:id="rId1" invalidUrl="" action="" tgtFrame="" tooltip="Club + Resort Business" history="1" highlightClick="0" endSnd="0">
+                  <a:extLst>
+                    <a:ext uri="{A12FA001-AC4F-418D-AE19-62706E023703}">
+                      <ahyp:hlinkClr xmlns:ahyp="http://schemas.microsoft.com/office/drawing/2018/hyperlinkcolor" val="tx"/>
+                    </a:ext>
+                  </a:extLst>
+                </a:hlinkClick>
+              </a:rPr>
+              <a:t>Club + Resort Business</a:t>
+            </a:r>
+            <a:pPr algn="l" indent="0" marL="0">
+              <a:buNone/>
+            </a:pPr>
+            <a:r>
+              <a:rPr lang="en-US" sz="700" dirty="0">
+                <a:solidFill>
+                  <a:srgbClr val="C4B8C4"/>
+                </a:solidFill>
+                <a:latin typeface="DM Sans" pitchFamily="34" charset="0"/>
+                <a:ea typeface="DM Sans" pitchFamily="34" charset="-122"/>
+                <a:cs typeface="DM Sans" pitchFamily="34" charset="-120"/>
+              </a:rPr>
+              <a:t>    ·    </a:t>
+            </a:r>
+            <a:pPr algn="l" indent="0" marL="0">
+              <a:buNone/>
+            </a:pPr>
+            <a:r>
+              <a:rPr lang="en-US" sz="700" u="sng" dirty="0">
+                <a:solidFill>
+                  <a:srgbClr val="3A243A"/>
+                </a:solidFill>
+                <a:latin typeface="DM Sans" pitchFamily="34" charset="0"/>
+                <a:ea typeface="DM Sans" pitchFamily="34" charset="-122"/>
+                <a:cs typeface="DM Sans" pitchFamily="34" charset="-120"/>
+                <a:hlinkClick r:id="rId2" invalidUrl="" action="" tgtFrame="" tooltip="Eye On Annapolis" history="1" highlightClick="0" endSnd="0">
+                  <a:extLst>
+                    <a:ext uri="{A12FA001-AC4F-418D-AE19-62706E023703}">
+                      <ahyp:hlinkClr xmlns:ahyp="http://schemas.microsoft.com/office/drawing/2018/hyperlinkcolor" val="tx"/>
+                    </a:ext>
+                  </a:extLst>
+                </a:hlinkClick>
+              </a:rPr>
+              <a:t>Eye On Annapolis</a:t>
+            </a:r>
+            <a:endParaRPr lang="en-US" sz="700" dirty="0"/>
+          </a:p>
+        </p:txBody>
+      </p:sp>
     </p:spTree>
   </p:cSld>
   <p:clrMapOvr>
@@ -12586,6 +12681,136 @@
           </a:p>
         </p:txBody>
       </p:sp>
+      <p:sp>
+        <p:nvSpPr>
+          <p:cNvPr id="35" name="Text 33"/>
+          <p:cNvSpPr/>
+          <p:nvPr/>
+        </p:nvSpPr>
+        <p:spPr>
+          <a:xfrm>
+            <a:off x="457200" y="6089904"/>
+            <a:ext cx="11274552" cy="237744"/>
+          </a:xfrm>
+          <a:prstGeom prst="rect">
+            <a:avLst/>
+          </a:prstGeom>
+          <a:noFill/>
+          <a:ln/>
+        </p:spPr>
+        <p:txBody>
+          <a:bodyPr wrap="square" lIns="0" tIns="0" rIns="0" bIns="0" rtlCol="0" anchor="ctr"/>
+          <a:lstStyle/>
+          <a:p>
+            <a:pPr algn="l" indent="0" marL="0">
+              <a:buNone/>
+            </a:pPr>
+            <a:r>
+              <a:rPr lang="en-US" sz="700" b="1" dirty="0">
+                <a:solidFill>
+                  <a:srgbClr val="6B5A6B"/>
+                </a:solidFill>
+                <a:latin typeface="DM Sans" pitchFamily="34" charset="0"/>
+                <a:ea typeface="DM Sans" pitchFamily="34" charset="-122"/>
+                <a:cs typeface="DM Sans" pitchFamily="34" charset="-120"/>
+              </a:rPr>
+              <a:t>Sources:  </a:t>
+            </a:r>
+            <a:pPr algn="l" indent="0" marL="0">
+              <a:buNone/>
+            </a:pPr>
+            <a:r>
+              <a:rPr lang="en-US" sz="700" u="sng" dirty="0">
+                <a:solidFill>
+                  <a:srgbClr val="3A243A"/>
+                </a:solidFill>
+                <a:latin typeface="DM Sans" pitchFamily="34" charset="0"/>
+                <a:ea typeface="DM Sans" pitchFamily="34" charset="-122"/>
+                <a:cs typeface="DM Sans" pitchFamily="34" charset="-120"/>
+                <a:hlinkClick r:id="rId1" invalidUrl="" action="" tgtFrame="" tooltip="qhgolf.com" history="1" highlightClick="0" endSnd="0">
+                  <a:extLst>
+                    <a:ext uri="{A12FA001-AC4F-418D-AE19-62706E023703}">
+                      <ahyp:hlinkClr xmlns:ahyp="http://schemas.microsoft.com/office/drawing/2018/hyperlinkcolor" val="tx"/>
+                    </a:ext>
+                  </a:extLst>
+                </a:hlinkClick>
+              </a:rPr>
+              <a:t>qhgolf.com</a:t>
+            </a:r>
+            <a:pPr algn="l" indent="0" marL="0">
+              <a:buNone/>
+            </a:pPr>
+            <a:r>
+              <a:rPr lang="en-US" sz="700" dirty="0">
+                <a:solidFill>
+                  <a:srgbClr val="C4B8C4"/>
+                </a:solidFill>
+                <a:latin typeface="DM Sans" pitchFamily="34" charset="0"/>
+                <a:ea typeface="DM Sans" pitchFamily="34" charset="-122"/>
+                <a:cs typeface="DM Sans" pitchFamily="34" charset="-120"/>
+              </a:rPr>
+              <a:t>    ·    </a:t>
+            </a:r>
+            <a:pPr algn="l" indent="0" marL="0">
+              <a:buNone/>
+            </a:pPr>
+            <a:r>
+              <a:rPr lang="en-US" sz="700" u="sng" dirty="0">
+                <a:solidFill>
+                  <a:srgbClr val="3A243A"/>
+                </a:solidFill>
+                <a:latin typeface="DM Sans" pitchFamily="34" charset="0"/>
+                <a:ea typeface="DM Sans" pitchFamily="34" charset="-122"/>
+                <a:cs typeface="DM Sans" pitchFamily="34" charset="-120"/>
+                <a:hlinkClick r:id="rId2" invalidUrl="" action="" tgtFrame="" tooltip="GolfDigest" history="1" highlightClick="0" endSnd="0">
+                  <a:extLst>
+                    <a:ext uri="{A12FA001-AC4F-418D-AE19-62706E023703}">
+                      <ahyp:hlinkClr xmlns:ahyp="http://schemas.microsoft.com/office/drawing/2018/hyperlinkcolor" val="tx"/>
+                    </a:ext>
+                  </a:extLst>
+                </a:hlinkClick>
+              </a:rPr>
+              <a:t>GolfDigest</a:t>
+            </a:r>
+            <a:pPr algn="l" indent="0" marL="0">
+              <a:buNone/>
+            </a:pPr>
+            <a:r>
+              <a:rPr lang="en-US" sz="700" dirty="0">
+                <a:solidFill>
+                  <a:srgbClr val="C4B8C4"/>
+                </a:solidFill>
+                <a:latin typeface="DM Sans" pitchFamily="34" charset="0"/>
+                <a:ea typeface="DM Sans" pitchFamily="34" charset="-122"/>
+                <a:cs typeface="DM Sans" pitchFamily="34" charset="-120"/>
+              </a:rPr>
+              <a:t>    ·    </a:t>
+            </a:r>
+            <a:pPr algn="l" indent="0" marL="0">
+              <a:buNone/>
+            </a:pPr>
+            <a:r>
+              <a:rPr lang="en-US" sz="700" u="sng" dirty="0">
+                <a:solidFill>
+                  <a:srgbClr val="3A243A"/>
+                </a:solidFill>
+                <a:latin typeface="DM Sans" pitchFamily="34" charset="0"/>
+                <a:ea typeface="DM Sans" pitchFamily="34" charset="-122"/>
+                <a:cs typeface="DM Sans" pitchFamily="34" charset="-120"/>
+                <a:hlinkClick r:id="rId3" invalidUrl="" action="" tgtFrame="" tooltip="VisitMaryland" history="1" highlightClick="0" endSnd="0">
+                  <a:extLst>
+                    <a:ext uri="{A12FA001-AC4F-418D-AE19-62706E023703}">
+                      <ahyp:hlinkClr xmlns:ahyp="http://schemas.microsoft.com/office/drawing/2018/hyperlinkcolor" val="tx"/>
+                    </a:ext>
+                  </a:extLst>
+                </a:hlinkClick>
+              </a:rPr>
+              <a:t>VisitMaryland</a:t>
+            </a:r>
+            <a:endParaRPr lang="en-US" sz="700" dirty="0"/>
+          </a:p>
+        </p:txBody>
+      </p:sp>
     </p:spTree>
   </p:cSld>
   <p:clrMapOvr>
@@ -13791,6 +14016,101 @@
           </a:p>
         </p:txBody>
       </p:sp>
+      <p:sp>
+        <p:nvSpPr>
+          <p:cNvPr id="35" name="Text 33"/>
+          <p:cNvSpPr/>
+          <p:nvPr/>
+        </p:nvSpPr>
+        <p:spPr>
+          <a:xfrm>
+            <a:off x="457200" y="6089904"/>
+            <a:ext cx="11274552" cy="237744"/>
+          </a:xfrm>
+          <a:prstGeom prst="rect">
+            <a:avLst/>
+          </a:prstGeom>
+          <a:noFill/>
+          <a:ln/>
+        </p:spPr>
+        <p:txBody>
+          <a:bodyPr wrap="square" lIns="0" tIns="0" rIns="0" bIns="0" rtlCol="0" anchor="ctr"/>
+          <a:lstStyle/>
+          <a:p>
+            <a:pPr algn="l" indent="0" marL="0">
+              <a:buNone/>
+            </a:pPr>
+            <a:r>
+              <a:rPr lang="en-US" sz="700" b="1" dirty="0">
+                <a:solidFill>
+                  <a:srgbClr val="6B5A6B"/>
+                </a:solidFill>
+                <a:latin typeface="DM Sans" pitchFamily="34" charset="0"/>
+                <a:ea typeface="DM Sans" pitchFamily="34" charset="-122"/>
+                <a:cs typeface="DM Sans" pitchFamily="34" charset="-120"/>
+              </a:rPr>
+              <a:t>Sources:  </a:t>
+            </a:r>
+            <a:pPr algn="l" indent="0" marL="0">
+              <a:buNone/>
+            </a:pPr>
+            <a:r>
+              <a:rPr lang="en-US" sz="700" u="sng" dirty="0">
+                <a:solidFill>
+                  <a:srgbClr val="3A243A"/>
+                </a:solidFill>
+                <a:latin typeface="DM Sans" pitchFamily="34" charset="0"/>
+                <a:ea typeface="DM Sans" pitchFamily="34" charset="-122"/>
+                <a:cs typeface="DM Sans" pitchFamily="34" charset="-120"/>
+                <a:hlinkClick r:id="rId1" invalidUrl="" action="" tgtFrame="" tooltip="Club + Resort Business" history="1" highlightClick="0" endSnd="0">
+                  <a:extLst>
+                    <a:ext uri="{A12FA001-AC4F-418D-AE19-62706E023703}">
+                      <ahyp:hlinkClr xmlns:ahyp="http://schemas.microsoft.com/office/drawing/2018/hyperlinkcolor" val="tx"/>
+                    </a:ext>
+                  </a:extLst>
+                </a:hlinkClick>
+              </a:rPr>
+              <a:t>Club + Resort Business</a:t>
+            </a:r>
+            <a:pPr algn="l" indent="0" marL="0">
+              <a:buNone/>
+            </a:pPr>
+            <a:r>
+              <a:rPr lang="en-US" sz="700" dirty="0">
+                <a:solidFill>
+                  <a:srgbClr val="C4B8C4"/>
+                </a:solidFill>
+                <a:latin typeface="DM Sans" pitchFamily="34" charset="0"/>
+                <a:ea typeface="DM Sans" pitchFamily="34" charset="-122"/>
+                <a:cs typeface="DM Sans" pitchFamily="34" charset="-120"/>
+              </a:rPr>
+              <a:t>    ·    </a:t>
+            </a:r>
+            <a:pPr algn="l" indent="0" marL="0">
+              <a:buNone/>
+            </a:pPr>
+            <a:r>
+              <a:rPr lang="en-US" sz="700" u="sng" dirty="0">
+                <a:solidFill>
+                  <a:srgbClr val="3A243A"/>
+                </a:solidFill>
+                <a:latin typeface="DM Sans" pitchFamily="34" charset="0"/>
+                <a:ea typeface="DM Sans" pitchFamily="34" charset="-122"/>
+                <a:cs typeface="DM Sans" pitchFamily="34" charset="-120"/>
+                <a:hlinkClick r:id="rId2" invalidUrl="" action="" tgtFrame="" tooltip="qhgolf.com/who-we-are" history="1" highlightClick="0" endSnd="0">
+                  <a:extLst>
+                    <a:ext uri="{A12FA001-AC4F-418D-AE19-62706E023703}">
+                      <ahyp:hlinkClr xmlns:ahyp="http://schemas.microsoft.com/office/drawing/2018/hyperlinkcolor" val="tx"/>
+                    </a:ext>
+                  </a:extLst>
+                </a:hlinkClick>
+              </a:rPr>
+              <a:t>qhgolf.com/who-we-are</a:t>
+            </a:r>
+            <a:endParaRPr lang="en-US" sz="700" dirty="0"/>
+          </a:p>
+        </p:txBody>
+      </p:sp>
     </p:spTree>
   </p:cSld>
   <p:clrMapOvr>
@@ -17133,6 +17453,136 @@
           </a:p>
         </p:txBody>
       </p:sp>
+      <p:sp>
+        <p:nvSpPr>
+          <p:cNvPr id="69" name="Text 67"/>
+          <p:cNvSpPr/>
+          <p:nvPr/>
+        </p:nvSpPr>
+        <p:spPr>
+          <a:xfrm>
+            <a:off x="457200" y="6053328"/>
+            <a:ext cx="11274552" cy="237744"/>
+          </a:xfrm>
+          <a:prstGeom prst="rect">
+            <a:avLst/>
+          </a:prstGeom>
+          <a:noFill/>
+          <a:ln/>
+        </p:spPr>
+        <p:txBody>
+          <a:bodyPr wrap="square" lIns="0" tIns="0" rIns="0" bIns="0" rtlCol="0" anchor="ctr"/>
+          <a:lstStyle/>
+          <a:p>
+            <a:pPr algn="l" indent="0" marL="0">
+              <a:buNone/>
+            </a:pPr>
+            <a:r>
+              <a:rPr lang="en-US" sz="700" b="1" dirty="0">
+                <a:solidFill>
+                  <a:srgbClr val="6B5A6B"/>
+                </a:solidFill>
+                <a:latin typeface="DM Sans" pitchFamily="34" charset="0"/>
+                <a:ea typeface="DM Sans" pitchFamily="34" charset="-122"/>
+                <a:cs typeface="DM Sans" pitchFamily="34" charset="-120"/>
+              </a:rPr>
+              <a:t>Sources:  </a:t>
+            </a:r>
+            <a:pPr algn="l" indent="0" marL="0">
+              <a:buNone/>
+            </a:pPr>
+            <a:r>
+              <a:rPr lang="en-US" sz="700" u="sng" dirty="0">
+                <a:solidFill>
+                  <a:srgbClr val="3A243A"/>
+                </a:solidFill>
+                <a:latin typeface="DM Sans" pitchFamily="34" charset="0"/>
+                <a:ea typeface="DM Sans" pitchFamily="34" charset="-122"/>
+                <a:cs typeface="DM Sans" pitchFamily="34" charset="-120"/>
+                <a:hlinkClick r:id="rId1" invalidUrl="" action="" tgtFrame="" tooltip="qhgolf.com/who-we-are" history="1" highlightClick="0" endSnd="0">
+                  <a:extLst>
+                    <a:ext uri="{A12FA001-AC4F-418D-AE19-62706E023703}">
+                      <ahyp:hlinkClr xmlns:ahyp="http://schemas.microsoft.com/office/drawing/2018/hyperlinkcolor" val="tx"/>
+                    </a:ext>
+                  </a:extLst>
+                </a:hlinkClick>
+              </a:rPr>
+              <a:t>qhgolf.com/who-we-are</a:t>
+            </a:r>
+            <a:pPr algn="l" indent="0" marL="0">
+              <a:buNone/>
+            </a:pPr>
+            <a:r>
+              <a:rPr lang="en-US" sz="700" dirty="0">
+                <a:solidFill>
+                  <a:srgbClr val="C4B8C4"/>
+                </a:solidFill>
+                <a:latin typeface="DM Sans" pitchFamily="34" charset="0"/>
+                <a:ea typeface="DM Sans" pitchFamily="34" charset="-122"/>
+                <a:cs typeface="DM Sans" pitchFamily="34" charset="-120"/>
+              </a:rPr>
+              <a:t>    ·    </a:t>
+            </a:r>
+            <a:pPr algn="l" indent="0" marL="0">
+              <a:buNone/>
+            </a:pPr>
+            <a:r>
+              <a:rPr lang="en-US" sz="700" u="sng" dirty="0">
+                <a:solidFill>
+                  <a:srgbClr val="3A243A"/>
+                </a:solidFill>
+                <a:latin typeface="DM Sans" pitchFamily="34" charset="0"/>
+                <a:ea typeface="DM Sans" pitchFamily="34" charset="-122"/>
+                <a:cs typeface="DM Sans" pitchFamily="34" charset="-120"/>
+                <a:hlinkClick r:id="rId2" invalidUrl="" action="" tgtFrame="" tooltip="Queen Anne's Co. — Critical Area" history="1" highlightClick="0" endSnd="0">
+                  <a:extLst>
+                    <a:ext uri="{A12FA001-AC4F-418D-AE19-62706E023703}">
+                      <ahyp:hlinkClr xmlns:ahyp="http://schemas.microsoft.com/office/drawing/2018/hyperlinkcolor" val="tx"/>
+                    </a:ext>
+                  </a:extLst>
+                </a:hlinkClick>
+              </a:rPr>
+              <a:t>Queen Anne's Co. — Critical Area</a:t>
+            </a:r>
+            <a:pPr algn="l" indent="0" marL="0">
+              <a:buNone/>
+            </a:pPr>
+            <a:r>
+              <a:rPr lang="en-US" sz="700" dirty="0">
+                <a:solidFill>
+                  <a:srgbClr val="C4B8C4"/>
+                </a:solidFill>
+                <a:latin typeface="DM Sans" pitchFamily="34" charset="0"/>
+                <a:ea typeface="DM Sans" pitchFamily="34" charset="-122"/>
+                <a:cs typeface="DM Sans" pitchFamily="34" charset="-120"/>
+              </a:rPr>
+              <a:t>    ·    </a:t>
+            </a:r>
+            <a:pPr algn="l" indent="0" marL="0">
+              <a:buNone/>
+            </a:pPr>
+            <a:r>
+              <a:rPr lang="en-US" sz="700" u="sng" dirty="0">
+                <a:solidFill>
+                  <a:srgbClr val="3A243A"/>
+                </a:solidFill>
+                <a:latin typeface="DM Sans" pitchFamily="34" charset="0"/>
+                <a:ea typeface="DM Sans" pitchFamily="34" charset="-122"/>
+                <a:cs typeface="DM Sans" pitchFamily="34" charset="-120"/>
+                <a:hlinkClick r:id="rId3" invalidUrl="" action="" tgtFrame="" tooltip="MD DNR — Critical Area" history="1" highlightClick="0" endSnd="0">
+                  <a:extLst>
+                    <a:ext uri="{A12FA001-AC4F-418D-AE19-62706E023703}">
+                      <ahyp:hlinkClr xmlns:ahyp="http://schemas.microsoft.com/office/drawing/2018/hyperlinkcolor" val="tx"/>
+                    </a:ext>
+                  </a:extLst>
+                </a:hlinkClick>
+              </a:rPr>
+              <a:t>MD DNR — Critical Area</a:t>
+            </a:r>
+            <a:endParaRPr lang="en-US" sz="700" dirty="0"/>
+          </a:p>
+        </p:txBody>
+      </p:sp>
     </p:spTree>
   </p:cSld>
   <p:clrMapOvr>
@@ -18632,6 +19082,101 @@
           </a:p>
         </p:txBody>
       </p:sp>
+      <p:sp>
+        <p:nvSpPr>
+          <p:cNvPr id="49" name="Text 47"/>
+          <p:cNvSpPr/>
+          <p:nvPr/>
+        </p:nvSpPr>
+        <p:spPr>
+          <a:xfrm>
+            <a:off x="457200" y="5321808"/>
+            <a:ext cx="11274552" cy="237744"/>
+          </a:xfrm>
+          <a:prstGeom prst="rect">
+            <a:avLst/>
+          </a:prstGeom>
+          <a:noFill/>
+          <a:ln/>
+        </p:spPr>
+        <p:txBody>
+          <a:bodyPr wrap="square" lIns="0" tIns="0" rIns="0" bIns="0" rtlCol="0" anchor="ctr"/>
+          <a:lstStyle/>
+          <a:p>
+            <a:pPr algn="l" indent="0" marL="0">
+              <a:buNone/>
+            </a:pPr>
+            <a:r>
+              <a:rPr lang="en-US" sz="700" b="1" dirty="0">
+                <a:solidFill>
+                  <a:srgbClr val="6B5A6B"/>
+                </a:solidFill>
+                <a:latin typeface="DM Sans" pitchFamily="34" charset="0"/>
+                <a:ea typeface="DM Sans" pitchFamily="34" charset="-122"/>
+                <a:cs typeface="DM Sans" pitchFamily="34" charset="-120"/>
+              </a:rPr>
+              <a:t>Sources:  </a:t>
+            </a:r>
+            <a:pPr algn="l" indent="0" marL="0">
+              <a:buNone/>
+            </a:pPr>
+            <a:r>
+              <a:rPr lang="en-US" sz="700" u="sng" dirty="0">
+                <a:solidFill>
+                  <a:srgbClr val="3A243A"/>
+                </a:solidFill>
+                <a:latin typeface="DM Sans" pitchFamily="34" charset="0"/>
+                <a:ea typeface="DM Sans" pitchFamily="34" charset="-122"/>
+                <a:cs typeface="DM Sans" pitchFamily="34" charset="-120"/>
+                <a:hlinkClick r:id="rId1" invalidUrl="" action="" tgtFrame="" tooltip="distance-cities.com" history="1" highlightClick="0" endSnd="0">
+                  <a:extLst>
+                    <a:ext uri="{A12FA001-AC4F-418D-AE19-62706E023703}">
+                      <ahyp:hlinkClr xmlns:ahyp="http://schemas.microsoft.com/office/drawing/2018/hyperlinkcolor" val="tx"/>
+                    </a:ext>
+                  </a:extLst>
+                </a:hlinkClick>
+              </a:rPr>
+              <a:t>distance-cities.com</a:t>
+            </a:r>
+            <a:pPr algn="l" indent="0" marL="0">
+              <a:buNone/>
+            </a:pPr>
+            <a:r>
+              <a:rPr lang="en-US" sz="700" dirty="0">
+                <a:solidFill>
+                  <a:srgbClr val="C4B8C4"/>
+                </a:solidFill>
+                <a:latin typeface="DM Sans" pitchFamily="34" charset="0"/>
+                <a:ea typeface="DM Sans" pitchFamily="34" charset="-122"/>
+                <a:cs typeface="DM Sans" pitchFamily="34" charset="-120"/>
+              </a:rPr>
+              <a:t>    ·    </a:t>
+            </a:r>
+            <a:pPr algn="l" indent="0" marL="0">
+              <a:buNone/>
+            </a:pPr>
+            <a:r>
+              <a:rPr lang="en-US" sz="700" u="sng" dirty="0">
+                <a:solidFill>
+                  <a:srgbClr val="3A243A"/>
+                </a:solidFill>
+                <a:latin typeface="DM Sans" pitchFamily="34" charset="0"/>
+                <a:ea typeface="DM Sans" pitchFamily="34" charset="-122"/>
+                <a:cs typeface="DM Sans" pitchFamily="34" charset="-120"/>
+                <a:hlinkClick r:id="rId2" invalidUrl="" action="" tgtFrame="" tooltip="Queen Anne's Co. — Critical Area" history="1" highlightClick="0" endSnd="0">
+                  <a:extLst>
+                    <a:ext uri="{A12FA001-AC4F-418D-AE19-62706E023703}">
+                      <ahyp:hlinkClr xmlns:ahyp="http://schemas.microsoft.com/office/drawing/2018/hyperlinkcolor" val="tx"/>
+                    </a:ext>
+                  </a:extLst>
+                </a:hlinkClick>
+              </a:rPr>
+              <a:t>Queen Anne's Co. — Critical Area</a:t>
+            </a:r>
+            <a:endParaRPr lang="en-US" sz="700" dirty="0"/>
+          </a:p>
+        </p:txBody>
+      </p:sp>
     </p:spTree>
   </p:cSld>
   <p:clrMapOvr>
@@ -19834,6 +20379,136 @@
               <a:t>Assess limited parcel entitlement without disturbing the member experience.</a:t>
             </a:r>
             <a:endParaRPr lang="en-US" sz="1000" dirty="0"/>
+          </a:p>
+        </p:txBody>
+      </p:sp>
+      <p:sp>
+        <p:nvSpPr>
+          <p:cNvPr id="35" name="Text 33"/>
+          <p:cNvSpPr/>
+          <p:nvPr/>
+        </p:nvSpPr>
+        <p:spPr>
+          <a:xfrm>
+            <a:off x="457200" y="6089904"/>
+            <a:ext cx="11274552" cy="237744"/>
+          </a:xfrm>
+          <a:prstGeom prst="rect">
+            <a:avLst/>
+          </a:prstGeom>
+          <a:noFill/>
+          <a:ln/>
+        </p:spPr>
+        <p:txBody>
+          <a:bodyPr wrap="square" lIns="0" tIns="0" rIns="0" bIns="0" rtlCol="0" anchor="ctr"/>
+          <a:lstStyle/>
+          <a:p>
+            <a:pPr algn="l" indent="0" marL="0">
+              <a:buNone/>
+            </a:pPr>
+            <a:r>
+              <a:rPr lang="en-US" sz="700" b="1" dirty="0">
+                <a:solidFill>
+                  <a:srgbClr val="6B5A6B"/>
+                </a:solidFill>
+                <a:latin typeface="DM Sans" pitchFamily="34" charset="0"/>
+                <a:ea typeface="DM Sans" pitchFamily="34" charset="-122"/>
+                <a:cs typeface="DM Sans" pitchFamily="34" charset="-120"/>
+              </a:rPr>
+              <a:t>Sources:  </a:t>
+            </a:r>
+            <a:pPr algn="l" indent="0" marL="0">
+              <a:buNone/>
+            </a:pPr>
+            <a:r>
+              <a:rPr lang="en-US" sz="700" u="sng" dirty="0">
+                <a:solidFill>
+                  <a:srgbClr val="3A243A"/>
+                </a:solidFill>
+                <a:latin typeface="DM Sans" pitchFamily="34" charset="0"/>
+                <a:ea typeface="DM Sans" pitchFamily="34" charset="-122"/>
+                <a:cs typeface="DM Sans" pitchFamily="34" charset="-120"/>
+                <a:hlinkClick r:id="rId1" invalidUrl="" action="" tgtFrame="" tooltip="golfclubsr.com" history="1" highlightClick="0" endSnd="0">
+                  <a:extLst>
+                    <a:ext uri="{A12FA001-AC4F-418D-AE19-62706E023703}">
+                      <ahyp:hlinkClr xmlns:ahyp="http://schemas.microsoft.com/office/drawing/2018/hyperlinkcolor" val="tx"/>
+                    </a:ext>
+                  </a:extLst>
+                </a:hlinkClick>
+              </a:rPr>
+              <a:t>golfclubsr.com</a:t>
+            </a:r>
+            <a:pPr algn="l" indent="0" marL="0">
+              <a:buNone/>
+            </a:pPr>
+            <a:r>
+              <a:rPr lang="en-US" sz="700" dirty="0">
+                <a:solidFill>
+                  <a:srgbClr val="C4B8C4"/>
+                </a:solidFill>
+                <a:latin typeface="DM Sans" pitchFamily="34" charset="0"/>
+                <a:ea typeface="DM Sans" pitchFamily="34" charset="-122"/>
+                <a:cs typeface="DM Sans" pitchFamily="34" charset="-120"/>
+              </a:rPr>
+              <a:t>    ·    </a:t>
+            </a:r>
+            <a:pPr algn="l" indent="0" marL="0">
+              <a:buNone/>
+            </a:pPr>
+            <a:r>
+              <a:rPr lang="en-US" sz="700" u="sng" dirty="0">
+                <a:solidFill>
+                  <a:srgbClr val="3A243A"/>
+                </a:solidFill>
+                <a:latin typeface="DM Sans" pitchFamily="34" charset="0"/>
+                <a:ea typeface="DM Sans" pitchFamily="34" charset="-122"/>
+                <a:cs typeface="DM Sans" pitchFamily="34" charset="-120"/>
+                <a:hlinkClick r:id="rId2" invalidUrl="" action="" tgtFrame="" tooltip="foretee.com" history="1" highlightClick="0" endSnd="0">
+                  <a:extLst>
+                    <a:ext uri="{A12FA001-AC4F-418D-AE19-62706E023703}">
+                      <ahyp:hlinkClr xmlns:ahyp="http://schemas.microsoft.com/office/drawing/2018/hyperlinkcolor" val="tx"/>
+                    </a:ext>
+                  </a:extLst>
+                </a:hlinkClick>
+              </a:rPr>
+              <a:t>foretee.com</a:t>
+            </a:r>
+            <a:pPr algn="l" indent="0" marL="0">
+              <a:buNone/>
+            </a:pPr>
+            <a:r>
+              <a:rPr lang="en-US" sz="700" dirty="0">
+                <a:solidFill>
+                  <a:srgbClr val="C4B8C4"/>
+                </a:solidFill>
+                <a:latin typeface="DM Sans" pitchFamily="34" charset="0"/>
+                <a:ea typeface="DM Sans" pitchFamily="34" charset="-122"/>
+                <a:cs typeface="DM Sans" pitchFamily="34" charset="-120"/>
+              </a:rPr>
+              <a:t>    ·    </a:t>
+            </a:r>
+            <a:pPr algn="l" indent="0" marL="0">
+              <a:buNone/>
+            </a:pPr>
+            <a:r>
+              <a:rPr lang="en-US" sz="700" u="sng" dirty="0">
+                <a:solidFill>
+                  <a:srgbClr val="3A243A"/>
+                </a:solidFill>
+                <a:latin typeface="DM Sans" pitchFamily="34" charset="0"/>
+                <a:ea typeface="DM Sans" pitchFamily="34" charset="-122"/>
+                <a:cs typeface="DM Sans" pitchFamily="34" charset="-120"/>
+                <a:hlinkClick r:id="rId3" invalidUrl="" action="" tgtFrame="" tooltip="Club + Resort Business" history="1" highlightClick="0" endSnd="0">
+                  <a:extLst>
+                    <a:ext uri="{A12FA001-AC4F-418D-AE19-62706E023703}">
+                      <ahyp:hlinkClr xmlns:ahyp="http://schemas.microsoft.com/office/drawing/2018/hyperlinkcolor" val="tx"/>
+                    </a:ext>
+                  </a:extLst>
+                </a:hlinkClick>
+              </a:rPr>
+              <a:t>Club + Resort Business</a:t>
+            </a:r>
+            <a:endParaRPr lang="en-US" sz="700" dirty="0"/>
           </a:p>
         </p:txBody>
       </p:sp>

</xml_diff>

<commit_message>
Finalize comp: $15K/mo retainer + expenses reimbursed
Set the advisory retainer to a flat $15K/month (creditable against
success fees) and add a dedicated 'Expenses — reimbursed at cost' row
(travel, survey, market & entitlement studies; billed separately, not
netted from fees) on the engagement slide.
</commit_message>
<xml_diff>
--- a/JAL_Queenstown_Harbor_Proposal.pptx
+++ b/JAL_Queenstown_Harbor_Proposal.pptx
@@ -780,7 +780,7 @@
           <a:p>
             <a:r>
               <a:rPr lang="en-US" dirty="0"/>
-              <a:t>Directly answers Bob's comp question. He said skin in the game; I agree and propose a hybrid — modest, creditable retainer + carry on lot-sale value. All numbers are opening positions.</a:t>
+              <a:t>Directly answers Bob's comp question. Hybrid: $15K/mo creditable retainer (≈ one day/week) + expenses reimbursed, then placement fees and the promote. Lead with alignment — the retainer is a floor, the carry is the prize.</a:t>
             </a:r>
             <a:endParaRPr lang="en-US" dirty="0"/>
           </a:p>
@@ -5740,7 +5740,7 @@
         </p:nvSpPr>
         <p:spPr>
           <a:xfrm>
-            <a:off x="457200" y="2880360"/>
+            <a:off x="457200" y="2852928"/>
             <a:ext cx="3108960" cy="365760"/>
           </a:xfrm>
           <a:prstGeom prst="rect">
@@ -5760,7 +5760,7 @@
         </p:nvSpPr>
         <p:spPr>
           <a:xfrm>
-            <a:off x="457200" y="2880360"/>
+            <a:off x="457200" y="2852928"/>
             <a:ext cx="3108960" cy="365760"/>
           </a:xfrm>
           <a:prstGeom prst="rect">
@@ -5799,7 +5799,7 @@
         </p:nvSpPr>
         <p:spPr>
           <a:xfrm>
-            <a:off x="3566160" y="2880360"/>
+            <a:off x="3566160" y="2852928"/>
             <a:ext cx="2743200" cy="365760"/>
           </a:xfrm>
           <a:prstGeom prst="rect">
@@ -5819,7 +5819,7 @@
         </p:nvSpPr>
         <p:spPr>
           <a:xfrm>
-            <a:off x="3566160" y="2880360"/>
+            <a:off x="3566160" y="2852928"/>
             <a:ext cx="2743200" cy="365760"/>
           </a:xfrm>
           <a:prstGeom prst="rect">
@@ -5858,7 +5858,7 @@
         </p:nvSpPr>
         <p:spPr>
           <a:xfrm>
-            <a:off x="6309360" y="2880360"/>
+            <a:off x="6309360" y="2852928"/>
             <a:ext cx="5422392" cy="365760"/>
           </a:xfrm>
           <a:prstGeom prst="rect">
@@ -5878,7 +5878,7 @@
         </p:nvSpPr>
         <p:spPr>
           <a:xfrm>
-            <a:off x="6309360" y="2880360"/>
+            <a:off x="6309360" y="2852928"/>
             <a:ext cx="5422392" cy="365760"/>
           </a:xfrm>
           <a:prstGeom prst="rect">
@@ -5917,8 +5917,8 @@
         </p:nvSpPr>
         <p:spPr>
           <a:xfrm>
-            <a:off x="457200" y="3246120"/>
-            <a:ext cx="3108960" cy="713232"/>
+            <a:off x="457200" y="3218688"/>
+            <a:ext cx="3108960" cy="640080"/>
           </a:xfrm>
           <a:prstGeom prst="rect">
             <a:avLst/>
@@ -5937,8 +5937,8 @@
         </p:nvSpPr>
         <p:spPr>
           <a:xfrm>
-            <a:off x="457200" y="3246120"/>
-            <a:ext cx="3108960" cy="713232"/>
+            <a:off x="457200" y="3218688"/>
+            <a:ext cx="3108960" cy="640080"/>
           </a:xfrm>
           <a:prstGeom prst="rect">
             <a:avLst/>
@@ -5976,8 +5976,8 @@
         </p:nvSpPr>
         <p:spPr>
           <a:xfrm>
-            <a:off x="3566160" y="3246120"/>
-            <a:ext cx="2743200" cy="713232"/>
+            <a:off x="3566160" y="3218688"/>
+            <a:ext cx="2743200" cy="640080"/>
           </a:xfrm>
           <a:prstGeom prst="rect">
             <a:avLst/>
@@ -5996,8 +5996,8 @@
         </p:nvSpPr>
         <p:spPr>
           <a:xfrm>
-            <a:off x="3566160" y="3246120"/>
-            <a:ext cx="2743200" cy="713232"/>
+            <a:off x="3566160" y="3218688"/>
+            <a:ext cx="2743200" cy="640080"/>
           </a:xfrm>
           <a:prstGeom prst="rect">
             <a:avLst/>
@@ -6021,7 +6021,7 @@
                 <a:ea typeface="Montserrat" pitchFamily="34" charset="-122"/>
                 <a:cs typeface="Montserrat" pitchFamily="34" charset="-120"/>
               </a:rPr>
-              <a:t>$15–25K / mo</a:t>
+              <a:t>$15K / mo</a:t>
             </a:r>
             <a:endParaRPr lang="en-US" sz="1100" dirty="0"/>
           </a:p>
@@ -6035,8 +6035,8 @@
         </p:nvSpPr>
         <p:spPr>
           <a:xfrm>
-            <a:off x="6309360" y="3246120"/>
-            <a:ext cx="5422392" cy="713232"/>
+            <a:off x="6309360" y="3218688"/>
+            <a:ext cx="5422392" cy="640080"/>
           </a:xfrm>
           <a:prstGeom prst="rect">
             <a:avLst/>
@@ -6055,8 +6055,8 @@
         </p:nvSpPr>
         <p:spPr>
           <a:xfrm>
-            <a:off x="6309360" y="3246120"/>
-            <a:ext cx="5422392" cy="713232"/>
+            <a:off x="6309360" y="3218688"/>
+            <a:ext cx="5422392" cy="640080"/>
           </a:xfrm>
           <a:prstGeom prst="rect">
             <a:avLst/>
@@ -6083,7 +6083,7 @@
                 <a:ea typeface="DM Sans" pitchFamily="34" charset="-122"/>
                 <a:cs typeface="DM Sans" pitchFamily="34" charset="-120"/>
               </a:rPr>
-              <a:t>Funds entitlement strategy, underwriting &amp; capital sourcing during an initial term (creditable against success fees)</a:t>
+              <a:t>Funds entitlement, underwriting &amp; capital sourcing during an initial term; creditable against success fees</a:t>
             </a:r>
             <a:endParaRPr lang="en-US" sz="950" dirty="0"/>
           </a:p>
@@ -6097,8 +6097,8 @@
         </p:nvSpPr>
         <p:spPr>
           <a:xfrm>
-            <a:off x="457200" y="3959352"/>
-            <a:ext cx="3108960" cy="713232"/>
+            <a:off x="457200" y="3858768"/>
+            <a:ext cx="3108960" cy="640080"/>
           </a:xfrm>
           <a:prstGeom prst="rect">
             <a:avLst/>
@@ -6117,8 +6117,8 @@
         </p:nvSpPr>
         <p:spPr>
           <a:xfrm>
-            <a:off x="457200" y="3959352"/>
-            <a:ext cx="3108960" cy="713232"/>
+            <a:off x="457200" y="3858768"/>
+            <a:ext cx="3108960" cy="640080"/>
           </a:xfrm>
           <a:prstGeom prst="rect">
             <a:avLst/>
@@ -6142,7 +6142,7 @@
                 <a:ea typeface="Montserrat" pitchFamily="34" charset="-122"/>
                 <a:cs typeface="Montserrat" pitchFamily="34" charset="-120"/>
               </a:rPr>
-              <a:t>Capital placement fee</a:t>
+              <a:t>Expenses</a:t>
             </a:r>
             <a:endParaRPr lang="en-US" sz="1100" dirty="0"/>
           </a:p>
@@ -6156,8 +6156,8 @@
         </p:nvSpPr>
         <p:spPr>
           <a:xfrm>
-            <a:off x="3566160" y="3959352"/>
-            <a:ext cx="2743200" cy="713232"/>
+            <a:off x="3566160" y="3858768"/>
+            <a:ext cx="2743200" cy="640080"/>
           </a:xfrm>
           <a:prstGeom prst="rect">
             <a:avLst/>
@@ -6176,8 +6176,8 @@
         </p:nvSpPr>
         <p:spPr>
           <a:xfrm>
-            <a:off x="3566160" y="3959352"/>
-            <a:ext cx="2743200" cy="713232"/>
+            <a:off x="3566160" y="3858768"/>
+            <a:ext cx="2743200" cy="640080"/>
           </a:xfrm>
           <a:prstGeom prst="rect">
             <a:avLst/>
@@ -6201,7 +6201,7 @@
                 <a:ea typeface="Montserrat" pitchFamily="34" charset="-122"/>
                 <a:cs typeface="Montserrat" pitchFamily="34" charset="-120"/>
               </a:rPr>
-              <a:t>1% debt · 2–3% equity</a:t>
+              <a:t>Reimbursed at cost</a:t>
             </a:r>
             <a:endParaRPr lang="en-US" sz="1100" dirty="0"/>
           </a:p>
@@ -6215,8 +6215,8 @@
         </p:nvSpPr>
         <p:spPr>
           <a:xfrm>
-            <a:off x="6309360" y="3959352"/>
-            <a:ext cx="5422392" cy="713232"/>
+            <a:off x="6309360" y="3858768"/>
+            <a:ext cx="5422392" cy="640080"/>
           </a:xfrm>
           <a:prstGeom prst="rect">
             <a:avLst/>
@@ -6235,8 +6235,8 @@
         </p:nvSpPr>
         <p:spPr>
           <a:xfrm>
-            <a:off x="6309360" y="3959352"/>
-            <a:ext cx="5422392" cy="713232"/>
+            <a:off x="6309360" y="3858768"/>
+            <a:ext cx="5422392" cy="640080"/>
           </a:xfrm>
           <a:prstGeom prst="rect">
             <a:avLst/>
@@ -6263,7 +6263,7 @@
                 <a:ea typeface="DM Sans" pitchFamily="34" charset="-122"/>
                 <a:cs typeface="DM Sans" pitchFamily="34" charset="-120"/>
               </a:rPr>
-              <a:t>Success fee if and when we place debt or equity for a parcel</a:t>
+              <a:t>Travel, survey, market &amp; entitlement studies — billed separately, not netted from fees</a:t>
             </a:r>
             <a:endParaRPr lang="en-US" sz="950" dirty="0"/>
           </a:p>
@@ -6277,8 +6277,8 @@
         </p:nvSpPr>
         <p:spPr>
           <a:xfrm>
-            <a:off x="457200" y="4672584"/>
-            <a:ext cx="3108960" cy="713232"/>
+            <a:off x="457200" y="4498848"/>
+            <a:ext cx="3108960" cy="640080"/>
           </a:xfrm>
           <a:prstGeom prst="rect">
             <a:avLst/>
@@ -6297,8 +6297,8 @@
         </p:nvSpPr>
         <p:spPr>
           <a:xfrm>
-            <a:off x="457200" y="4672584"/>
-            <a:ext cx="3108960" cy="713232"/>
+            <a:off x="457200" y="4498848"/>
+            <a:ext cx="3108960" cy="640080"/>
           </a:xfrm>
           <a:prstGeom prst="rect">
             <a:avLst/>
@@ -6322,7 +6322,7 @@
                 <a:ea typeface="Montserrat" pitchFamily="34" charset="-122"/>
                 <a:cs typeface="Montserrat" pitchFamily="34" charset="-120"/>
               </a:rPr>
-              <a:t>Carried interest</a:t>
+              <a:t>Capital placement fee</a:t>
             </a:r>
             <a:endParaRPr lang="en-US" sz="1100" dirty="0"/>
           </a:p>
@@ -6336,8 +6336,8 @@
         </p:nvSpPr>
         <p:spPr>
           <a:xfrm>
-            <a:off x="3566160" y="4672584"/>
-            <a:ext cx="2743200" cy="713232"/>
+            <a:off x="3566160" y="4498848"/>
+            <a:ext cx="2743200" cy="640080"/>
           </a:xfrm>
           <a:prstGeom prst="rect">
             <a:avLst/>
@@ -6356,8 +6356,8 @@
         </p:nvSpPr>
         <p:spPr>
           <a:xfrm>
-            <a:off x="3566160" y="4672584"/>
-            <a:ext cx="2743200" cy="713232"/>
+            <a:off x="3566160" y="4498848"/>
+            <a:ext cx="2743200" cy="640080"/>
           </a:xfrm>
           <a:prstGeom prst="rect">
             <a:avLst/>
@@ -6381,7 +6381,7 @@
                 <a:ea typeface="Montserrat" pitchFamily="34" charset="-122"/>
                 <a:cs typeface="Montserrat" pitchFamily="34" charset="-120"/>
               </a:rPr>
-              <a:t>Co-GP promote</a:t>
+              <a:t>1% debt · 2–3% equity</a:t>
             </a:r>
             <a:endParaRPr lang="en-US" sz="1100" dirty="0"/>
           </a:p>
@@ -6395,8 +6395,8 @@
         </p:nvSpPr>
         <p:spPr>
           <a:xfrm>
-            <a:off x="6309360" y="4672584"/>
-            <a:ext cx="5422392" cy="713232"/>
+            <a:off x="6309360" y="4498848"/>
+            <a:ext cx="5422392" cy="640080"/>
           </a:xfrm>
           <a:prstGeom prst="rect">
             <a:avLst/>
@@ -6415,8 +6415,8 @@
         </p:nvSpPr>
         <p:spPr>
           <a:xfrm>
-            <a:off x="6309360" y="4672584"/>
-            <a:ext cx="5422392" cy="713232"/>
+            <a:off x="6309360" y="4498848"/>
+            <a:ext cx="5422392" cy="640080"/>
           </a:xfrm>
           <a:prstGeom prst="rect">
             <a:avLst/>
@@ -6443,6 +6443,186 @@
                 <a:ea typeface="DM Sans" pitchFamily="34" charset="-122"/>
                 <a:cs typeface="DM Sans" pitchFamily="34" charset="-120"/>
               </a:rPr>
+              <a:t>Success fee if and when we place debt or equity for a parcel</a:t>
+            </a:r>
+            <a:endParaRPr lang="en-US" sz="950" dirty="0"/>
+          </a:p>
+        </p:txBody>
+      </p:sp>
+      <p:sp>
+        <p:nvSpPr>
+          <p:cNvPr id="41" name="Shape 39"/>
+          <p:cNvSpPr/>
+          <p:nvPr/>
+        </p:nvSpPr>
+        <p:spPr>
+          <a:xfrm>
+            <a:off x="457200" y="5138928"/>
+            <a:ext cx="3108960" cy="640080"/>
+          </a:xfrm>
+          <a:prstGeom prst="rect">
+            <a:avLst/>
+          </a:prstGeom>
+          <a:solidFill>
+            <a:srgbClr val="F4F2ED"/>
+          </a:solidFill>
+          <a:ln/>
+        </p:spPr>
+      </p:sp>
+      <p:sp>
+        <p:nvSpPr>
+          <p:cNvPr id="42" name="Text 40"/>
+          <p:cNvSpPr/>
+          <p:nvPr/>
+        </p:nvSpPr>
+        <p:spPr>
+          <a:xfrm>
+            <a:off x="457200" y="5138928"/>
+            <a:ext cx="3108960" cy="640080"/>
+          </a:xfrm>
+          <a:prstGeom prst="rect">
+            <a:avLst/>
+          </a:prstGeom>
+          <a:noFill/>
+          <a:ln/>
+        </p:spPr>
+        <p:txBody>
+          <a:bodyPr wrap="square" lIns="25400" tIns="76200" rIns="76200" bIns="25400" rtlCol="0" anchor="ctr"/>
+          <a:lstStyle/>
+          <a:p>
+            <a:pPr algn="l" indent="0" marL="0">
+              <a:buNone/>
+            </a:pPr>
+            <a:r>
+              <a:rPr lang="en-US" sz="1100" b="1" dirty="0">
+                <a:solidFill>
+                  <a:srgbClr val="0B163C"/>
+                </a:solidFill>
+                <a:latin typeface="Montserrat" pitchFamily="34" charset="0"/>
+                <a:ea typeface="Montserrat" pitchFamily="34" charset="-122"/>
+                <a:cs typeface="Montserrat" pitchFamily="34" charset="-120"/>
+              </a:rPr>
+              <a:t>Carried interest</a:t>
+            </a:r>
+            <a:endParaRPr lang="en-US" sz="1100" dirty="0"/>
+          </a:p>
+        </p:txBody>
+      </p:sp>
+      <p:sp>
+        <p:nvSpPr>
+          <p:cNvPr id="43" name="Shape 41"/>
+          <p:cNvSpPr/>
+          <p:nvPr/>
+        </p:nvSpPr>
+        <p:spPr>
+          <a:xfrm>
+            <a:off x="3566160" y="5138928"/>
+            <a:ext cx="2743200" cy="640080"/>
+          </a:xfrm>
+          <a:prstGeom prst="rect">
+            <a:avLst/>
+          </a:prstGeom>
+          <a:solidFill>
+            <a:srgbClr val="F4F2ED"/>
+          </a:solidFill>
+          <a:ln/>
+        </p:spPr>
+      </p:sp>
+      <p:sp>
+        <p:nvSpPr>
+          <p:cNvPr id="44" name="Text 42"/>
+          <p:cNvSpPr/>
+          <p:nvPr/>
+        </p:nvSpPr>
+        <p:spPr>
+          <a:xfrm>
+            <a:off x="3566160" y="5138928"/>
+            <a:ext cx="2743200" cy="640080"/>
+          </a:xfrm>
+          <a:prstGeom prst="rect">
+            <a:avLst/>
+          </a:prstGeom>
+          <a:noFill/>
+          <a:ln/>
+        </p:spPr>
+        <p:txBody>
+          <a:bodyPr wrap="square" lIns="25400" tIns="76200" rIns="76200" bIns="25400" rtlCol="0" anchor="ctr"/>
+          <a:lstStyle/>
+          <a:p>
+            <a:pPr algn="ctr" indent="0" marL="0">
+              <a:buNone/>
+            </a:pPr>
+            <a:r>
+              <a:rPr lang="en-US" sz="1100" b="1" dirty="0">
+                <a:solidFill>
+                  <a:srgbClr val="3A243A"/>
+                </a:solidFill>
+                <a:latin typeface="Montserrat" pitchFamily="34" charset="0"/>
+                <a:ea typeface="Montserrat" pitchFamily="34" charset="-122"/>
+                <a:cs typeface="Montserrat" pitchFamily="34" charset="-120"/>
+              </a:rPr>
+              <a:t>Co-GP promote</a:t>
+            </a:r>
+            <a:endParaRPr lang="en-US" sz="1100" dirty="0"/>
+          </a:p>
+        </p:txBody>
+      </p:sp>
+      <p:sp>
+        <p:nvSpPr>
+          <p:cNvPr id="45" name="Shape 43"/>
+          <p:cNvSpPr/>
+          <p:nvPr/>
+        </p:nvSpPr>
+        <p:spPr>
+          <a:xfrm>
+            <a:off x="6309360" y="5138928"/>
+            <a:ext cx="5422392" cy="640080"/>
+          </a:xfrm>
+          <a:prstGeom prst="rect">
+            <a:avLst/>
+          </a:prstGeom>
+          <a:solidFill>
+            <a:srgbClr val="F4F2ED"/>
+          </a:solidFill>
+          <a:ln/>
+        </p:spPr>
+      </p:sp>
+      <p:sp>
+        <p:nvSpPr>
+          <p:cNvPr id="46" name="Text 44"/>
+          <p:cNvSpPr/>
+          <p:nvPr/>
+        </p:nvSpPr>
+        <p:spPr>
+          <a:xfrm>
+            <a:off x="6309360" y="5138928"/>
+            <a:ext cx="5422392" cy="640080"/>
+          </a:xfrm>
+          <a:prstGeom prst="rect">
+            <a:avLst/>
+          </a:prstGeom>
+          <a:noFill/>
+          <a:ln/>
+        </p:spPr>
+        <p:txBody>
+          <a:bodyPr wrap="square" lIns="25400" tIns="76200" rIns="76200" bIns="25400" rtlCol="0" anchor="ctr"/>
+          <a:lstStyle/>
+          <a:p>
+            <a:pPr algn="l" indent="0" marL="0">
+              <a:lnSpc>
+                <a:spcPts val="1200"/>
+              </a:lnSpc>
+              <a:buNone/>
+            </a:pPr>
+            <a:r>
+              <a:rPr lang="en-US" sz="950" dirty="0">
+                <a:solidFill>
+                  <a:srgbClr val="6B5A6B"/>
+                </a:solidFill>
+                <a:latin typeface="DM Sans" pitchFamily="34" charset="0"/>
+                <a:ea typeface="DM Sans" pitchFamily="34" charset="-122"/>
+                <a:cs typeface="DM Sans" pitchFamily="34" charset="-120"/>
+              </a:rPr>
               <a:t>Share of value created on lot sales; JAL co-invests its own capital alongside</a:t>
             </a:r>
             <a:endParaRPr lang="en-US" sz="950" dirty="0"/>
@@ -6451,7 +6631,7 @@
       </p:sp>
       <p:sp>
         <p:nvSpPr>
-          <p:cNvPr id="41" name="Shape 39"/>
+          <p:cNvPr id="47" name="Shape 45"/>
           <p:cNvSpPr/>
           <p:nvPr/>
         </p:nvSpPr>
@@ -6471,7 +6651,7 @@
       </p:sp>
       <p:sp>
         <p:nvSpPr>
-          <p:cNvPr id="42" name="Text 40"/>
+          <p:cNvPr id="48" name="Text 46"/>
           <p:cNvSpPr/>
           <p:nvPr/>
         </p:nvSpPr>

</xml_diff>

<commit_message>
Spell out comp in the engagement headline band
Headline now reads '$15K/mo + expenses, then success fees + carry'
instead of the generic 'Retainer + success fees + carried interest.'
</commit_message>
<xml_diff>
--- a/JAL_Queenstown_Harbor_Proposal.pptx
+++ b/JAL_Queenstown_Harbor_Proposal.pptx
@@ -5601,23 +5601,23 @@
         <p:spPr>
           <a:xfrm>
             <a:off x="3291840" y="1883664"/>
-            <a:ext cx="4937760" cy="365760"/>
-          </a:xfrm>
-          <a:prstGeom prst="rect">
-            <a:avLst/>
-          </a:prstGeom>
-          <a:noFill/>
-          <a:ln/>
-        </p:spPr>
-        <p:txBody>
-          <a:bodyPr wrap="square" lIns="0" tIns="0" rIns="0" bIns="0" rtlCol="0" anchor="ctr"/>
-          <a:lstStyle/>
-          <a:p>
-            <a:pPr algn="l" indent="0" marL="0">
-              <a:buNone/>
-            </a:pPr>
-            <a:r>
-              <a:rPr lang="en-US" sz="1400" b="1" dirty="0">
+            <a:ext cx="5349240" cy="365760"/>
+          </a:xfrm>
+          <a:prstGeom prst="rect">
+            <a:avLst/>
+          </a:prstGeom>
+          <a:noFill/>
+          <a:ln/>
+        </p:spPr>
+        <p:txBody>
+          <a:bodyPr wrap="square" lIns="0" tIns="0" rIns="0" bIns="0" rtlCol="0" anchor="ctr"/>
+          <a:lstStyle/>
+          <a:p>
+            <a:pPr algn="l" indent="0" marL="0">
+              <a:buNone/>
+            </a:pPr>
+            <a:r>
+              <a:rPr lang="en-US" sz="1350" b="1" dirty="0">
                 <a:solidFill>
                   <a:srgbClr val="FFFFFF"/>
                 </a:solidFill>
@@ -5625,9 +5625,9 @@
                 <a:ea typeface="Montserrat" pitchFamily="34" charset="-122"/>
                 <a:cs typeface="Montserrat" pitchFamily="34" charset="-120"/>
               </a:rPr>
-              <a:t>Retainer + success fees + carried interest</a:t>
-            </a:r>
-            <a:endParaRPr lang="en-US" sz="1400" dirty="0"/>
+              <a:t>$15K/mo + expenses, then success fees + carry</a:t>
+            </a:r>
+            <a:endParaRPr lang="en-US" sz="1350" dirty="0"/>
           </a:p>
         </p:txBody>
       </p:sp>
@@ -5640,7 +5640,7 @@
         <p:spPr>
           <a:xfrm>
             <a:off x="3291840" y="2249424"/>
-            <a:ext cx="5120640" cy="320040"/>
+            <a:ext cx="5349240" cy="320040"/>
           </a:xfrm>
           <a:prstGeom prst="rect">
             <a:avLst/>

</xml_diff>

<commit_message>
Add PDF output: dual pptx+pdf render, $15M, discussion-draft framing
- generate.js now records the deck via a render-agnostic proxy and
  replays it to BOTH pptxgenjs and pdfkit, so the .pptx and .pdf are
  identical. Adds JAL_Queenstown_Harbor_Proposal.pdf (brand fonts
  embedded from fonts/; Montserrat & DM Sans, OFL).
- Houston equity raise shown as $15M (was $14M).
- Framed as a non-final discussion document: 'DISCUSSION DRAFT' deck
  label + cover date tag, cover disclaimer, and the data footnote now
  reads 'own research; subject to change & confirmation'.
</commit_message>
<xml_diff>
--- a/JAL_Queenstown_Harbor_Proposal.pptx
+++ b/JAL_Queenstown_Harbor_Proposal.pptx
@@ -604,7 +604,7 @@
           <a:p>
             <a:r>
               <a:rPr lang="en-US" dirty="0"/>
-              <a:t>Bob's inbound was about capital access. Lead with the live Houston deal ($14M / $19.5M) as proof I close, then the network. Even capital-light, this is why I'm useful.</a:t>
+              <a:t>Bob's inbound was about capital access. Lead with the live Houston deal ($15M / $19.5M) as proof I close, then the network. Even capital-light, this is why I'm useful.</a:t>
             </a:r>
             <a:endParaRPr lang="en-US" dirty="0"/>
           </a:p>
@@ -2436,7 +2436,49 @@
       </p:sp>
       <p:sp>
         <p:nvSpPr>
-          <p:cNvPr id="11" name="Shape 9"/>
+          <p:cNvPr id="11" name="Text 9"/>
+          <p:cNvSpPr/>
+          <p:nvPr/>
+        </p:nvSpPr>
+        <p:spPr>
+          <a:xfrm>
+            <a:off x="685800" y="5486400"/>
+            <a:ext cx="10607040" cy="548640"/>
+          </a:xfrm>
+          <a:prstGeom prst="rect">
+            <a:avLst/>
+          </a:prstGeom>
+          <a:noFill/>
+          <a:ln/>
+        </p:spPr>
+        <p:txBody>
+          <a:bodyPr wrap="square" lIns="0" tIns="0" rIns="0" bIns="0" rtlCol="0" anchor="t"/>
+          <a:lstStyle/>
+          <a:p>
+            <a:pPr algn="l" indent="0" marL="0">
+              <a:lnSpc>
+                <a:spcPts val="1200"/>
+              </a:lnSpc>
+              <a:buNone/>
+            </a:pPr>
+            <a:r>
+              <a:rPr lang="en-US" sz="950" dirty="0">
+                <a:solidFill>
+                  <a:srgbClr val="8C9BB5"/>
+                </a:solidFill>
+                <a:latin typeface="DM Sans" pitchFamily="34" charset="0"/>
+                <a:ea typeface="DM Sans" pitchFamily="34" charset="-122"/>
+                <a:cs typeface="DM Sans" pitchFamily="34" charset="-120"/>
+              </a:rPr>
+              <a:t>Preliminary discussion document — not a final proposal or commitment. Figures compiled from public sources and independent research; subject to change and confirmation in further conversations.</a:t>
+            </a:r>
+            <a:endParaRPr lang="en-US" sz="950" dirty="0"/>
+          </a:p>
+        </p:txBody>
+      </p:sp>
+      <p:sp>
+        <p:nvSpPr>
+          <p:cNvPr id="12" name="Shape 10"/>
           <p:cNvSpPr/>
           <p:nvPr/>
         </p:nvSpPr>
@@ -2456,7 +2498,7 @@
       </p:sp>
       <p:sp>
         <p:nvSpPr>
-          <p:cNvPr id="12" name="Text 10"/>
+          <p:cNvPr id="13" name="Text 11"/>
           <p:cNvSpPr/>
           <p:nvPr/>
         </p:nvSpPr>
@@ -2495,7 +2537,7 @@
       </p:sp>
       <p:sp>
         <p:nvSpPr>
-          <p:cNvPr id="13" name="Text 11"/>
+          <p:cNvPr id="14" name="Text 12"/>
           <p:cNvSpPr/>
           <p:nvPr/>
         </p:nvSpPr>
@@ -2518,7 +2560,7 @@
               <a:buNone/>
             </a:pPr>
             <a:r>
-              <a:rPr lang="en-US" sz="900" b="1" spc="150" kern="0" dirty="0">
+              <a:rPr lang="en-US" sz="900" b="1" spc="120" kern="0" dirty="0">
                 <a:solidFill>
                   <a:srgbClr val="C4B8C4"/>
                 </a:solidFill>
@@ -2526,7 +2568,7 @@
                 <a:ea typeface="Montserrat" pitchFamily="34" charset="-122"/>
                 <a:cs typeface="Montserrat" pitchFamily="34" charset="-120"/>
               </a:rPr>
-              <a:t>JUNE 2026  |  CONFIDENTIAL</a:t>
+              <a:t>JUNE 2026  ·  DISCUSSION DRAFT</a:t>
             </a:r>
             <a:endParaRPr lang="en-US" sz="900" dirty="0"/>
           </a:p>
@@ -2656,7 +2698,7 @@
                 <a:ea typeface="Montserrat" pitchFamily="34" charset="-122"/>
                 <a:cs typeface="Montserrat" pitchFamily="34" charset="-120"/>
               </a:rPr>
-              <a:t>QUEENSTOWN HARBOR  |  CONFIDENTIAL</a:t>
+              <a:t>QUEENSTOWN HARBOR  ·  CONFIDENTIAL  ·  DISCUSSION DRAFT</a:t>
             </a:r>
             <a:endParaRPr lang="en-US" sz="900" dirty="0"/>
           </a:p>
@@ -2938,7 +2980,7 @@
                 <a:ea typeface="Montserrat" pitchFamily="34" charset="-122"/>
                 <a:cs typeface="Montserrat" pitchFamily="34" charset="-120"/>
               </a:rPr>
-              <a:t>$14M</a:t>
+              <a:t>$15M</a:t>
             </a:r>
             <a:endParaRPr lang="en-US" sz="2700" dirty="0"/>
           </a:p>
@@ -3861,7 +3903,7 @@
                 <a:ea typeface="Montserrat" pitchFamily="34" charset="-122"/>
                 <a:cs typeface="Montserrat" pitchFamily="34" charset="-120"/>
               </a:rPr>
-              <a:t>QUEENSTOWN HARBOR  |  CONFIDENTIAL</a:t>
+              <a:t>QUEENSTOWN HARBOR  ·  CONFIDENTIAL  ·  DISCUSSION DRAFT</a:t>
             </a:r>
             <a:endParaRPr lang="en-US" sz="900" dirty="0"/>
           </a:p>
@@ -5289,7 +5331,7 @@
                 <a:ea typeface="Montserrat" pitchFamily="34" charset="-122"/>
                 <a:cs typeface="Montserrat" pitchFamily="34" charset="-120"/>
               </a:rPr>
-              <a:t>QUEENSTOWN HARBOR  |  CONFIDENTIAL</a:t>
+              <a:t>QUEENSTOWN HARBOR  ·  CONFIDENTIAL  ·  DISCUSSION DRAFT</a:t>
             </a:r>
             <a:endParaRPr lang="en-US" sz="900" dirty="0"/>
           </a:p>
@@ -6812,7 +6854,7 @@
                 <a:ea typeface="Montserrat" pitchFamily="34" charset="-122"/>
                 <a:cs typeface="Montserrat" pitchFamily="34" charset="-120"/>
               </a:rPr>
-              <a:t>QUEENSTOWN HARBOR  |  CONFIDENTIAL</a:t>
+              <a:t>QUEENSTOWN HARBOR  ·  CONFIDENTIAL  ·  DISCUSSION DRAFT</a:t>
             </a:r>
             <a:endParaRPr lang="en-US" sz="900" dirty="0"/>
           </a:p>
@@ -8151,7 +8193,7 @@
                 <a:ea typeface="Montserrat" pitchFamily="34" charset="-122"/>
                 <a:cs typeface="Montserrat" pitchFamily="34" charset="-120"/>
               </a:rPr>
-              <a:t>QUEENSTOWN HARBOR  |  CONFIDENTIAL</a:t>
+              <a:t>QUEENSTOWN HARBOR  ·  CONFIDENTIAL  ·  DISCUSSION DRAFT</a:t>
             </a:r>
             <a:endParaRPr lang="en-US" sz="900" dirty="0"/>
           </a:p>
@@ -10311,7 +10353,7 @@
                 <a:ea typeface="Montserrat" pitchFamily="34" charset="-122"/>
                 <a:cs typeface="Montserrat" pitchFamily="34" charset="-120"/>
               </a:rPr>
-              <a:t>QUEENSTOWN HARBOR  |  CONFIDENTIAL</a:t>
+              <a:t>QUEENSTOWN HARBOR  ·  CONFIDENTIAL  ·  DISCUSSION DRAFT</a:t>
             </a:r>
             <a:endParaRPr lang="en-US" sz="900" dirty="0"/>
           </a:p>
@@ -10480,7 +10522,7 @@
                 <a:ea typeface="Montserrat" pitchFamily="34" charset="-122"/>
                 <a:cs typeface="Montserrat" pitchFamily="34" charset="-120"/>
               </a:rPr>
-              <a:t>QUEENSTOWN HARBOR  |  CONFIDENTIAL</a:t>
+              <a:t>QUEENSTOWN HARBOR  ·  CONFIDENTIAL  ·  DISCUSSION DRAFT</a:t>
             </a:r>
             <a:endParaRPr lang="en-US" sz="900" dirty="0"/>
           </a:p>
@@ -11594,7 +11636,7 @@
                 <a:ea typeface="DM Sans" pitchFamily="34" charset="-122"/>
                 <a:cs typeface="DM Sans" pitchFamily="34" charset="-120"/>
               </a:rPr>
-              <a:t>Sources:  </a:t>
+              <a:t>Sources (own research; subject to change &amp; confirmation):  </a:t>
             </a:r>
             <a:pPr algn="l" indent="0" marL="0">
               <a:buNone/>
@@ -11780,7 +11822,7 @@
                 <a:ea typeface="Montserrat" pitchFamily="34" charset="-122"/>
                 <a:cs typeface="Montserrat" pitchFamily="34" charset="-120"/>
               </a:rPr>
-              <a:t>QUEENSTOWN HARBOR  |  CONFIDENTIAL</a:t>
+              <a:t>QUEENSTOWN HARBOR  ·  CONFIDENTIAL  ·  DISCUSSION DRAFT</a:t>
             </a:r>
             <a:endParaRPr lang="en-US" sz="900" dirty="0"/>
           </a:p>
@@ -12894,7 +12936,7 @@
                 <a:ea typeface="DM Sans" pitchFamily="34" charset="-122"/>
                 <a:cs typeface="DM Sans" pitchFamily="34" charset="-120"/>
               </a:rPr>
-              <a:t>Sources:  </a:t>
+              <a:t>Sources (own research; subject to change &amp; confirmation):  </a:t>
             </a:r>
             <a:pPr algn="l" indent="0" marL="0">
               <a:buNone/>
@@ -13115,7 +13157,7 @@
                 <a:ea typeface="Montserrat" pitchFamily="34" charset="-122"/>
                 <a:cs typeface="Montserrat" pitchFamily="34" charset="-120"/>
               </a:rPr>
-              <a:t>QUEENSTOWN HARBOR  |  CONFIDENTIAL</a:t>
+              <a:t>QUEENSTOWN HARBOR  ·  CONFIDENTIAL  ·  DISCUSSION DRAFT</a:t>
             </a:r>
             <a:endParaRPr lang="en-US" sz="900" dirty="0"/>
           </a:p>
@@ -14229,7 +14271,7 @@
                 <a:ea typeface="DM Sans" pitchFamily="34" charset="-122"/>
                 <a:cs typeface="DM Sans" pitchFamily="34" charset="-120"/>
               </a:rPr>
-              <a:t>Sources:  </a:t>
+              <a:t>Sources (own research; subject to change &amp; confirmation):  </a:t>
             </a:r>
             <a:pPr algn="l" indent="0" marL="0">
               <a:buNone/>
@@ -14415,7 +14457,7 @@
                 <a:ea typeface="Montserrat" pitchFamily="34" charset="-122"/>
                 <a:cs typeface="Montserrat" pitchFamily="34" charset="-120"/>
               </a:rPr>
-              <a:t>QUEENSTOWN HARBOR  |  CONFIDENTIAL</a:t>
+              <a:t>QUEENSTOWN HARBOR  ·  CONFIDENTIAL  ·  DISCUSSION DRAFT</a:t>
             </a:r>
             <a:endParaRPr lang="en-US" sz="900" dirty="0"/>
           </a:p>
@@ -15698,7 +15740,7 @@
                 <a:ea typeface="Montserrat" pitchFamily="34" charset="-122"/>
                 <a:cs typeface="Montserrat" pitchFamily="34" charset="-120"/>
               </a:rPr>
-              <a:t>QUEENSTOWN HARBOR  |  CONFIDENTIAL</a:t>
+              <a:t>QUEENSTOWN HARBOR  ·  CONFIDENTIAL  ·  DISCUSSION DRAFT</a:t>
             </a:r>
             <a:endParaRPr lang="en-US" sz="900" dirty="0"/>
           </a:p>
@@ -17666,7 +17708,7 @@
                 <a:ea typeface="DM Sans" pitchFamily="34" charset="-122"/>
                 <a:cs typeface="DM Sans" pitchFamily="34" charset="-120"/>
               </a:rPr>
-              <a:t>Sources:  </a:t>
+              <a:t>Sources (own research; subject to change &amp; confirmation):  </a:t>
             </a:r>
             <a:pPr algn="l" indent="0" marL="0">
               <a:buNone/>
@@ -17887,7 +17929,7 @@
                 <a:ea typeface="Montserrat" pitchFamily="34" charset="-122"/>
                 <a:cs typeface="Montserrat" pitchFamily="34" charset="-120"/>
               </a:rPr>
-              <a:t>QUEENSTOWN HARBOR  |  CONFIDENTIAL</a:t>
+              <a:t>QUEENSTOWN HARBOR  ·  CONFIDENTIAL  ·  DISCUSSION DRAFT</a:t>
             </a:r>
             <a:endParaRPr lang="en-US" sz="900" dirty="0"/>
           </a:p>
@@ -19295,7 +19337,7 @@
                 <a:ea typeface="DM Sans" pitchFamily="34" charset="-122"/>
                 <a:cs typeface="DM Sans" pitchFamily="34" charset="-120"/>
               </a:rPr>
-              <a:t>Sources:  </a:t>
+              <a:t>Sources (own research; subject to change &amp; confirmation):  </a:t>
             </a:r>
             <a:pPr algn="l" indent="0" marL="0">
               <a:buNone/>
@@ -19481,7 +19523,7 @@
                 <a:ea typeface="Montserrat" pitchFamily="34" charset="-122"/>
                 <a:cs typeface="Montserrat" pitchFamily="34" charset="-120"/>
               </a:rPr>
-              <a:t>QUEENSTOWN HARBOR  |  CONFIDENTIAL</a:t>
+              <a:t>QUEENSTOWN HARBOR  ·  CONFIDENTIAL  ·  DISCUSSION DRAFT</a:t>
             </a:r>
             <a:endParaRPr lang="en-US" sz="900" dirty="0"/>
           </a:p>
@@ -20595,7 +20637,7 @@
                 <a:ea typeface="DM Sans" pitchFamily="34" charset="-122"/>
                 <a:cs typeface="DM Sans" pitchFamily="34" charset="-120"/>
               </a:rPr>
-              <a:t>Sources:  </a:t>
+              <a:t>Sources (own research; subject to change &amp; confirmation):  </a:t>
             </a:r>
             <a:pPr algn="l" indent="0" marL="0">
               <a:buNone/>
@@ -20816,7 +20858,7 @@
                 <a:ea typeface="Montserrat" pitchFamily="34" charset="-122"/>
                 <a:cs typeface="Montserrat" pitchFamily="34" charset="-120"/>
               </a:rPr>
-              <a:t>QUEENSTOWN HARBOR  |  CONFIDENTIAL</a:t>
+              <a:t>QUEENSTOWN HARBOR  ·  CONFIDENTIAL  ·  DISCUSSION DRAFT</a:t>
             </a:r>
             <a:endParaRPr lang="en-US" sz="900" dirty="0"/>
           </a:p>

</xml_diff>

<commit_message>
Make slide 6 math internally consistent (entitled-lot basis)
The old number double-counted: it used a finished-lot price ($150K) while
the pitch has the builder funding the horizontal. Reworked to an
entitled-lot basis and shows the full derivation:

  ~140 developable ac x ~2.0 = ~280 entitled lots
  per lot = $150K finished - $60K builder-funded horizontal - $22K margin = ~$68K
  280 x $68K = $19.0M, less ~10% JV soft costs = ~$17M net

Builder funds the horizontal, so only entitlement/soft costs are deducted
(no double count). Updates title, band, notes and the README accuracy note.
</commit_message>
<xml_diff>
--- a/JAL_Queenstown_Harbor_Proposal.pptx
+++ b/JAL_Queenstown_Harbor_Proposal.pptx
@@ -1484,7 +1484,7 @@
           <a:p>
             <a:r>
               <a:rPr lang="en-US" dirty="0"/>
-              <a:t>Now derived, not guessed: 700 gross − 198 conservation − ~300 golf complex − ~60 Critical Area/wetlands ≈ 140 developable acres. Maryland's Chesapeake Bay Critical Area (1,000-ft zone, ~1 unit/20 ac in RCA) is the real constraint on the waterfront land. All figures illustrative until survey / easement review.</a:t>
+              <a:t>Internally consistent entitled-lot basis: the builder funds the horizontal, so the JV sells paper lots. Per lot = $150K finished − $60K horizontal − $22K builder margin ≈ $68K. 280 × $68K = $19.0M, less ~10% soft costs ≈ $17M. (Earlier $29M double-counted a finished price with a low cost load.) Illustrative until survey / entitlement.</a:t>
             </a:r>
             <a:endParaRPr lang="en-US" dirty="0"/>
           </a:p>
@@ -15916,7 +15916,7 @@
                 <a:ea typeface="Montserrat" pitchFamily="34" charset="-122"/>
                 <a:cs typeface="Montserrat" pitchFamily="34" charset="-120"/>
               </a:rPr>
-              <a:t>From 700 acres to the developable envelope.</a:t>
+              <a:t>From 700 acres to ~$17M of entitled-lot value.</a:t>
             </a:r>
             <a:endParaRPr lang="en-US" sz="2500" dirty="0"/>
           </a:p>
@@ -15958,7 +15958,7 @@
                 <a:ea typeface="DM Sans" pitchFamily="34" charset="-122"/>
                 <a:cs typeface="DM Sans" pitchFamily="34" charset="-120"/>
               </a:rPr>
-              <a:t>Built down from real constraints — the recorded conservation easement, the golf footprint, and Maryland's Chesapeake Bay Critical Area. Developable acreage is survey-dependent; figures illustrative.</a:t>
+              <a:t>Capital-light, entitled-lot basis: the JV sells entitled lots and the homebuilder funds the horizontal. Each lot equals the finished-lot price less the builder's horizontal cost and margin. Illustrative — survey-dependent.</a:t>
             </a:r>
             <a:endParaRPr lang="en-US" sz="1300" dirty="0"/>
           </a:p>
@@ -15972,7 +15972,7 @@
         </p:nvSpPr>
         <p:spPr>
           <a:xfrm>
-            <a:off x="457200" y="1938528"/>
+            <a:off x="457200" y="1920240"/>
             <a:ext cx="2926080" cy="365760"/>
           </a:xfrm>
           <a:prstGeom prst="rect">
@@ -15992,7 +15992,7 @@
         </p:nvSpPr>
         <p:spPr>
           <a:xfrm>
-            <a:off x="457200" y="1938528"/>
+            <a:off x="457200" y="1920240"/>
             <a:ext cx="2926080" cy="365760"/>
           </a:xfrm>
           <a:prstGeom prst="rect">
@@ -16031,7 +16031,7 @@
         </p:nvSpPr>
         <p:spPr>
           <a:xfrm>
-            <a:off x="3383280" y="1938528"/>
+            <a:off x="3383280" y="1920240"/>
             <a:ext cx="3108960" cy="365760"/>
           </a:xfrm>
           <a:prstGeom prst="rect">
@@ -16051,7 +16051,7 @@
         </p:nvSpPr>
         <p:spPr>
           <a:xfrm>
-            <a:off x="3383280" y="1938528"/>
+            <a:off x="3383280" y="1920240"/>
             <a:ext cx="3108960" cy="365760"/>
           </a:xfrm>
           <a:prstGeom prst="rect">
@@ -16090,7 +16090,7 @@
         </p:nvSpPr>
         <p:spPr>
           <a:xfrm>
-            <a:off x="6492240" y="1938528"/>
+            <a:off x="6492240" y="1920240"/>
             <a:ext cx="2651760" cy="365760"/>
           </a:xfrm>
           <a:prstGeom prst="rect">
@@ -16110,7 +16110,7 @@
         </p:nvSpPr>
         <p:spPr>
           <a:xfrm>
-            <a:off x="6492240" y="1938528"/>
+            <a:off x="6492240" y="1920240"/>
             <a:ext cx="2651760" cy="365760"/>
           </a:xfrm>
           <a:prstGeom prst="rect">
@@ -16149,7 +16149,7 @@
         </p:nvSpPr>
         <p:spPr>
           <a:xfrm>
-            <a:off x="9144000" y="1938528"/>
+            <a:off x="9144000" y="1920240"/>
             <a:ext cx="2587752" cy="365760"/>
           </a:xfrm>
           <a:prstGeom prst="rect">
@@ -16169,7 +16169,7 @@
         </p:nvSpPr>
         <p:spPr>
           <a:xfrm>
-            <a:off x="9144000" y="1938528"/>
+            <a:off x="9144000" y="1920240"/>
             <a:ext cx="2587752" cy="365760"/>
           </a:xfrm>
           <a:prstGeom prst="rect">
@@ -16208,8 +16208,8 @@
         </p:nvSpPr>
         <p:spPr>
           <a:xfrm>
-            <a:off x="457200" y="2304288"/>
-            <a:ext cx="2926080" cy="502920"/>
+            <a:off x="457200" y="2286000"/>
+            <a:ext cx="2926080" cy="393192"/>
           </a:xfrm>
           <a:prstGeom prst="rect">
             <a:avLst/>
@@ -16228,8 +16228,8 @@
         </p:nvSpPr>
         <p:spPr>
           <a:xfrm>
-            <a:off x="457200" y="2304288"/>
-            <a:ext cx="2926080" cy="502920"/>
+            <a:off x="457200" y="2286000"/>
+            <a:ext cx="2926080" cy="393192"/>
           </a:xfrm>
           <a:prstGeom prst="rect">
             <a:avLst/>
@@ -16253,7 +16253,7 @@
                 <a:ea typeface="Montserrat" pitchFamily="34" charset="-122"/>
                 <a:cs typeface="Montserrat" pitchFamily="34" charset="-120"/>
               </a:rPr>
-              <a:t>Queenstown land (gross)</a:t>
+              <a:t>Gross Queenstown land</a:t>
             </a:r>
             <a:endParaRPr lang="en-US" sz="1000" dirty="0"/>
           </a:p>
@@ -16267,8 +16267,8 @@
         </p:nvSpPr>
         <p:spPr>
           <a:xfrm>
-            <a:off x="3383280" y="2304288"/>
-            <a:ext cx="3108960" cy="502920"/>
+            <a:off x="3383280" y="2286000"/>
+            <a:ext cx="3108960" cy="393192"/>
           </a:xfrm>
           <a:prstGeom prst="rect">
             <a:avLst/>
@@ -16287,8 +16287,8 @@
         </p:nvSpPr>
         <p:spPr>
           <a:xfrm>
-            <a:off x="3383280" y="2304288"/>
-            <a:ext cx="3108960" cy="502920"/>
+            <a:off x="3383280" y="2286000"/>
+            <a:ext cx="3108960" cy="393192"/>
           </a:xfrm>
           <a:prstGeom prst="rect">
             <a:avLst/>
@@ -16312,7 +16312,7 @@
                 <a:ea typeface="DM Sans" pitchFamily="34" charset="-122"/>
                 <a:cs typeface="DM Sans" pitchFamily="34" charset="-120"/>
               </a:rPr>
-              <a:t>per ownership estimate</a:t>
+              <a:t>per ownership (to confirm)</a:t>
             </a:r>
             <a:endParaRPr lang="en-US" sz="950" dirty="0"/>
           </a:p>
@@ -16326,8 +16326,8 @@
         </p:nvSpPr>
         <p:spPr>
           <a:xfrm>
-            <a:off x="6492240" y="2304288"/>
-            <a:ext cx="2651760" cy="502920"/>
+            <a:off x="6492240" y="2286000"/>
+            <a:ext cx="2651760" cy="393192"/>
           </a:xfrm>
           <a:prstGeom prst="rect">
             <a:avLst/>
@@ -16346,8 +16346,8 @@
         </p:nvSpPr>
         <p:spPr>
           <a:xfrm>
-            <a:off x="6492240" y="2304288"/>
-            <a:ext cx="2651760" cy="502920"/>
+            <a:off x="6492240" y="2286000"/>
+            <a:ext cx="2651760" cy="393192"/>
           </a:xfrm>
           <a:prstGeom prst="rect">
             <a:avLst/>
@@ -16385,8 +16385,8 @@
         </p:nvSpPr>
         <p:spPr>
           <a:xfrm>
-            <a:off x="9144000" y="2304288"/>
-            <a:ext cx="2587752" cy="502920"/>
+            <a:off x="9144000" y="2286000"/>
+            <a:ext cx="2587752" cy="393192"/>
           </a:xfrm>
           <a:prstGeom prst="rect">
             <a:avLst/>
@@ -16405,8 +16405,8 @@
         </p:nvSpPr>
         <p:spPr>
           <a:xfrm>
-            <a:off x="9144000" y="2304288"/>
-            <a:ext cx="2587752" cy="502920"/>
+            <a:off x="9144000" y="2286000"/>
+            <a:ext cx="2587752" cy="393192"/>
           </a:xfrm>
           <a:prstGeom prst="rect">
             <a:avLst/>
@@ -16444,8 +16444,8 @@
         </p:nvSpPr>
         <p:spPr>
           <a:xfrm>
-            <a:off x="457200" y="2807208"/>
-            <a:ext cx="2926080" cy="502920"/>
+            <a:off x="457200" y="2679192"/>
+            <a:ext cx="2926080" cy="393192"/>
           </a:xfrm>
           <a:prstGeom prst="rect">
             <a:avLst/>
@@ -16464,8 +16464,8 @@
         </p:nvSpPr>
         <p:spPr>
           <a:xfrm>
-            <a:off x="457200" y="2807208"/>
-            <a:ext cx="2926080" cy="502920"/>
+            <a:off x="457200" y="2679192"/>
+            <a:ext cx="2926080" cy="393192"/>
           </a:xfrm>
           <a:prstGeom prst="rect">
             <a:avLst/>
@@ -16503,8 +16503,8 @@
         </p:nvSpPr>
         <p:spPr>
           <a:xfrm>
-            <a:off x="3383280" y="2807208"/>
-            <a:ext cx="3108960" cy="502920"/>
+            <a:off x="3383280" y="2679192"/>
+            <a:ext cx="3108960" cy="393192"/>
           </a:xfrm>
           <a:prstGeom prst="rect">
             <a:avLst/>
@@ -16523,8 +16523,8 @@
         </p:nvSpPr>
         <p:spPr>
           <a:xfrm>
-            <a:off x="3383280" y="2807208"/>
-            <a:ext cx="3108960" cy="502920"/>
+            <a:off x="3383280" y="2679192"/>
+            <a:ext cx="3108960" cy="393192"/>
           </a:xfrm>
           <a:prstGeom prst="rect">
             <a:avLst/>
@@ -16562,8 +16562,8 @@
         </p:nvSpPr>
         <p:spPr>
           <a:xfrm>
-            <a:off x="6492240" y="2807208"/>
-            <a:ext cx="2651760" cy="502920"/>
+            <a:off x="6492240" y="2679192"/>
+            <a:ext cx="2651760" cy="393192"/>
           </a:xfrm>
           <a:prstGeom prst="rect">
             <a:avLst/>
@@ -16582,8 +16582,8 @@
         </p:nvSpPr>
         <p:spPr>
           <a:xfrm>
-            <a:off x="6492240" y="2807208"/>
-            <a:ext cx="2651760" cy="502920"/>
+            <a:off x="6492240" y="2679192"/>
+            <a:ext cx="2651760" cy="393192"/>
           </a:xfrm>
           <a:prstGeom prst="rect">
             <a:avLst/>
@@ -16621,8 +16621,8 @@
         </p:nvSpPr>
         <p:spPr>
           <a:xfrm>
-            <a:off x="9144000" y="2807208"/>
-            <a:ext cx="2587752" cy="502920"/>
+            <a:off x="9144000" y="2679192"/>
+            <a:ext cx="2587752" cy="393192"/>
           </a:xfrm>
           <a:prstGeom prst="rect">
             <a:avLst/>
@@ -16641,8 +16641,8 @@
         </p:nvSpPr>
         <p:spPr>
           <a:xfrm>
-            <a:off x="9144000" y="2807208"/>
-            <a:ext cx="2587752" cy="502920"/>
+            <a:off x="9144000" y="2679192"/>
+            <a:ext cx="2587752" cy="393192"/>
           </a:xfrm>
           <a:prstGeom prst="rect">
             <a:avLst/>
@@ -16680,8 +16680,8 @@
         </p:nvSpPr>
         <p:spPr>
           <a:xfrm>
-            <a:off x="457200" y="3310128"/>
-            <a:ext cx="2926080" cy="502920"/>
+            <a:off x="457200" y="3072384"/>
+            <a:ext cx="2926080" cy="393192"/>
           </a:xfrm>
           <a:prstGeom prst="rect">
             <a:avLst/>
@@ -16700,8 +16700,8 @@
         </p:nvSpPr>
         <p:spPr>
           <a:xfrm>
-            <a:off x="457200" y="3310128"/>
-            <a:ext cx="2926080" cy="502920"/>
+            <a:off x="457200" y="3072384"/>
+            <a:ext cx="2926080" cy="393192"/>
           </a:xfrm>
           <a:prstGeom prst="rect">
             <a:avLst/>
@@ -16739,8 +16739,8 @@
         </p:nvSpPr>
         <p:spPr>
           <a:xfrm>
-            <a:off x="3383280" y="3310128"/>
-            <a:ext cx="3108960" cy="502920"/>
+            <a:off x="3383280" y="3072384"/>
+            <a:ext cx="3108960" cy="393192"/>
           </a:xfrm>
           <a:prstGeom prst="rect">
             <a:avLst/>
@@ -16759,8 +16759,8 @@
         </p:nvSpPr>
         <p:spPr>
           <a:xfrm>
-            <a:off x="3383280" y="3310128"/>
-            <a:ext cx="3108960" cy="502920"/>
+            <a:off x="3383280" y="3072384"/>
+            <a:ext cx="3108960" cy="393192"/>
           </a:xfrm>
           <a:prstGeom prst="rect">
             <a:avLst/>
@@ -16798,8 +16798,8 @@
         </p:nvSpPr>
         <p:spPr>
           <a:xfrm>
-            <a:off x="6492240" y="3310128"/>
-            <a:ext cx="2651760" cy="502920"/>
+            <a:off x="6492240" y="3072384"/>
+            <a:ext cx="2651760" cy="393192"/>
           </a:xfrm>
           <a:prstGeom prst="rect">
             <a:avLst/>
@@ -16818,8 +16818,8 @@
         </p:nvSpPr>
         <p:spPr>
           <a:xfrm>
-            <a:off x="6492240" y="3310128"/>
-            <a:ext cx="2651760" cy="502920"/>
+            <a:off x="6492240" y="3072384"/>
+            <a:ext cx="2651760" cy="393192"/>
           </a:xfrm>
           <a:prstGeom prst="rect">
             <a:avLst/>
@@ -16857,8 +16857,8 @@
         </p:nvSpPr>
         <p:spPr>
           <a:xfrm>
-            <a:off x="9144000" y="3310128"/>
-            <a:ext cx="2587752" cy="502920"/>
+            <a:off x="9144000" y="3072384"/>
+            <a:ext cx="2587752" cy="393192"/>
           </a:xfrm>
           <a:prstGeom prst="rect">
             <a:avLst/>
@@ -16877,8 +16877,8 @@
         </p:nvSpPr>
         <p:spPr>
           <a:xfrm>
-            <a:off x="9144000" y="3310128"/>
-            <a:ext cx="2587752" cy="502920"/>
+            <a:off x="9144000" y="3072384"/>
+            <a:ext cx="2587752" cy="393192"/>
           </a:xfrm>
           <a:prstGeom prst="rect">
             <a:avLst/>
@@ -16916,8 +16916,8 @@
         </p:nvSpPr>
         <p:spPr>
           <a:xfrm>
-            <a:off x="457200" y="3813048"/>
-            <a:ext cx="2926080" cy="502920"/>
+            <a:off x="457200" y="3465576"/>
+            <a:ext cx="2926080" cy="393192"/>
           </a:xfrm>
           <a:prstGeom prst="rect">
             <a:avLst/>
@@ -16936,8 +16936,8 @@
         </p:nvSpPr>
         <p:spPr>
           <a:xfrm>
-            <a:off x="457200" y="3813048"/>
-            <a:ext cx="2926080" cy="502920"/>
+            <a:off x="457200" y="3465576"/>
+            <a:ext cx="2926080" cy="393192"/>
           </a:xfrm>
           <a:prstGeom prst="rect">
             <a:avLst/>
@@ -16975,8 +16975,8 @@
         </p:nvSpPr>
         <p:spPr>
           <a:xfrm>
-            <a:off x="3383280" y="3813048"/>
-            <a:ext cx="3108960" cy="502920"/>
+            <a:off x="3383280" y="3465576"/>
+            <a:ext cx="3108960" cy="393192"/>
           </a:xfrm>
           <a:prstGeom prst="rect">
             <a:avLst/>
@@ -16995,8 +16995,8 @@
         </p:nvSpPr>
         <p:spPr>
           <a:xfrm>
-            <a:off x="3383280" y="3813048"/>
-            <a:ext cx="3108960" cy="502920"/>
+            <a:off x="3383280" y="3465576"/>
+            <a:ext cx="3108960" cy="393192"/>
           </a:xfrm>
           <a:prstGeom prst="rect">
             <a:avLst/>
@@ -17034,8 +17034,8 @@
         </p:nvSpPr>
         <p:spPr>
           <a:xfrm>
-            <a:off x="6492240" y="3813048"/>
-            <a:ext cx="2651760" cy="502920"/>
+            <a:off x="6492240" y="3465576"/>
+            <a:ext cx="2651760" cy="393192"/>
           </a:xfrm>
           <a:prstGeom prst="rect">
             <a:avLst/>
@@ -17054,8 +17054,8 @@
         </p:nvSpPr>
         <p:spPr>
           <a:xfrm>
-            <a:off x="6492240" y="3813048"/>
-            <a:ext cx="2651760" cy="502920"/>
+            <a:off x="6492240" y="3465576"/>
+            <a:ext cx="2651760" cy="393192"/>
           </a:xfrm>
           <a:prstGeom prst="rect">
             <a:avLst/>
@@ -17093,8 +17093,8 @@
         </p:nvSpPr>
         <p:spPr>
           <a:xfrm>
-            <a:off x="9144000" y="3813048"/>
-            <a:ext cx="2587752" cy="502920"/>
+            <a:off x="9144000" y="3465576"/>
+            <a:ext cx="2587752" cy="393192"/>
           </a:xfrm>
           <a:prstGeom prst="rect">
             <a:avLst/>
@@ -17113,8 +17113,8 @@
         </p:nvSpPr>
         <p:spPr>
           <a:xfrm>
-            <a:off x="9144000" y="3813048"/>
-            <a:ext cx="2587752" cy="502920"/>
+            <a:off x="9144000" y="3465576"/>
+            <a:ext cx="2587752" cy="393192"/>
           </a:xfrm>
           <a:prstGeom prst="rect">
             <a:avLst/>
@@ -17152,8 +17152,8 @@
         </p:nvSpPr>
         <p:spPr>
           <a:xfrm>
-            <a:off x="457200" y="4315968"/>
-            <a:ext cx="2926080" cy="502920"/>
+            <a:off x="457200" y="3858768"/>
+            <a:ext cx="2926080" cy="393192"/>
           </a:xfrm>
           <a:prstGeom prst="rect">
             <a:avLst/>
@@ -17172,8 +17172,8 @@
         </p:nvSpPr>
         <p:spPr>
           <a:xfrm>
-            <a:off x="457200" y="4315968"/>
-            <a:ext cx="2926080" cy="502920"/>
+            <a:off x="457200" y="3858768"/>
+            <a:ext cx="2926080" cy="393192"/>
           </a:xfrm>
           <a:prstGeom prst="rect">
             <a:avLst/>
@@ -17197,7 +17197,7 @@
                 <a:ea typeface="Montserrat" pitchFamily="34" charset="-122"/>
                 <a:cs typeface="Montserrat" pitchFamily="34" charset="-120"/>
               </a:rPr>
-              <a:t>Net developable → lots</a:t>
+              <a:t>Entitled lots</a:t>
             </a:r>
             <a:endParaRPr lang="en-US" sz="1000" dirty="0"/>
           </a:p>
@@ -17211,8 +17211,8 @@
         </p:nvSpPr>
         <p:spPr>
           <a:xfrm>
-            <a:off x="3383280" y="4315968"/>
-            <a:ext cx="3108960" cy="502920"/>
+            <a:off x="3383280" y="3858768"/>
+            <a:ext cx="3108960" cy="393192"/>
           </a:xfrm>
           <a:prstGeom prst="rect">
             <a:avLst/>
@@ -17231,8 +17231,8 @@
         </p:nvSpPr>
         <p:spPr>
           <a:xfrm>
-            <a:off x="3383280" y="4315968"/>
-            <a:ext cx="3108960" cy="502920"/>
+            <a:off x="3383280" y="3858768"/>
+            <a:ext cx="3108960" cy="393192"/>
           </a:xfrm>
           <a:prstGeom prst="rect">
             <a:avLst/>
@@ -17270,8 +17270,8 @@
         </p:nvSpPr>
         <p:spPr>
           <a:xfrm>
-            <a:off x="6492240" y="4315968"/>
-            <a:ext cx="2651760" cy="502920"/>
+            <a:off x="6492240" y="3858768"/>
+            <a:ext cx="2651760" cy="393192"/>
           </a:xfrm>
           <a:prstGeom prst="rect">
             <a:avLst/>
@@ -17290,8 +17290,8 @@
         </p:nvSpPr>
         <p:spPr>
           <a:xfrm>
-            <a:off x="6492240" y="4315968"/>
-            <a:ext cx="2651760" cy="502920"/>
+            <a:off x="6492240" y="3858768"/>
+            <a:ext cx="2651760" cy="393192"/>
           </a:xfrm>
           <a:prstGeom prst="rect">
             <a:avLst/>
@@ -17329,8 +17329,8 @@
         </p:nvSpPr>
         <p:spPr>
           <a:xfrm>
-            <a:off x="9144000" y="4315968"/>
-            <a:ext cx="2587752" cy="502920"/>
+            <a:off x="9144000" y="3858768"/>
+            <a:ext cx="2587752" cy="393192"/>
           </a:xfrm>
           <a:prstGeom prst="rect">
             <a:avLst/>
@@ -17349,8 +17349,8 @@
         </p:nvSpPr>
         <p:spPr>
           <a:xfrm>
-            <a:off x="9144000" y="4315968"/>
-            <a:ext cx="2587752" cy="502920"/>
+            <a:off x="9144000" y="3858768"/>
+            <a:ext cx="2587752" cy="393192"/>
           </a:xfrm>
           <a:prstGeom prst="rect">
             <a:avLst/>
@@ -17388,8 +17388,8 @@
         </p:nvSpPr>
         <p:spPr>
           <a:xfrm>
-            <a:off x="457200" y="4818888"/>
-            <a:ext cx="2926080" cy="502920"/>
+            <a:off x="457200" y="4251960"/>
+            <a:ext cx="2926080" cy="393192"/>
           </a:xfrm>
           <a:prstGeom prst="rect">
             <a:avLst/>
@@ -17408,8 +17408,8 @@
         </p:nvSpPr>
         <p:spPr>
           <a:xfrm>
-            <a:off x="457200" y="4818888"/>
-            <a:ext cx="2926080" cy="502920"/>
+            <a:off x="457200" y="4251960"/>
+            <a:ext cx="2926080" cy="393192"/>
           </a:xfrm>
           <a:prstGeom prst="rect">
             <a:avLst/>
@@ -17433,7 +17433,7 @@
                 <a:ea typeface="Montserrat" pitchFamily="34" charset="-122"/>
                 <a:cs typeface="Montserrat" pitchFamily="34" charset="-120"/>
               </a:rPr>
-              <a:t>FINISHED LOT VALUE (net, illustrative)</a:t>
+              <a:t>Value per entitled lot</a:t>
             </a:r>
             <a:endParaRPr lang="en-US" sz="1000" dirty="0"/>
           </a:p>
@@ -17447,8 +17447,8 @@
         </p:nvSpPr>
         <p:spPr>
           <a:xfrm>
-            <a:off x="3383280" y="4818888"/>
-            <a:ext cx="3108960" cy="502920"/>
+            <a:off x="3383280" y="4251960"/>
+            <a:ext cx="3108960" cy="393192"/>
           </a:xfrm>
           <a:prstGeom prst="rect">
             <a:avLst/>
@@ -17467,8 +17467,8 @@
         </p:nvSpPr>
         <p:spPr>
           <a:xfrm>
-            <a:off x="3383280" y="4818888"/>
-            <a:ext cx="3108960" cy="502920"/>
+            <a:off x="3383280" y="4251960"/>
+            <a:ext cx="3108960" cy="393192"/>
           </a:xfrm>
           <a:prstGeom prst="rect">
             <a:avLst/>
@@ -17486,13 +17486,13 @@
             <a:r>
               <a:rPr lang="en-US" sz="950" dirty="0">
                 <a:solidFill>
-                  <a:srgbClr val="6B5A6B"/>
+                  <a:srgbClr val="0B163C"/>
                 </a:solidFill>
                 <a:latin typeface="DM Sans" pitchFamily="34" charset="0"/>
                 <a:ea typeface="DM Sans" pitchFamily="34" charset="-122"/>
                 <a:cs typeface="DM Sans" pitchFamily="34" charset="-120"/>
               </a:rPr>
-              <a:t>$150K / lot, less ~30% costs</a:t>
+              <a:t>builder funds the horizontal</a:t>
             </a:r>
             <a:endParaRPr lang="en-US" sz="950" dirty="0"/>
           </a:p>
@@ -17506,8 +17506,8 @@
         </p:nvSpPr>
         <p:spPr>
           <a:xfrm>
-            <a:off x="6492240" y="4818888"/>
-            <a:ext cx="2651760" cy="502920"/>
+            <a:off x="6492240" y="4251960"/>
+            <a:ext cx="2651760" cy="393192"/>
           </a:xfrm>
           <a:prstGeom prst="rect">
             <a:avLst/>
@@ -17526,8 +17526,8 @@
         </p:nvSpPr>
         <p:spPr>
           <a:xfrm>
-            <a:off x="6492240" y="4818888"/>
-            <a:ext cx="2651760" cy="502920"/>
+            <a:off x="6492240" y="4251960"/>
+            <a:ext cx="2651760" cy="393192"/>
           </a:xfrm>
           <a:prstGeom prst="rect">
             <a:avLst/>
@@ -17551,7 +17551,7 @@
                 <a:ea typeface="DM Sans" pitchFamily="34" charset="-122"/>
                 <a:cs typeface="DM Sans" pitchFamily="34" charset="-120"/>
               </a:rPr>
-              <a:t>280 × $150K × 0.70</a:t>
+              <a:t>$150K − $60K − $22K</a:t>
             </a:r>
             <a:endParaRPr lang="en-US" sz="900" dirty="0"/>
           </a:p>
@@ -17565,8 +17565,8 @@
         </p:nvSpPr>
         <p:spPr>
           <a:xfrm>
-            <a:off x="9144000" y="4818888"/>
-            <a:ext cx="2587752" cy="502920"/>
+            <a:off x="9144000" y="4251960"/>
+            <a:ext cx="2587752" cy="393192"/>
           </a:xfrm>
           <a:prstGeom prst="rect">
             <a:avLst/>
@@ -17585,8 +17585,8 @@
         </p:nvSpPr>
         <p:spPr>
           <a:xfrm>
-            <a:off x="9144000" y="4818888"/>
-            <a:ext cx="2587752" cy="502920"/>
+            <a:off x="9144000" y="4251960"/>
+            <a:ext cx="2587752" cy="393192"/>
           </a:xfrm>
           <a:prstGeom prst="rect">
             <a:avLst/>
@@ -17610,7 +17610,7 @@
                 <a:ea typeface="Montserrat" pitchFamily="34" charset="-122"/>
                 <a:cs typeface="Montserrat" pitchFamily="34" charset="-120"/>
               </a:rPr>
-              <a:t>≈ $29M</a:t>
+              <a:t>~$68K</a:t>
             </a:r>
             <a:endParaRPr lang="en-US" sz="1100" dirty="0"/>
           </a:p>
@@ -17624,8 +17624,480 @@
         </p:nvSpPr>
         <p:spPr>
           <a:xfrm>
-            <a:off x="457200" y="5394960"/>
-            <a:ext cx="11274552" cy="457200"/>
+            <a:off x="457200" y="4645152"/>
+            <a:ext cx="2926080" cy="393192"/>
+          </a:xfrm>
+          <a:prstGeom prst="rect">
+            <a:avLst/>
+          </a:prstGeom>
+          <a:solidFill>
+            <a:srgbClr val="FFFFFF"/>
+          </a:solidFill>
+          <a:ln/>
+        </p:spPr>
+      </p:sp>
+      <p:sp>
+        <p:nvSpPr>
+          <p:cNvPr id="68" name="Text 66"/>
+          <p:cNvSpPr/>
+          <p:nvPr/>
+        </p:nvSpPr>
+        <p:spPr>
+          <a:xfrm>
+            <a:off x="457200" y="4645152"/>
+            <a:ext cx="2926080" cy="393192"/>
+          </a:xfrm>
+          <a:prstGeom prst="rect">
+            <a:avLst/>
+          </a:prstGeom>
+          <a:noFill/>
+          <a:ln/>
+        </p:spPr>
+        <p:txBody>
+          <a:bodyPr wrap="square" lIns="25400" tIns="76200" rIns="76200" bIns="25400" rtlCol="0" anchor="ctr"/>
+          <a:lstStyle/>
+          <a:p>
+            <a:pPr algn="l" indent="0" marL="0">
+              <a:buNone/>
+            </a:pPr>
+            <a:r>
+              <a:rPr lang="en-US" sz="1000" b="1" dirty="0">
+                <a:solidFill>
+                  <a:srgbClr val="0B163C"/>
+                </a:solidFill>
+                <a:latin typeface="Montserrat" pitchFamily="34" charset="0"/>
+                <a:ea typeface="Montserrat" pitchFamily="34" charset="-122"/>
+                <a:cs typeface="Montserrat" pitchFamily="34" charset="-120"/>
+              </a:rPr>
+              <a:t>Gross land proceeds</a:t>
+            </a:r>
+            <a:endParaRPr lang="en-US" sz="1000" dirty="0"/>
+          </a:p>
+        </p:txBody>
+      </p:sp>
+      <p:sp>
+        <p:nvSpPr>
+          <p:cNvPr id="69" name="Shape 67"/>
+          <p:cNvSpPr/>
+          <p:nvPr/>
+        </p:nvSpPr>
+        <p:spPr>
+          <a:xfrm>
+            <a:off x="3383280" y="4645152"/>
+            <a:ext cx="3108960" cy="393192"/>
+          </a:xfrm>
+          <a:prstGeom prst="rect">
+            <a:avLst/>
+          </a:prstGeom>
+          <a:solidFill>
+            <a:srgbClr val="FFFFFF"/>
+          </a:solidFill>
+          <a:ln/>
+        </p:spPr>
+      </p:sp>
+      <p:sp>
+        <p:nvSpPr>
+          <p:cNvPr id="70" name="Text 68"/>
+          <p:cNvSpPr/>
+          <p:nvPr/>
+        </p:nvSpPr>
+        <p:spPr>
+          <a:xfrm>
+            <a:off x="3383280" y="4645152"/>
+            <a:ext cx="3108960" cy="393192"/>
+          </a:xfrm>
+          <a:prstGeom prst="rect">
+            <a:avLst/>
+          </a:prstGeom>
+          <a:noFill/>
+          <a:ln/>
+        </p:spPr>
+        <p:txBody>
+          <a:bodyPr wrap="square" lIns="25400" tIns="76200" rIns="76200" bIns="25400" rtlCol="0" anchor="ctr"/>
+          <a:lstStyle/>
+          <a:p>
+            <a:pPr algn="l" indent="0" marL="0">
+              <a:buNone/>
+            </a:pPr>
+            <a:r>
+              <a:rPr lang="en-US" sz="950" dirty="0">
+                <a:solidFill>
+                  <a:srgbClr val="0B163C"/>
+                </a:solidFill>
+                <a:latin typeface="DM Sans" pitchFamily="34" charset="0"/>
+                <a:ea typeface="DM Sans" pitchFamily="34" charset="-122"/>
+                <a:cs typeface="DM Sans" pitchFamily="34" charset="-120"/>
+              </a:rPr>
+              <a:t>paid by the homebuilder</a:t>
+            </a:r>
+            <a:endParaRPr lang="en-US" sz="950" dirty="0"/>
+          </a:p>
+        </p:txBody>
+      </p:sp>
+      <p:sp>
+        <p:nvSpPr>
+          <p:cNvPr id="71" name="Shape 69"/>
+          <p:cNvSpPr/>
+          <p:nvPr/>
+        </p:nvSpPr>
+        <p:spPr>
+          <a:xfrm>
+            <a:off x="6492240" y="4645152"/>
+            <a:ext cx="2651760" cy="393192"/>
+          </a:xfrm>
+          <a:prstGeom prst="rect">
+            <a:avLst/>
+          </a:prstGeom>
+          <a:solidFill>
+            <a:srgbClr val="FFFFFF"/>
+          </a:solidFill>
+          <a:ln/>
+        </p:spPr>
+      </p:sp>
+      <p:sp>
+        <p:nvSpPr>
+          <p:cNvPr id="72" name="Text 70"/>
+          <p:cNvSpPr/>
+          <p:nvPr/>
+        </p:nvSpPr>
+        <p:spPr>
+          <a:xfrm>
+            <a:off x="6492240" y="4645152"/>
+            <a:ext cx="2651760" cy="393192"/>
+          </a:xfrm>
+          <a:prstGeom prst="rect">
+            <a:avLst/>
+          </a:prstGeom>
+          <a:noFill/>
+          <a:ln/>
+        </p:spPr>
+        <p:txBody>
+          <a:bodyPr wrap="square" lIns="25400" tIns="76200" rIns="76200" bIns="25400" rtlCol="0" anchor="ctr"/>
+          <a:lstStyle/>
+          <a:p>
+            <a:pPr algn="l" indent="0" marL="0">
+              <a:buNone/>
+            </a:pPr>
+            <a:r>
+              <a:rPr lang="en-US" sz="900" dirty="0">
+                <a:solidFill>
+                  <a:srgbClr val="6B5A6B"/>
+                </a:solidFill>
+                <a:latin typeface="DM Sans" pitchFamily="34" charset="0"/>
+                <a:ea typeface="DM Sans" pitchFamily="34" charset="-122"/>
+                <a:cs typeface="DM Sans" pitchFamily="34" charset="-120"/>
+              </a:rPr>
+              <a:t>280 × $68K</a:t>
+            </a:r>
+            <a:endParaRPr lang="en-US" sz="900" dirty="0"/>
+          </a:p>
+        </p:txBody>
+      </p:sp>
+      <p:sp>
+        <p:nvSpPr>
+          <p:cNvPr id="73" name="Shape 71"/>
+          <p:cNvSpPr/>
+          <p:nvPr/>
+        </p:nvSpPr>
+        <p:spPr>
+          <a:xfrm>
+            <a:off x="9144000" y="4645152"/>
+            <a:ext cx="2587752" cy="393192"/>
+          </a:xfrm>
+          <a:prstGeom prst="rect">
+            <a:avLst/>
+          </a:prstGeom>
+          <a:solidFill>
+            <a:srgbClr val="FFFFFF"/>
+          </a:solidFill>
+          <a:ln/>
+        </p:spPr>
+      </p:sp>
+      <p:sp>
+        <p:nvSpPr>
+          <p:cNvPr id="74" name="Text 72"/>
+          <p:cNvSpPr/>
+          <p:nvPr/>
+        </p:nvSpPr>
+        <p:spPr>
+          <a:xfrm>
+            <a:off x="9144000" y="4645152"/>
+            <a:ext cx="2587752" cy="393192"/>
+          </a:xfrm>
+          <a:prstGeom prst="rect">
+            <a:avLst/>
+          </a:prstGeom>
+          <a:noFill/>
+          <a:ln/>
+        </p:spPr>
+        <p:txBody>
+          <a:bodyPr wrap="square" lIns="25400" tIns="76200" rIns="76200" bIns="25400" rtlCol="0" anchor="ctr"/>
+          <a:lstStyle/>
+          <a:p>
+            <a:pPr algn="r" indent="0" marL="0">
+              <a:buNone/>
+            </a:pPr>
+            <a:r>
+              <a:rPr lang="en-US" sz="1100" b="1" dirty="0">
+                <a:solidFill>
+                  <a:srgbClr val="3A243A"/>
+                </a:solidFill>
+                <a:latin typeface="Montserrat" pitchFamily="34" charset="0"/>
+                <a:ea typeface="Montserrat" pitchFamily="34" charset="-122"/>
+                <a:cs typeface="Montserrat" pitchFamily="34" charset="-120"/>
+              </a:rPr>
+              <a:t>$19.0M</a:t>
+            </a:r>
+            <a:endParaRPr lang="en-US" sz="1100" dirty="0"/>
+          </a:p>
+        </p:txBody>
+      </p:sp>
+      <p:sp>
+        <p:nvSpPr>
+          <p:cNvPr id="75" name="Shape 73"/>
+          <p:cNvSpPr/>
+          <p:nvPr/>
+        </p:nvSpPr>
+        <p:spPr>
+          <a:xfrm>
+            <a:off x="457200" y="5038344"/>
+            <a:ext cx="2926080" cy="393192"/>
+          </a:xfrm>
+          <a:prstGeom prst="rect">
+            <a:avLst/>
+          </a:prstGeom>
+          <a:solidFill>
+            <a:srgbClr val="F4F2ED"/>
+          </a:solidFill>
+          <a:ln/>
+        </p:spPr>
+      </p:sp>
+      <p:sp>
+        <p:nvSpPr>
+          <p:cNvPr id="76" name="Text 74"/>
+          <p:cNvSpPr/>
+          <p:nvPr/>
+        </p:nvSpPr>
+        <p:spPr>
+          <a:xfrm>
+            <a:off x="457200" y="5038344"/>
+            <a:ext cx="2926080" cy="393192"/>
+          </a:xfrm>
+          <a:prstGeom prst="rect">
+            <a:avLst/>
+          </a:prstGeom>
+          <a:noFill/>
+          <a:ln/>
+        </p:spPr>
+        <p:txBody>
+          <a:bodyPr wrap="square" lIns="25400" tIns="76200" rIns="76200" bIns="25400" rtlCol="0" anchor="ctr"/>
+          <a:lstStyle/>
+          <a:p>
+            <a:pPr algn="l" indent="0" marL="0">
+              <a:buNone/>
+            </a:pPr>
+            <a:r>
+              <a:rPr lang="en-US" sz="1000" b="1" dirty="0">
+                <a:solidFill>
+                  <a:srgbClr val="0B163C"/>
+                </a:solidFill>
+                <a:latin typeface="Montserrat" pitchFamily="34" charset="0"/>
+                <a:ea typeface="Montserrat" pitchFamily="34" charset="-122"/>
+                <a:cs typeface="Montserrat" pitchFamily="34" charset="-120"/>
+              </a:rPr>
+              <a:t>Less JV soft costs (~10%)</a:t>
+            </a:r>
+            <a:endParaRPr lang="en-US" sz="1000" dirty="0"/>
+          </a:p>
+        </p:txBody>
+      </p:sp>
+      <p:sp>
+        <p:nvSpPr>
+          <p:cNvPr id="77" name="Shape 75"/>
+          <p:cNvSpPr/>
+          <p:nvPr/>
+        </p:nvSpPr>
+        <p:spPr>
+          <a:xfrm>
+            <a:off x="3383280" y="5038344"/>
+            <a:ext cx="3108960" cy="393192"/>
+          </a:xfrm>
+          <a:prstGeom prst="rect">
+            <a:avLst/>
+          </a:prstGeom>
+          <a:solidFill>
+            <a:srgbClr val="F4F2ED"/>
+          </a:solidFill>
+          <a:ln/>
+        </p:spPr>
+      </p:sp>
+      <p:sp>
+        <p:nvSpPr>
+          <p:cNvPr id="78" name="Text 76"/>
+          <p:cNvSpPr/>
+          <p:nvPr/>
+        </p:nvSpPr>
+        <p:spPr>
+          <a:xfrm>
+            <a:off x="3383280" y="5038344"/>
+            <a:ext cx="3108960" cy="393192"/>
+          </a:xfrm>
+          <a:prstGeom prst="rect">
+            <a:avLst/>
+          </a:prstGeom>
+          <a:noFill/>
+          <a:ln/>
+        </p:spPr>
+        <p:txBody>
+          <a:bodyPr wrap="square" lIns="25400" tIns="76200" rIns="76200" bIns="25400" rtlCol="0" anchor="ctr"/>
+          <a:lstStyle/>
+          <a:p>
+            <a:pPr algn="l" indent="0" marL="0">
+              <a:buNone/>
+            </a:pPr>
+            <a:r>
+              <a:rPr lang="en-US" sz="950" dirty="0">
+                <a:solidFill>
+                  <a:srgbClr val="6B5A6B"/>
+                </a:solidFill>
+                <a:latin typeface="DM Sans" pitchFamily="34" charset="0"/>
+                <a:ea typeface="DM Sans" pitchFamily="34" charset="-122"/>
+                <a:cs typeface="DM Sans" pitchFamily="34" charset="-120"/>
+              </a:rPr>
+              <a:t>entitlement · legal · broker</a:t>
+            </a:r>
+            <a:endParaRPr lang="en-US" sz="950" dirty="0"/>
+          </a:p>
+        </p:txBody>
+      </p:sp>
+      <p:sp>
+        <p:nvSpPr>
+          <p:cNvPr id="79" name="Shape 77"/>
+          <p:cNvSpPr/>
+          <p:nvPr/>
+        </p:nvSpPr>
+        <p:spPr>
+          <a:xfrm>
+            <a:off x="6492240" y="5038344"/>
+            <a:ext cx="2651760" cy="393192"/>
+          </a:xfrm>
+          <a:prstGeom prst="rect">
+            <a:avLst/>
+          </a:prstGeom>
+          <a:solidFill>
+            <a:srgbClr val="F4F2ED"/>
+          </a:solidFill>
+          <a:ln/>
+        </p:spPr>
+      </p:sp>
+      <p:sp>
+        <p:nvSpPr>
+          <p:cNvPr id="80" name="Text 78"/>
+          <p:cNvSpPr/>
+          <p:nvPr/>
+        </p:nvSpPr>
+        <p:spPr>
+          <a:xfrm>
+            <a:off x="6492240" y="5038344"/>
+            <a:ext cx="2651760" cy="393192"/>
+          </a:xfrm>
+          <a:prstGeom prst="rect">
+            <a:avLst/>
+          </a:prstGeom>
+          <a:noFill/>
+          <a:ln/>
+        </p:spPr>
+        <p:txBody>
+          <a:bodyPr wrap="square" lIns="25400" tIns="76200" rIns="76200" bIns="25400" rtlCol="0" anchor="ctr"/>
+          <a:lstStyle/>
+          <a:p>
+            <a:pPr algn="l" indent="0" marL="0">
+              <a:buNone/>
+            </a:pPr>
+            <a:r>
+              <a:rPr lang="en-US" sz="900" dirty="0">
+                <a:solidFill>
+                  <a:srgbClr val="6B5A6B"/>
+                </a:solidFill>
+                <a:latin typeface="DM Sans" pitchFamily="34" charset="0"/>
+                <a:ea typeface="DM Sans" pitchFamily="34" charset="-122"/>
+                <a:cs typeface="DM Sans" pitchFamily="34" charset="-120"/>
+              </a:rPr>
+              <a:t>× 0.90</a:t>
+            </a:r>
+            <a:endParaRPr lang="en-US" sz="900" dirty="0"/>
+          </a:p>
+        </p:txBody>
+      </p:sp>
+      <p:sp>
+        <p:nvSpPr>
+          <p:cNvPr id="81" name="Shape 79"/>
+          <p:cNvSpPr/>
+          <p:nvPr/>
+        </p:nvSpPr>
+        <p:spPr>
+          <a:xfrm>
+            <a:off x="9144000" y="5038344"/>
+            <a:ext cx="2587752" cy="393192"/>
+          </a:xfrm>
+          <a:prstGeom prst="rect">
+            <a:avLst/>
+          </a:prstGeom>
+          <a:solidFill>
+            <a:srgbClr val="F4F2ED"/>
+          </a:solidFill>
+          <a:ln/>
+        </p:spPr>
+      </p:sp>
+      <p:sp>
+        <p:nvSpPr>
+          <p:cNvPr id="82" name="Text 80"/>
+          <p:cNvSpPr/>
+          <p:nvPr/>
+        </p:nvSpPr>
+        <p:spPr>
+          <a:xfrm>
+            <a:off x="9144000" y="5038344"/>
+            <a:ext cx="2587752" cy="393192"/>
+          </a:xfrm>
+          <a:prstGeom prst="rect">
+            <a:avLst/>
+          </a:prstGeom>
+          <a:noFill/>
+          <a:ln/>
+        </p:spPr>
+        <p:txBody>
+          <a:bodyPr wrap="square" lIns="25400" tIns="76200" rIns="76200" bIns="25400" rtlCol="0" anchor="ctr"/>
+          <a:lstStyle/>
+          <a:p>
+            <a:pPr algn="r" indent="0" marL="0">
+              <a:buNone/>
+            </a:pPr>
+            <a:r>
+              <a:rPr lang="en-US" sz="1100" b="1" dirty="0">
+                <a:solidFill>
+                  <a:srgbClr val="3A243A"/>
+                </a:solidFill>
+                <a:latin typeface="Montserrat" pitchFamily="34" charset="0"/>
+                <a:ea typeface="Montserrat" pitchFamily="34" charset="-122"/>
+                <a:cs typeface="Montserrat" pitchFamily="34" charset="-120"/>
+              </a:rPr>
+              <a:t>≈ $17M</a:t>
+            </a:r>
+            <a:endParaRPr lang="en-US" sz="1100" dirty="0"/>
+          </a:p>
+        </p:txBody>
+      </p:sp>
+      <p:sp>
+        <p:nvSpPr>
+          <p:cNvPr id="83" name="Shape 81"/>
+          <p:cNvSpPr/>
+          <p:nvPr/>
+        </p:nvSpPr>
+        <p:spPr>
+          <a:xfrm>
+            <a:off x="457200" y="5486400"/>
+            <a:ext cx="11274552" cy="411480"/>
           </a:xfrm>
           <a:prstGeom prst="rect">
             <a:avLst/>
@@ -17638,14 +18110,14 @@
       </p:sp>
       <p:sp>
         <p:nvSpPr>
-          <p:cNvPr id="68" name="Text 66"/>
-          <p:cNvSpPr/>
-          <p:nvPr/>
-        </p:nvSpPr>
-        <p:spPr>
-          <a:xfrm>
-            <a:off x="640080" y="5394960"/>
-            <a:ext cx="10908792" cy="457200"/>
+          <p:cNvPr id="84" name="Text 82"/>
+          <p:cNvSpPr/>
+          <p:nvPr/>
+        </p:nvSpPr>
+        <p:spPr>
+          <a:xfrm>
+            <a:off x="640080" y="5486400"/>
+            <a:ext cx="10908792" cy="411480"/>
           </a:xfrm>
           <a:prstGeom prst="rect">
             <a:avLst/>
@@ -17661,7 +18133,7 @@
               <a:buNone/>
             </a:pPr>
             <a:r>
-              <a:rPr lang="en-US" sz="1200" b="1" dirty="0">
+              <a:rPr lang="en-US" sz="1150" b="1" dirty="0">
                 <a:solidFill>
                   <a:srgbClr val="FFFFFF"/>
                 </a:solidFill>
@@ -17669,15 +18141,15 @@
                 <a:ea typeface="Montserrat" pitchFamily="34" charset="-122"/>
                 <a:cs typeface="Montserrat" pitchFamily="34" charset="-120"/>
               </a:rPr>
-              <a:t>≈ $29M illustrative net from ~140 developable acres — net of conservation &amp; Critical Area, additive to the resort.</a:t>
-            </a:r>
-            <a:endParaRPr lang="en-US" sz="1200" dirty="0"/>
-          </a:p>
-        </p:txBody>
-      </p:sp>
-      <p:sp>
-        <p:nvSpPr>
-          <p:cNvPr id="69" name="Text 67"/>
+              <a:t>≈ $17M net to the JV — capital-light: the homebuilder funds the horizontal, so only entitlement &amp; soft costs come out.</a:t>
+            </a:r>
+            <a:endParaRPr lang="en-US" sz="1150" dirty="0"/>
+          </a:p>
+        </p:txBody>
+      </p:sp>
+      <p:sp>
+        <p:nvSpPr>
+          <p:cNvPr id="85" name="Text 83"/>
           <p:cNvSpPr/>
           <p:nvPr/>
         </p:nvSpPr>

</xml_diff>

<commit_message>
Switch to finished-lot model (JV funds horizontal) + add backup Excel model
Per direction, the JV now funds the horizontal (roads, sewer, utilities)
and sells FINISHED lots; homebuilders just build the homes (capturing the
builder's development margin).

Deck (slides 2,4,5,6,9,10,11): reframed from capital-light/builder-funded
to finished-lot development. New economics: 280 finished lots x $150K =
$42.0M revenue; $27.5M cost (incl. $16.8M JV-funded horizontal); ~$14.5M
profit; ~2.3x equity / ~24% project IRR; ~60% LTC development loan.

model.js: backup financial model -> JAL_Queenstown_Harbor_Model.xlsx with
live formulas (every output references the INPUTS block) so it shows how
each number is derived; project IRR ~24%. Adds npm run model / all.
</commit_message>
<xml_diff>
--- a/JAL_Queenstown_Harbor_Proposal.pptx
+++ b/JAL_Queenstown_Harbor_Proposal.pptx
@@ -607,7 +607,7 @@
           <a:p>
             <a:r>
               <a:rPr lang="en-US" dirty="0"/>
-              <a:t>Capital-light merchant land pro forma, consistent with slide 6. $19.0M lot revenue − $6.5M cost ($4.0M contributed land + ~$2.5M soft) ≈ $12.5M profit. On ~$6.0M equity ≈ 3.0x / ~32% IRR (phased Yr 2–4); LP ~24% after an 8% pref + JAL co-GP promote. Land basis and lot price are the big swing factors. All illustrative.</a:t>
+              <a:t>Finished-lot development pro forma, consistent with slide 6. $42.0M revenue − $27.5M cost ≈ $14.5M profit. Funded ~60% by a development loan; equity ~$11M (land $4M + cash $7M) → ~2.3x / ~24% project IRR (phased); LP ~20% after an 8% pref + JAL co-GP promote. We capture the builder's margin but take horizontal risk. All illustrative.</a:t>
             </a:r>
             <a:endParaRPr lang="en-US" dirty="0"/>
           </a:p>
@@ -695,7 +695,7 @@
           <a:p>
             <a:r>
               <a:rPr lang="en-US" dirty="0"/>
-              <a:t>Backs the pro forma. Market inputs are sourced: QAC home/lot prices (Land.com, Zillow) support a conservative $150K finished lot; $60K/lot horizontal matches national land-dev benchmarks (HomeGuide). Deal-specific inputs — gross acreage, the developable balance, land basis and density — are flagged 'to confirm' pending survey / easement / zoning.</a:t>
+              <a:t>Backs the pro forma. Market inputs are sourced: QAC home/lot prices (Land.com, Zillow) support a conservative $150K finished lot; the $60K/lot horizontal (now JV-funded) matches national land-dev benchmarks (HomeGuide). Deal-specific inputs — gross acreage, the developable balance, land basis and density — are flagged 'to confirm' pending survey / easement / zoning.</a:t>
             </a:r>
             <a:endParaRPr lang="en-US" dirty="0"/>
           </a:p>
@@ -1399,7 +1399,7 @@
           <a:p>
             <a:r>
               <a:rPr lang="en-US" dirty="0"/>
-              <a:t>Anchor on the fresh acquisition (H6 — Bob's fund). The land bank is additive to the hospitality: monetize the developable acreage the golf doesn't need, capital-light.</a:t>
+              <a:t>Anchor on the fresh acquisition (H6 — Bob's fund). The land bank is additive to the hospitality: monetize the developable acreage the golf doesn't need — develop and sell finished lots.</a:t>
             </a:r>
             <a:endParaRPr lang="en-US" dirty="0"/>
           </a:p>
@@ -1751,7 +1751,7 @@
           <a:p>
             <a:r>
               <a:rPr lang="en-US" dirty="0"/>
-              <a:t>Internally consistent entitled-lot basis: the builder funds the horizontal, so the JV sells paper lots. Per lot = $150K finished − $60K horizontal − $22K builder margin ≈ $68K. 280 × $68K = $19.0M, less ~10% soft costs ≈ $17M. (Earlier $29M double-counted a finished price with a low cost load.) Illustrative until survey / entitlement.</a:t>
+              <a:t>Finished-lot basis: the JV funds the horizontal and sells finished lots. 280 lots × $150K = $42.0M gross revenue. Costs and returns are on the pro forma (slide 10). This captures the builder's development margin but takes horizontal execution risk and more capital than selling paper lots. Illustrative until survey / entitlement.</a:t>
             </a:r>
             <a:endParaRPr lang="en-US" dirty="0"/>
           </a:p>
@@ -2015,7 +2015,7 @@
           <a:p>
             <a:r>
               <a:rPr lang="en-US" dirty="0"/>
-              <a:t>For the land bank the honest story is capital-light: soft costs in, builders fund infra and buy lots. Land is already owned via H6 — no acquisition capital needed.</a:t>
+              <a:t>Finished-lot development: start light (entitlement), then fund the horizontal (roads/sewer/utilities) and deliver finished lots. Captures the builder's development margin and controls quality/timing — more capital, more value.</a:t>
             </a:r>
             <a:endParaRPr lang="en-US" dirty="0"/>
           </a:p>
@@ -3183,7 +3183,7 @@
                 <a:ea typeface="DM Sans" pitchFamily="34" charset="-122"/>
                 <a:cs typeface="DM Sans" pitchFamily="34" charset="-120"/>
               </a:rPr>
-              <a:t>A capital-light, entitled-lot merchant model: Capital H6 contributes the land, a small equity raise funds entitlement, and ~280 lots sell to a homebuilder who funds the horizontal. Illustrative — for discussion.</a:t>
+              <a:t>A finished-lot development: Capital H6 contributes the land, a development loan plus equity funds the horizontal, and we sell ~280 finished lots to homebuilders. Illustrative — for discussion.</a:t>
             </a:r>
             <a:endParaRPr lang="en-US" sz="1300" dirty="0"/>
           </a:p>
@@ -3467,7 +3467,7 @@
                 <a:ea typeface="DM Sans" pitchFamily="34" charset="-122"/>
                 <a:cs typeface="DM Sans" pitchFamily="34" charset="-120"/>
               </a:rPr>
-              <a:t>Entitlement, civil &amp; environmental</a:t>
+              <a:t>Horizontal site development ($60K/lot)</a:t>
             </a:r>
             <a:endParaRPr lang="en-US" sz="950" dirty="0"/>
           </a:p>
@@ -3526,7 +3526,7 @@
                 <a:ea typeface="Montserrat" pitchFamily="34" charset="-122"/>
                 <a:cs typeface="Montserrat" pitchFamily="34" charset="-120"/>
               </a:rPr>
-              <a:t>$1.1M</a:t>
+              <a:t>$16.8M</a:t>
             </a:r>
             <a:endParaRPr lang="en-US" sz="950" dirty="0"/>
           </a:p>
@@ -3585,7 +3585,7 @@
                 <a:ea typeface="DM Sans" pitchFamily="34" charset="-122"/>
                 <a:cs typeface="DM Sans" pitchFamily="34" charset="-120"/>
               </a:rPr>
-              <a:t>Legal, zoning &amp; approvals</a:t>
+              <a:t>Soft costs (entitle, civil, env, legal)</a:t>
             </a:r>
             <a:endParaRPr lang="en-US" sz="950" dirty="0"/>
           </a:p>
@@ -3644,7 +3644,7 @@
                 <a:ea typeface="Montserrat" pitchFamily="34" charset="-122"/>
                 <a:cs typeface="Montserrat" pitchFamily="34" charset="-120"/>
               </a:rPr>
-              <a:t>$0.4M</a:t>
+              <a:t>$2.8M</a:t>
             </a:r>
             <a:endParaRPr lang="en-US" sz="950" dirty="0"/>
           </a:p>
@@ -3762,7 +3762,7 @@
                 <a:ea typeface="Montserrat" pitchFamily="34" charset="-122"/>
                 <a:cs typeface="Montserrat" pitchFamily="34" charset="-120"/>
               </a:rPr>
-              <a:t>$0.6M</a:t>
+              <a:t>$1.3M</a:t>
             </a:r>
             <a:endParaRPr lang="en-US" sz="950" dirty="0"/>
           </a:p>
@@ -3821,7 +3821,7 @@
                 <a:ea typeface="DM Sans" pitchFamily="34" charset="-122"/>
                 <a:cs typeface="DM Sans" pitchFamily="34" charset="-120"/>
               </a:rPr>
-              <a:t>Predevelopment carry &amp; financing</a:t>
+              <a:t>Contingency (7% of hard)</a:t>
             </a:r>
             <a:endParaRPr lang="en-US" sz="950" dirty="0"/>
           </a:p>
@@ -3880,7 +3880,7 @@
                 <a:ea typeface="Montserrat" pitchFamily="34" charset="-122"/>
                 <a:cs typeface="Montserrat" pitchFamily="34" charset="-120"/>
               </a:rPr>
-              <a:t>$0.2M</a:t>
+              <a:t>$1.2M</a:t>
             </a:r>
             <a:endParaRPr lang="en-US" sz="950" dirty="0"/>
           </a:p>
@@ -3939,7 +3939,7 @@
                 <a:ea typeface="DM Sans" pitchFamily="34" charset="-122"/>
                 <a:cs typeface="DM Sans" pitchFamily="34" charset="-120"/>
               </a:rPr>
-              <a:t>Contingency</a:t>
+              <a:t>Financing / interest carry</a:t>
             </a:r>
             <a:endParaRPr lang="en-US" sz="950" dirty="0"/>
           </a:p>
@@ -3998,7 +3998,7 @@
                 <a:ea typeface="Montserrat" pitchFamily="34" charset="-122"/>
                 <a:cs typeface="Montserrat" pitchFamily="34" charset="-120"/>
               </a:rPr>
-              <a:t>$0.2M</a:t>
+              <a:t>$1.4M</a:t>
             </a:r>
             <a:endParaRPr lang="en-US" sz="950" dirty="0"/>
           </a:p>
@@ -4116,7 +4116,7 @@
                 <a:ea typeface="Montserrat" pitchFamily="34" charset="-122"/>
                 <a:cs typeface="Montserrat" pitchFamily="34" charset="-120"/>
               </a:rPr>
-              <a:t>$6.5M</a:t>
+              <a:t>$27.5M</a:t>
             </a:r>
             <a:endParaRPr lang="en-US" sz="950" dirty="0"/>
           </a:p>
@@ -4282,7 +4282,7 @@
                 <a:ea typeface="DM Sans" pitchFamily="34" charset="-122"/>
                 <a:cs typeface="DM Sans" pitchFamily="34" charset="-120"/>
               </a:rPr>
-              <a:t>Land equity (H6)</a:t>
+              <a:t>Development loan (~60% LTC)</a:t>
             </a:r>
             <a:endParaRPr lang="en-US" sz="950" dirty="0"/>
           </a:p>
@@ -4341,7 +4341,7 @@
                 <a:ea typeface="Montserrat" pitchFamily="34" charset="-122"/>
                 <a:cs typeface="Montserrat" pitchFamily="34" charset="-120"/>
               </a:rPr>
-              <a:t>$4.0M</a:t>
+              <a:t>$16.5M</a:t>
             </a:r>
             <a:endParaRPr lang="en-US" sz="950" dirty="0"/>
           </a:p>
@@ -4400,7 +4400,7 @@
                 <a:ea typeface="DM Sans" pitchFamily="34" charset="-122"/>
                 <a:cs typeface="DM Sans" pitchFamily="34" charset="-120"/>
               </a:rPr>
-              <a:t>Cash equity (JAL + LP)</a:t>
+              <a:t>Land equity (H6)</a:t>
             </a:r>
             <a:endParaRPr lang="en-US" sz="950" dirty="0"/>
           </a:p>
@@ -4459,7 +4459,7 @@
                 <a:ea typeface="Montserrat" pitchFamily="34" charset="-122"/>
                 <a:cs typeface="Montserrat" pitchFamily="34" charset="-120"/>
               </a:rPr>
-              <a:t>$2.0M</a:t>
+              <a:t>$4.0M</a:t>
             </a:r>
             <a:endParaRPr lang="en-US" sz="950" dirty="0"/>
           </a:p>
@@ -4518,7 +4518,7 @@
                 <a:ea typeface="DM Sans" pitchFamily="34" charset="-122"/>
                 <a:cs typeface="DM Sans" pitchFamily="34" charset="-120"/>
               </a:rPr>
-              <a:t>Predev facility</a:t>
+              <a:t>Cash equity (JAL + LP)</a:t>
             </a:r>
             <a:endParaRPr lang="en-US" sz="950" dirty="0"/>
           </a:p>
@@ -4577,7 +4577,7 @@
                 <a:ea typeface="Montserrat" pitchFamily="34" charset="-122"/>
                 <a:cs typeface="Montserrat" pitchFamily="34" charset="-120"/>
               </a:rPr>
-              <a:t>$0.5M</a:t>
+              <a:t>$7.0M</a:t>
             </a:r>
             <a:endParaRPr lang="en-US" sz="950" dirty="0"/>
           </a:p>
@@ -4695,7 +4695,7 @@
                 <a:ea typeface="Montserrat" pitchFamily="34" charset="-122"/>
                 <a:cs typeface="Montserrat" pitchFamily="34" charset="-120"/>
               </a:rPr>
-              <a:t>$6.5M</a:t>
+              <a:t>$27.5M</a:t>
             </a:r>
             <a:endParaRPr lang="en-US" sz="950" dirty="0"/>
           </a:p>
@@ -4816,7 +4816,7 @@
                 <a:ea typeface="DM Sans" pitchFamily="34" charset="-122"/>
                 <a:cs typeface="DM Sans" pitchFamily="34" charset="-120"/>
               </a:rPr>
-              <a:t>$68K net / lot  ·  ~280 lots over Yr 2–4  ·  builder funds horizontal  ·  8% pref + co-GP promote  ·  land at appraised value</a:t>
+              <a:t>$150K finished lot  ·  280 lots  ·  we fund the horizontal ($60K/lot)  ·  ~60% LTC loan  ·  8% pref + co-GP promote</a:t>
             </a:r>
             <a:endParaRPr lang="en-US" sz="850" dirty="0"/>
           </a:p>
@@ -4934,7 +4934,7 @@
                 <a:ea typeface="Montserrat" pitchFamily="34" charset="-122"/>
                 <a:cs typeface="Montserrat" pitchFamily="34" charset="-120"/>
               </a:rPr>
-              <a:t>$19.0M</a:t>
+              <a:t>$42.0M</a:t>
             </a:r>
             <a:endParaRPr lang="en-US" sz="1700" dirty="0"/>
           </a:p>
@@ -5012,7 +5012,7 @@
                 <a:ea typeface="Montserrat" pitchFamily="34" charset="-122"/>
                 <a:cs typeface="Montserrat" pitchFamily="34" charset="-120"/>
               </a:rPr>
-              <a:t>$12.5M</a:t>
+              <a:t>$14.5M</a:t>
             </a:r>
             <a:endParaRPr lang="en-US" sz="1700" dirty="0"/>
           </a:p>
@@ -5090,7 +5090,7 @@
                 <a:ea typeface="Montserrat" pitchFamily="34" charset="-122"/>
                 <a:cs typeface="Montserrat" pitchFamily="34" charset="-120"/>
               </a:rPr>
-              <a:t>~3.0×</a:t>
+              <a:t>~2.3×</a:t>
             </a:r>
             <a:endParaRPr lang="en-US" sz="1700" dirty="0"/>
           </a:p>
@@ -5168,7 +5168,7 @@
                 <a:ea typeface="Montserrat" pitchFamily="34" charset="-122"/>
                 <a:cs typeface="Montserrat" pitchFamily="34" charset="-120"/>
               </a:rPr>
-              <a:t>~32%</a:t>
+              <a:t>~24%</a:t>
             </a:r>
             <a:endParaRPr lang="en-US" sz="1700" dirty="0"/>
           </a:p>
@@ -5246,7 +5246,7 @@
                 <a:ea typeface="Montserrat" pitchFamily="34" charset="-122"/>
                 <a:cs typeface="Montserrat" pitchFamily="34" charset="-120"/>
               </a:rPr>
-              <a:t>~24%</a:t>
+              <a:t>~20%</a:t>
             </a:r>
             <a:endParaRPr lang="en-US" sz="1700" dirty="0"/>
           </a:p>
@@ -5344,7 +5344,7 @@
                 <a:ea typeface="DM Sans" pitchFamily="34" charset="-122"/>
                 <a:cs typeface="DM Sans" pitchFamily="34" charset="-120"/>
               </a:rPr>
-              <a:t>Illustrative: ~$12.5M profit on ~$6.5M cost — ~3.0× equity, ~32% project IRR. Builder funds the horizontal; JAL co-invests.</a:t>
+              <a:t>Illustrative: ~$14.5M profit on ~$27.5M cost — ~2.3× equity, ~24% project IRR. We deliver finished lots; builders just build.</a:t>
             </a:r>
             <a:endParaRPr lang="en-US" sz="1050" dirty="0"/>
           </a:p>
@@ -6327,7 +6327,7 @@
                 <a:ea typeface="Montserrat" pitchFamily="34" charset="-122"/>
                 <a:cs typeface="Montserrat" pitchFamily="34" charset="-120"/>
               </a:rPr>
-              <a:t>Finished lot value</a:t>
+              <a:t>Finished lot price</a:t>
             </a:r>
             <a:endParaRPr lang="en-US" sz="950" dirty="0"/>
           </a:p>
@@ -6507,7 +6507,7 @@
                 <a:ea typeface="Montserrat" pitchFamily="34" charset="-122"/>
                 <a:cs typeface="Montserrat" pitchFamily="34" charset="-120"/>
               </a:rPr>
-              <a:t>Builder-funded horizontal</a:t>
+              <a:t>Horizontal site development</a:t>
             </a:r>
             <a:endParaRPr lang="en-US" sz="950" dirty="0"/>
           </a:p>
@@ -6628,7 +6628,7 @@
                 <a:ea typeface="DM Sans" pitchFamily="34" charset="-122"/>
                 <a:cs typeface="DM Sans" pitchFamily="34" charset="-120"/>
               </a:rPr>
-              <a:t>Per-lot land-development benchmark; residential development runs $50–150K / acre</a:t>
+              <a:t>JV-funded — roads, sewer, utilities; national benchmark $50–150K / acre</a:t>
             </a:r>
             <a:endParaRPr lang="en-US" sz="900" dirty="0"/>
           </a:p>
@@ -6687,7 +6687,7 @@
                 <a:ea typeface="Montserrat" pitchFamily="34" charset="-122"/>
                 <a:cs typeface="Montserrat" pitchFamily="34" charset="-120"/>
               </a:rPr>
-              <a:t>Builder margin</a:t>
+              <a:t>Soft costs</a:t>
             </a:r>
             <a:endParaRPr lang="en-US" sz="950" dirty="0"/>
           </a:p>
@@ -6746,7 +6746,7 @@
                 <a:ea typeface="Montserrat" pitchFamily="34" charset="-122"/>
                 <a:cs typeface="Montserrat" pitchFamily="34" charset="-120"/>
               </a:rPr>
-              <a:t>~$22K (15%)</a:t>
+              <a:t>~$2.8M</a:t>
             </a:r>
             <a:endParaRPr lang="en-US" sz="950" dirty="0"/>
           </a:p>
@@ -6808,7 +6808,7 @@
                 <a:ea typeface="DM Sans" pitchFamily="34" charset="-122"/>
                 <a:cs typeface="DM Sans" pitchFamily="34" charset="-120"/>
               </a:rPr>
-              <a:t>Standard return for the builder to carry entitled lots through to finished</a:t>
+              <a:t>Entitlement, civil &amp; environmental, legal / zoning and management</a:t>
             </a:r>
             <a:endParaRPr lang="en-US" sz="900" dirty="0"/>
           </a:p>
@@ -6867,7 +6867,7 @@
                 <a:ea typeface="Montserrat" pitchFamily="34" charset="-122"/>
                 <a:cs typeface="Montserrat" pitchFamily="34" charset="-120"/>
               </a:rPr>
-              <a:t>JV soft costs</a:t>
+              <a:t>Development loan</a:t>
             </a:r>
             <a:endParaRPr lang="en-US" sz="950" dirty="0"/>
           </a:p>
@@ -6926,7 +6926,7 @@
                 <a:ea typeface="Montserrat" pitchFamily="34" charset="-122"/>
                 <a:cs typeface="Montserrat" pitchFamily="34" charset="-120"/>
               </a:rPr>
-              <a:t>~10%</a:t>
+              <a:t>~60% LTC</a:t>
             </a:r>
             <a:endParaRPr lang="en-US" sz="950" dirty="0"/>
           </a:p>
@@ -6988,7 +6988,7 @@
                 <a:ea typeface="DM Sans" pitchFamily="34" charset="-122"/>
                 <a:cs typeface="DM Sans" pitchFamily="34" charset="-120"/>
               </a:rPr>
-              <a:t>Entitlement, civil &amp; environmental, legal / zoning and brokerage</a:t>
+              <a:t>Standard land-development / A&amp;D financing on the horizontal</a:t>
             </a:r>
             <a:endParaRPr lang="en-US" sz="900" dirty="0"/>
           </a:p>
@@ -16883,7 +16883,7 @@
                 <a:ea typeface="DM Sans" pitchFamily="34" charset="-122"/>
                 <a:cs typeface="DM Sans" pitchFamily="34" charset="-120"/>
               </a:rPr>
-              <a:t>First entitled-lot sales underwritten</a:t>
+              <a:t>First finished-lot sales underwritten</a:t>
             </a:r>
             <a:endParaRPr lang="en-US" sz="1000" dirty="0"/>
           </a:p>
@@ -18223,7 +18223,7 @@
                 <a:ea typeface="Montserrat" pitchFamily="34" charset="-122"/>
                 <a:cs typeface="Montserrat" pitchFamily="34" charset="-120"/>
               </a:rPr>
-              <a:t>To begin</a:t>
+              <a:t>To entitle</a:t>
             </a:r>
             <a:endParaRPr lang="en-US" sz="1200" dirty="0"/>
           </a:p>
@@ -18262,7 +18262,7 @@
                 <a:ea typeface="DM Sans" pitchFamily="34" charset="-122"/>
                 <a:cs typeface="DM Sans" pitchFamily="34" charset="-120"/>
               </a:rPr>
-              <a:t>Builders fund the horizontal infrastructure</a:t>
+              <a:t>Phase 1 is light; we fund the horizontal next</a:t>
             </a:r>
             <a:endParaRPr lang="en-US" sz="1000" dirty="0"/>
           </a:p>
@@ -18467,7 +18467,7 @@
                 <a:ea typeface="DM Sans" pitchFamily="34" charset="-122"/>
                 <a:cs typeface="DM Sans" pitchFamily="34" charset="-120"/>
               </a:rPr>
-              <a:t>Builders fund sewer, roads and utilities — you carry approvals, not construction risk.</a:t>
+              <a:t>We develop the lots — roads, sewer and utilities — and sell them finished, capturing the full lot value.</a:t>
             </a:r>
             <a:endParaRPr lang="en-US" sz="1000" dirty="0"/>
           </a:p>
@@ -20329,7 +20329,7 @@
                 <a:ea typeface="DM Sans" pitchFamily="34" charset="-122"/>
                 <a:cs typeface="DM Sans" pitchFamily="34" charset="-120"/>
               </a:rPr>
-              <a:t>The resort operates; the value-creation is entitling the developable, non-conservation acreage and selling finished lots to homebuilders. Capital-light, and additive to the hospitality.</a:t>
+              <a:t>The resort operates; the value-creation is entitling and developing the non-conservation acreage and selling finished lots to homebuilders — capturing the full lot value, additive to the hospitality.</a:t>
             </a:r>
             <a:endParaRPr lang="en-US" sz="1300" dirty="0"/>
           </a:p>
@@ -21102,7 +21102,7 @@
                 <a:ea typeface="DM Sans" pitchFamily="34" charset="-122"/>
                 <a:cs typeface="DM Sans" pitchFamily="34" charset="-120"/>
               </a:rPr>
-              <a:t>Entitle for residential; sell finished lots to builders who fund the horizontal work.</a:t>
+              <a:t>Entitle, then develop finished lots — we fund the roads, sewer and utilities; builders just build.</a:t>
             </a:r>
             <a:endParaRPr lang="en-US" sz="1000" dirty="0"/>
           </a:p>
@@ -21629,7 +21629,7 @@
                 <a:ea typeface="DM Sans" pitchFamily="34" charset="-122"/>
                 <a:cs typeface="DM Sans" pitchFamily="34" charset="-120"/>
               </a:rPr>
-              <a:t>Capital-light by sequence — soft costs first, then builders carry the infrastructure and construction risk, and the proceeds recycle into the next parcel.</a:t>
+              <a:t>Phased — entitle first (soft costs), then we fund the horizontal and deliver finished lots, recycling proceeds into the next parcel.</a:t>
             </a:r>
             <a:endParaRPr lang="en-US" sz="1300" dirty="0"/>
           </a:p>
@@ -22067,7 +22067,7 @@
                 <a:ea typeface="DM Sans" pitchFamily="34" charset="-122"/>
                 <a:cs typeface="DM Sans" pitchFamily="34" charset="-120"/>
               </a:rPr>
-              <a:t>Sell entitled lots to regional builders and let them fund sewer, roads and utilities.</a:t>
+              <a:t>Develop finished lots — we fund the roads, sewer and utilities; the builder just builds the homes.</a:t>
             </a:r>
             <a:endParaRPr lang="en-US" sz="1050" dirty="0"/>
           </a:p>
@@ -22870,7 +22870,7 @@
                 <a:ea typeface="Montserrat" pitchFamily="34" charset="-122"/>
                 <a:cs typeface="Montserrat" pitchFamily="34" charset="-120"/>
               </a:rPr>
-              <a:t>From 700 acres to ~$17M of entitled-lot value.</a:t>
+              <a:t>From 700 acres to $42M of finished-lot revenue.</a:t>
             </a:r>
             <a:endParaRPr lang="en-US" sz="2500" dirty="0"/>
           </a:p>
@@ -22912,7 +22912,7 @@
                 <a:ea typeface="DM Sans" pitchFamily="34" charset="-122"/>
                 <a:cs typeface="DM Sans" pitchFamily="34" charset="-120"/>
               </a:rPr>
-              <a:t>Capital-light, entitled-lot basis: the JV sells entitled lots and the homebuilder funds the horizontal. Each lot equals the finished-lot price less the builder's horizontal cost and margin. Illustrative — survey-dependent.</a:t>
+              <a:t>Finished-lot basis: we develop the lots — funding roads, sewer and utilities — and sell them finished; the builder just builds the homes. Costs and returns are on the pro forma. Illustrative — survey-dependent.</a:t>
             </a:r>
             <a:endParaRPr lang="en-US" sz="1300" dirty="0"/>
           </a:p>
@@ -23163,7 +23163,7 @@
         <p:spPr>
           <a:xfrm>
             <a:off x="457200" y="2286000"/>
-            <a:ext cx="2926080" cy="393192"/>
+            <a:ext cx="2926080" cy="438912"/>
           </a:xfrm>
           <a:prstGeom prst="rect">
             <a:avLst/>
@@ -23183,7 +23183,7 @@
         <p:spPr>
           <a:xfrm>
             <a:off x="457200" y="2286000"/>
-            <a:ext cx="2926080" cy="393192"/>
+            <a:ext cx="2926080" cy="438912"/>
           </a:xfrm>
           <a:prstGeom prst="rect">
             <a:avLst/>
@@ -23222,7 +23222,7 @@
         <p:spPr>
           <a:xfrm>
             <a:off x="3383280" y="2286000"/>
-            <a:ext cx="3108960" cy="393192"/>
+            <a:ext cx="3108960" cy="438912"/>
           </a:xfrm>
           <a:prstGeom prst="rect">
             <a:avLst/>
@@ -23242,7 +23242,7 @@
         <p:spPr>
           <a:xfrm>
             <a:off x="3383280" y="2286000"/>
-            <a:ext cx="3108960" cy="393192"/>
+            <a:ext cx="3108960" cy="438912"/>
           </a:xfrm>
           <a:prstGeom prst="rect">
             <a:avLst/>
@@ -23281,7 +23281,7 @@
         <p:spPr>
           <a:xfrm>
             <a:off x="6492240" y="2286000"/>
-            <a:ext cx="2651760" cy="393192"/>
+            <a:ext cx="2651760" cy="438912"/>
           </a:xfrm>
           <a:prstGeom prst="rect">
             <a:avLst/>
@@ -23301,7 +23301,7 @@
         <p:spPr>
           <a:xfrm>
             <a:off x="6492240" y="2286000"/>
-            <a:ext cx="2651760" cy="393192"/>
+            <a:ext cx="2651760" cy="438912"/>
           </a:xfrm>
           <a:prstGeom prst="rect">
             <a:avLst/>
@@ -23340,7 +23340,7 @@
         <p:spPr>
           <a:xfrm>
             <a:off x="9144000" y="2286000"/>
-            <a:ext cx="2587752" cy="393192"/>
+            <a:ext cx="2587752" cy="438912"/>
           </a:xfrm>
           <a:prstGeom prst="rect">
             <a:avLst/>
@@ -23360,7 +23360,7 @@
         <p:spPr>
           <a:xfrm>
             <a:off x="9144000" y="2286000"/>
-            <a:ext cx="2587752" cy="393192"/>
+            <a:ext cx="2587752" cy="438912"/>
           </a:xfrm>
           <a:prstGeom prst="rect">
             <a:avLst/>
@@ -23398,8 +23398,8 @@
         </p:nvSpPr>
         <p:spPr>
           <a:xfrm>
-            <a:off x="457200" y="2679192"/>
-            <a:ext cx="2926080" cy="393192"/>
+            <a:off x="457200" y="2724912"/>
+            <a:ext cx="2926080" cy="438912"/>
           </a:xfrm>
           <a:prstGeom prst="rect">
             <a:avLst/>
@@ -23418,8 +23418,8 @@
         </p:nvSpPr>
         <p:spPr>
           <a:xfrm>
-            <a:off x="457200" y="2679192"/>
-            <a:ext cx="2926080" cy="393192"/>
+            <a:off x="457200" y="2724912"/>
+            <a:ext cx="2926080" cy="438912"/>
           </a:xfrm>
           <a:prstGeom prst="rect">
             <a:avLst/>
@@ -23457,8 +23457,8 @@
         </p:nvSpPr>
         <p:spPr>
           <a:xfrm>
-            <a:off x="3383280" y="2679192"/>
-            <a:ext cx="3108960" cy="393192"/>
+            <a:off x="3383280" y="2724912"/>
+            <a:ext cx="3108960" cy="438912"/>
           </a:xfrm>
           <a:prstGeom prst="rect">
             <a:avLst/>
@@ -23477,8 +23477,8 @@
         </p:nvSpPr>
         <p:spPr>
           <a:xfrm>
-            <a:off x="3383280" y="2679192"/>
-            <a:ext cx="3108960" cy="393192"/>
+            <a:off x="3383280" y="2724912"/>
+            <a:ext cx="3108960" cy="438912"/>
           </a:xfrm>
           <a:prstGeom prst="rect">
             <a:avLst/>
@@ -23516,8 +23516,8 @@
         </p:nvSpPr>
         <p:spPr>
           <a:xfrm>
-            <a:off x="6492240" y="2679192"/>
-            <a:ext cx="2651760" cy="393192"/>
+            <a:off x="6492240" y="2724912"/>
+            <a:ext cx="2651760" cy="438912"/>
           </a:xfrm>
           <a:prstGeom prst="rect">
             <a:avLst/>
@@ -23536,8 +23536,8 @@
         </p:nvSpPr>
         <p:spPr>
           <a:xfrm>
-            <a:off x="6492240" y="2679192"/>
-            <a:ext cx="2651760" cy="393192"/>
+            <a:off x="6492240" y="2724912"/>
+            <a:ext cx="2651760" cy="438912"/>
           </a:xfrm>
           <a:prstGeom prst="rect">
             <a:avLst/>
@@ -23575,8 +23575,8 @@
         </p:nvSpPr>
         <p:spPr>
           <a:xfrm>
-            <a:off x="9144000" y="2679192"/>
-            <a:ext cx="2587752" cy="393192"/>
+            <a:off x="9144000" y="2724912"/>
+            <a:ext cx="2587752" cy="438912"/>
           </a:xfrm>
           <a:prstGeom prst="rect">
             <a:avLst/>
@@ -23595,8 +23595,8 @@
         </p:nvSpPr>
         <p:spPr>
           <a:xfrm>
-            <a:off x="9144000" y="2679192"/>
-            <a:ext cx="2587752" cy="393192"/>
+            <a:off x="9144000" y="2724912"/>
+            <a:ext cx="2587752" cy="438912"/>
           </a:xfrm>
           <a:prstGeom prst="rect">
             <a:avLst/>
@@ -23634,8 +23634,8 @@
         </p:nvSpPr>
         <p:spPr>
           <a:xfrm>
-            <a:off x="457200" y="3072384"/>
-            <a:ext cx="2926080" cy="393192"/>
+            <a:off x="457200" y="3163824"/>
+            <a:ext cx="2926080" cy="438912"/>
           </a:xfrm>
           <a:prstGeom prst="rect">
             <a:avLst/>
@@ -23654,8 +23654,8 @@
         </p:nvSpPr>
         <p:spPr>
           <a:xfrm>
-            <a:off x="457200" y="3072384"/>
-            <a:ext cx="2926080" cy="393192"/>
+            <a:off x="457200" y="3163824"/>
+            <a:ext cx="2926080" cy="438912"/>
           </a:xfrm>
           <a:prstGeom prst="rect">
             <a:avLst/>
@@ -23693,8 +23693,8 @@
         </p:nvSpPr>
         <p:spPr>
           <a:xfrm>
-            <a:off x="3383280" y="3072384"/>
-            <a:ext cx="3108960" cy="393192"/>
+            <a:off x="3383280" y="3163824"/>
+            <a:ext cx="3108960" cy="438912"/>
           </a:xfrm>
           <a:prstGeom prst="rect">
             <a:avLst/>
@@ -23713,8 +23713,8 @@
         </p:nvSpPr>
         <p:spPr>
           <a:xfrm>
-            <a:off x="3383280" y="3072384"/>
-            <a:ext cx="3108960" cy="393192"/>
+            <a:off x="3383280" y="3163824"/>
+            <a:ext cx="3108960" cy="438912"/>
           </a:xfrm>
           <a:prstGeom prst="rect">
             <a:avLst/>
@@ -23752,8 +23752,8 @@
         </p:nvSpPr>
         <p:spPr>
           <a:xfrm>
-            <a:off x="6492240" y="3072384"/>
-            <a:ext cx="2651760" cy="393192"/>
+            <a:off x="6492240" y="3163824"/>
+            <a:ext cx="2651760" cy="438912"/>
           </a:xfrm>
           <a:prstGeom prst="rect">
             <a:avLst/>
@@ -23772,8 +23772,8 @@
         </p:nvSpPr>
         <p:spPr>
           <a:xfrm>
-            <a:off x="6492240" y="3072384"/>
-            <a:ext cx="2651760" cy="393192"/>
+            <a:off x="6492240" y="3163824"/>
+            <a:ext cx="2651760" cy="438912"/>
           </a:xfrm>
           <a:prstGeom prst="rect">
             <a:avLst/>
@@ -23811,8 +23811,8 @@
         </p:nvSpPr>
         <p:spPr>
           <a:xfrm>
-            <a:off x="9144000" y="3072384"/>
-            <a:ext cx="2587752" cy="393192"/>
+            <a:off x="9144000" y="3163824"/>
+            <a:ext cx="2587752" cy="438912"/>
           </a:xfrm>
           <a:prstGeom prst="rect">
             <a:avLst/>
@@ -23831,8 +23831,8 @@
         </p:nvSpPr>
         <p:spPr>
           <a:xfrm>
-            <a:off x="9144000" y="3072384"/>
-            <a:ext cx="2587752" cy="393192"/>
+            <a:off x="9144000" y="3163824"/>
+            <a:ext cx="2587752" cy="438912"/>
           </a:xfrm>
           <a:prstGeom prst="rect">
             <a:avLst/>
@@ -23870,8 +23870,8 @@
         </p:nvSpPr>
         <p:spPr>
           <a:xfrm>
-            <a:off x="457200" y="3465576"/>
-            <a:ext cx="2926080" cy="393192"/>
+            <a:off x="457200" y="3602736"/>
+            <a:ext cx="2926080" cy="438912"/>
           </a:xfrm>
           <a:prstGeom prst="rect">
             <a:avLst/>
@@ -23890,8 +23890,8 @@
         </p:nvSpPr>
         <p:spPr>
           <a:xfrm>
-            <a:off x="457200" y="3465576"/>
-            <a:ext cx="2926080" cy="393192"/>
+            <a:off x="457200" y="3602736"/>
+            <a:ext cx="2926080" cy="438912"/>
           </a:xfrm>
           <a:prstGeom prst="rect">
             <a:avLst/>
@@ -23929,8 +23929,8 @@
         </p:nvSpPr>
         <p:spPr>
           <a:xfrm>
-            <a:off x="3383280" y="3465576"/>
-            <a:ext cx="3108960" cy="393192"/>
+            <a:off x="3383280" y="3602736"/>
+            <a:ext cx="3108960" cy="438912"/>
           </a:xfrm>
           <a:prstGeom prst="rect">
             <a:avLst/>
@@ -23949,8 +23949,8 @@
         </p:nvSpPr>
         <p:spPr>
           <a:xfrm>
-            <a:off x="3383280" y="3465576"/>
-            <a:ext cx="3108960" cy="393192"/>
+            <a:off x="3383280" y="3602736"/>
+            <a:ext cx="3108960" cy="438912"/>
           </a:xfrm>
           <a:prstGeom prst="rect">
             <a:avLst/>
@@ -23988,8 +23988,8 @@
         </p:nvSpPr>
         <p:spPr>
           <a:xfrm>
-            <a:off x="6492240" y="3465576"/>
-            <a:ext cx="2651760" cy="393192"/>
+            <a:off x="6492240" y="3602736"/>
+            <a:ext cx="2651760" cy="438912"/>
           </a:xfrm>
           <a:prstGeom prst="rect">
             <a:avLst/>
@@ -24008,8 +24008,8 @@
         </p:nvSpPr>
         <p:spPr>
           <a:xfrm>
-            <a:off x="6492240" y="3465576"/>
-            <a:ext cx="2651760" cy="393192"/>
+            <a:off x="6492240" y="3602736"/>
+            <a:ext cx="2651760" cy="438912"/>
           </a:xfrm>
           <a:prstGeom prst="rect">
             <a:avLst/>
@@ -24047,8 +24047,8 @@
         </p:nvSpPr>
         <p:spPr>
           <a:xfrm>
-            <a:off x="9144000" y="3465576"/>
-            <a:ext cx="2587752" cy="393192"/>
+            <a:off x="9144000" y="3602736"/>
+            <a:ext cx="2587752" cy="438912"/>
           </a:xfrm>
           <a:prstGeom prst="rect">
             <a:avLst/>
@@ -24067,8 +24067,8 @@
         </p:nvSpPr>
         <p:spPr>
           <a:xfrm>
-            <a:off x="9144000" y="3465576"/>
-            <a:ext cx="2587752" cy="393192"/>
+            <a:off x="9144000" y="3602736"/>
+            <a:ext cx="2587752" cy="438912"/>
           </a:xfrm>
           <a:prstGeom prst="rect">
             <a:avLst/>
@@ -24106,8 +24106,8 @@
         </p:nvSpPr>
         <p:spPr>
           <a:xfrm>
-            <a:off x="457200" y="3858768"/>
-            <a:ext cx="2926080" cy="393192"/>
+            <a:off x="457200" y="4041648"/>
+            <a:ext cx="2926080" cy="438912"/>
           </a:xfrm>
           <a:prstGeom prst="rect">
             <a:avLst/>
@@ -24126,8 +24126,8 @@
         </p:nvSpPr>
         <p:spPr>
           <a:xfrm>
-            <a:off x="457200" y="3858768"/>
-            <a:ext cx="2926080" cy="393192"/>
+            <a:off x="457200" y="4041648"/>
+            <a:ext cx="2926080" cy="438912"/>
           </a:xfrm>
           <a:prstGeom prst="rect">
             <a:avLst/>
@@ -24151,7 +24151,7 @@
                 <a:ea typeface="Montserrat" pitchFamily="34" charset="-122"/>
                 <a:cs typeface="Montserrat" pitchFamily="34" charset="-120"/>
               </a:rPr>
-              <a:t>Entitled lots</a:t>
+              <a:t>Finished lots</a:t>
             </a:r>
             <a:endParaRPr lang="en-US" sz="1000" dirty="0"/>
           </a:p>
@@ -24165,8 +24165,8 @@
         </p:nvSpPr>
         <p:spPr>
           <a:xfrm>
-            <a:off x="3383280" y="3858768"/>
-            <a:ext cx="3108960" cy="393192"/>
+            <a:off x="3383280" y="4041648"/>
+            <a:ext cx="3108960" cy="438912"/>
           </a:xfrm>
           <a:prstGeom prst="rect">
             <a:avLst/>
@@ -24185,8 +24185,8 @@
         </p:nvSpPr>
         <p:spPr>
           <a:xfrm>
-            <a:off x="3383280" y="3858768"/>
-            <a:ext cx="3108960" cy="393192"/>
+            <a:off x="3383280" y="4041648"/>
+            <a:ext cx="3108960" cy="438912"/>
           </a:xfrm>
           <a:prstGeom prst="rect">
             <a:avLst/>
@@ -24224,8 +24224,8 @@
         </p:nvSpPr>
         <p:spPr>
           <a:xfrm>
-            <a:off x="6492240" y="3858768"/>
-            <a:ext cx="2651760" cy="393192"/>
+            <a:off x="6492240" y="4041648"/>
+            <a:ext cx="2651760" cy="438912"/>
           </a:xfrm>
           <a:prstGeom prst="rect">
             <a:avLst/>
@@ -24244,8 +24244,8 @@
         </p:nvSpPr>
         <p:spPr>
           <a:xfrm>
-            <a:off x="6492240" y="3858768"/>
-            <a:ext cx="2651760" cy="393192"/>
+            <a:off x="6492240" y="4041648"/>
+            <a:ext cx="2651760" cy="438912"/>
           </a:xfrm>
           <a:prstGeom prst="rect">
             <a:avLst/>
@@ -24283,8 +24283,8 @@
         </p:nvSpPr>
         <p:spPr>
           <a:xfrm>
-            <a:off x="9144000" y="3858768"/>
-            <a:ext cx="2587752" cy="393192"/>
+            <a:off x="9144000" y="4041648"/>
+            <a:ext cx="2587752" cy="438912"/>
           </a:xfrm>
           <a:prstGeom prst="rect">
             <a:avLst/>
@@ -24303,8 +24303,8 @@
         </p:nvSpPr>
         <p:spPr>
           <a:xfrm>
-            <a:off x="9144000" y="3858768"/>
-            <a:ext cx="2587752" cy="393192"/>
+            <a:off x="9144000" y="4041648"/>
+            <a:ext cx="2587752" cy="438912"/>
           </a:xfrm>
           <a:prstGeom prst="rect">
             <a:avLst/>
@@ -24342,8 +24342,8 @@
         </p:nvSpPr>
         <p:spPr>
           <a:xfrm>
-            <a:off x="457200" y="4251960"/>
-            <a:ext cx="2926080" cy="393192"/>
+            <a:off x="457200" y="4480560"/>
+            <a:ext cx="2926080" cy="438912"/>
           </a:xfrm>
           <a:prstGeom prst="rect">
             <a:avLst/>
@@ -24362,8 +24362,8 @@
         </p:nvSpPr>
         <p:spPr>
           <a:xfrm>
-            <a:off x="457200" y="4251960"/>
-            <a:ext cx="2926080" cy="393192"/>
+            <a:off x="457200" y="4480560"/>
+            <a:ext cx="2926080" cy="438912"/>
           </a:xfrm>
           <a:prstGeom prst="rect">
             <a:avLst/>
@@ -24387,7 +24387,7 @@
                 <a:ea typeface="Montserrat" pitchFamily="34" charset="-122"/>
                 <a:cs typeface="Montserrat" pitchFamily="34" charset="-120"/>
               </a:rPr>
-              <a:t>Value per entitled lot</a:t>
+              <a:t>Finished lot price</a:t>
             </a:r>
             <a:endParaRPr lang="en-US" sz="1000" dirty="0"/>
           </a:p>
@@ -24401,8 +24401,8 @@
         </p:nvSpPr>
         <p:spPr>
           <a:xfrm>
-            <a:off x="3383280" y="4251960"/>
-            <a:ext cx="3108960" cy="393192"/>
+            <a:off x="3383280" y="4480560"/>
+            <a:ext cx="3108960" cy="438912"/>
           </a:xfrm>
           <a:prstGeom prst="rect">
             <a:avLst/>
@@ -24421,8 +24421,8 @@
         </p:nvSpPr>
         <p:spPr>
           <a:xfrm>
-            <a:off x="3383280" y="4251960"/>
-            <a:ext cx="3108960" cy="393192"/>
+            <a:off x="3383280" y="4480560"/>
+            <a:ext cx="3108960" cy="438912"/>
           </a:xfrm>
           <a:prstGeom prst="rect">
             <a:avLst/>
@@ -24446,7 +24446,7 @@
                 <a:ea typeface="DM Sans" pitchFamily="34" charset="-122"/>
                 <a:cs typeface="DM Sans" pitchFamily="34" charset="-120"/>
               </a:rPr>
-              <a:t>builder funds the horizontal</a:t>
+              <a:t>we deliver finished lots</a:t>
             </a:r>
             <a:endParaRPr lang="en-US" sz="950" dirty="0"/>
           </a:p>
@@ -24460,8 +24460,8 @@
         </p:nvSpPr>
         <p:spPr>
           <a:xfrm>
-            <a:off x="6492240" y="4251960"/>
-            <a:ext cx="2651760" cy="393192"/>
+            <a:off x="6492240" y="4480560"/>
+            <a:ext cx="2651760" cy="438912"/>
           </a:xfrm>
           <a:prstGeom prst="rect">
             <a:avLst/>
@@ -24480,8 +24480,8 @@
         </p:nvSpPr>
         <p:spPr>
           <a:xfrm>
-            <a:off x="6492240" y="4251960"/>
-            <a:ext cx="2651760" cy="393192"/>
+            <a:off x="6492240" y="4480560"/>
+            <a:ext cx="2651760" cy="438912"/>
           </a:xfrm>
           <a:prstGeom prst="rect">
             <a:avLst/>
@@ -24505,7 +24505,7 @@
                 <a:ea typeface="DM Sans" pitchFamily="34" charset="-122"/>
                 <a:cs typeface="DM Sans" pitchFamily="34" charset="-120"/>
               </a:rPr>
-              <a:t>$150K − $60K − $22K</a:t>
+              <a:t>to homebuilders</a:t>
             </a:r>
             <a:endParaRPr lang="en-US" sz="900" dirty="0"/>
           </a:p>
@@ -24519,8 +24519,8 @@
         </p:nvSpPr>
         <p:spPr>
           <a:xfrm>
-            <a:off x="9144000" y="4251960"/>
-            <a:ext cx="2587752" cy="393192"/>
+            <a:off x="9144000" y="4480560"/>
+            <a:ext cx="2587752" cy="438912"/>
           </a:xfrm>
           <a:prstGeom prst="rect">
             <a:avLst/>
@@ -24539,8 +24539,8 @@
         </p:nvSpPr>
         <p:spPr>
           <a:xfrm>
-            <a:off x="9144000" y="4251960"/>
-            <a:ext cx="2587752" cy="393192"/>
+            <a:off x="9144000" y="4480560"/>
+            <a:ext cx="2587752" cy="438912"/>
           </a:xfrm>
           <a:prstGeom prst="rect">
             <a:avLst/>
@@ -24564,7 +24564,7 @@
                 <a:ea typeface="Montserrat" pitchFamily="34" charset="-122"/>
                 <a:cs typeface="Montserrat" pitchFamily="34" charset="-120"/>
               </a:rPr>
-              <a:t>~$68K</a:t>
+              <a:t>$150K</a:t>
             </a:r>
             <a:endParaRPr lang="en-US" sz="1100" dirty="0"/>
           </a:p>
@@ -24578,8 +24578,8 @@
         </p:nvSpPr>
         <p:spPr>
           <a:xfrm>
-            <a:off x="457200" y="4645152"/>
-            <a:ext cx="2926080" cy="393192"/>
+            <a:off x="457200" y="4919472"/>
+            <a:ext cx="2926080" cy="438912"/>
           </a:xfrm>
           <a:prstGeom prst="rect">
             <a:avLst/>
@@ -24598,8 +24598,8 @@
         </p:nvSpPr>
         <p:spPr>
           <a:xfrm>
-            <a:off x="457200" y="4645152"/>
-            <a:ext cx="2926080" cy="393192"/>
+            <a:off x="457200" y="4919472"/>
+            <a:ext cx="2926080" cy="438912"/>
           </a:xfrm>
           <a:prstGeom prst="rect">
             <a:avLst/>
@@ -24623,7 +24623,7 @@
                 <a:ea typeface="Montserrat" pitchFamily="34" charset="-122"/>
                 <a:cs typeface="Montserrat" pitchFamily="34" charset="-120"/>
               </a:rPr>
-              <a:t>Gross land proceeds</a:t>
+              <a:t>GROSS LOT REVENUE</a:t>
             </a:r>
             <a:endParaRPr lang="en-US" sz="1000" dirty="0"/>
           </a:p>
@@ -24637,8 +24637,8 @@
         </p:nvSpPr>
         <p:spPr>
           <a:xfrm>
-            <a:off x="3383280" y="4645152"/>
-            <a:ext cx="3108960" cy="393192"/>
+            <a:off x="3383280" y="4919472"/>
+            <a:ext cx="3108960" cy="438912"/>
           </a:xfrm>
           <a:prstGeom prst="rect">
             <a:avLst/>
@@ -24657,8 +24657,8 @@
         </p:nvSpPr>
         <p:spPr>
           <a:xfrm>
-            <a:off x="3383280" y="4645152"/>
-            <a:ext cx="3108960" cy="393192"/>
+            <a:off x="3383280" y="4919472"/>
+            <a:ext cx="3108960" cy="438912"/>
           </a:xfrm>
           <a:prstGeom prst="rect">
             <a:avLst/>
@@ -24676,13 +24676,13 @@
             <a:r>
               <a:rPr lang="en-US" sz="950" dirty="0">
                 <a:solidFill>
-                  <a:srgbClr val="0B163C"/>
+                  <a:srgbClr val="6B5A6B"/>
                 </a:solidFill>
                 <a:latin typeface="DM Sans" pitchFamily="34" charset="0"/>
                 <a:ea typeface="DM Sans" pitchFamily="34" charset="-122"/>
                 <a:cs typeface="DM Sans" pitchFamily="34" charset="-120"/>
               </a:rPr>
-              <a:t>paid by the homebuilder</a:t>
+              <a:t>net profit &amp; returns on the pro forma</a:t>
             </a:r>
             <a:endParaRPr lang="en-US" sz="950" dirty="0"/>
           </a:p>
@@ -24696,8 +24696,8 @@
         </p:nvSpPr>
         <p:spPr>
           <a:xfrm>
-            <a:off x="6492240" y="4645152"/>
-            <a:ext cx="2651760" cy="393192"/>
+            <a:off x="6492240" y="4919472"/>
+            <a:ext cx="2651760" cy="438912"/>
           </a:xfrm>
           <a:prstGeom prst="rect">
             <a:avLst/>
@@ -24716,8 +24716,8 @@
         </p:nvSpPr>
         <p:spPr>
           <a:xfrm>
-            <a:off x="6492240" y="4645152"/>
-            <a:ext cx="2651760" cy="393192"/>
+            <a:off x="6492240" y="4919472"/>
+            <a:ext cx="2651760" cy="438912"/>
           </a:xfrm>
           <a:prstGeom prst="rect">
             <a:avLst/>
@@ -24741,7 +24741,7 @@
                 <a:ea typeface="DM Sans" pitchFamily="34" charset="-122"/>
                 <a:cs typeface="DM Sans" pitchFamily="34" charset="-120"/>
               </a:rPr>
-              <a:t>280 × $68K</a:t>
+              <a:t>280 × $150K</a:t>
             </a:r>
             <a:endParaRPr lang="en-US" sz="900" dirty="0"/>
           </a:p>
@@ -24755,8 +24755,8 @@
         </p:nvSpPr>
         <p:spPr>
           <a:xfrm>
-            <a:off x="9144000" y="4645152"/>
-            <a:ext cx="2587752" cy="393192"/>
+            <a:off x="9144000" y="4919472"/>
+            <a:ext cx="2587752" cy="438912"/>
           </a:xfrm>
           <a:prstGeom prst="rect">
             <a:avLst/>
@@ -24775,8 +24775,8 @@
         </p:nvSpPr>
         <p:spPr>
           <a:xfrm>
-            <a:off x="9144000" y="4645152"/>
-            <a:ext cx="2587752" cy="393192"/>
+            <a:off x="9144000" y="4919472"/>
+            <a:ext cx="2587752" cy="438912"/>
           </a:xfrm>
           <a:prstGeom prst="rect">
             <a:avLst/>
@@ -24800,7 +24800,7 @@
                 <a:ea typeface="Montserrat" pitchFamily="34" charset="-122"/>
                 <a:cs typeface="Montserrat" pitchFamily="34" charset="-120"/>
               </a:rPr>
-              <a:t>$19.0M</a:t>
+              <a:t>$42.0M</a:t>
             </a:r>
             <a:endParaRPr lang="en-US" sz="1100" dirty="0"/>
           </a:p>
@@ -24814,14 +24814,14 @@
         </p:nvSpPr>
         <p:spPr>
           <a:xfrm>
-            <a:off x="457200" y="5038344"/>
-            <a:ext cx="2926080" cy="393192"/>
-          </a:xfrm>
-          <a:prstGeom prst="rect">
-            <a:avLst/>
-          </a:prstGeom>
-          <a:solidFill>
-            <a:srgbClr val="F4F2ED"/>
+            <a:off x="457200" y="5486400"/>
+            <a:ext cx="11274552" cy="411480"/>
+          </a:xfrm>
+          <a:prstGeom prst="rect">
+            <a:avLst/>
+          </a:prstGeom>
+          <a:solidFill>
+            <a:srgbClr val="0B163C"/>
           </a:solidFill>
           <a:ln/>
         </p:spPr>
@@ -24834,209 +24834,32 @@
         </p:nvSpPr>
         <p:spPr>
           <a:xfrm>
-            <a:off x="457200" y="5038344"/>
-            <a:ext cx="2926080" cy="393192"/>
-          </a:xfrm>
-          <a:prstGeom prst="rect">
-            <a:avLst/>
-          </a:prstGeom>
-          <a:noFill/>
-          <a:ln/>
-        </p:spPr>
-        <p:txBody>
-          <a:bodyPr wrap="square" lIns="25400" tIns="76200" rIns="76200" bIns="25400" rtlCol="0" anchor="ctr"/>
-          <a:lstStyle/>
-          <a:p>
-            <a:pPr algn="l" indent="0" marL="0">
-              <a:buNone/>
-            </a:pPr>
-            <a:r>
-              <a:rPr lang="en-US" sz="1000" b="1" dirty="0">
-                <a:solidFill>
-                  <a:srgbClr val="0B163C"/>
+            <a:off x="640080" y="5486400"/>
+            <a:ext cx="10908792" cy="411480"/>
+          </a:xfrm>
+          <a:prstGeom prst="rect">
+            <a:avLst/>
+          </a:prstGeom>
+          <a:noFill/>
+          <a:ln/>
+        </p:spPr>
+        <p:txBody>
+          <a:bodyPr wrap="square" lIns="0" tIns="0" rIns="0" bIns="0" rtlCol="0" anchor="ctr"/>
+          <a:lstStyle/>
+          <a:p>
+            <a:pPr algn="ctr" indent="0" marL="0">
+              <a:buNone/>
+            </a:pPr>
+            <a:r>
+              <a:rPr lang="en-US" sz="1100" b="1" dirty="0">
+                <a:solidFill>
+                  <a:srgbClr val="FFFFFF"/>
                 </a:solidFill>
                 <a:latin typeface="Montserrat" pitchFamily="34" charset="0"/>
                 <a:ea typeface="Montserrat" pitchFamily="34" charset="-122"/>
                 <a:cs typeface="Montserrat" pitchFamily="34" charset="-120"/>
               </a:rPr>
-              <a:t>Less JV soft costs (~10%)</a:t>
-            </a:r>
-            <a:endParaRPr lang="en-US" sz="1000" dirty="0"/>
-          </a:p>
-        </p:txBody>
-      </p:sp>
-      <p:sp>
-        <p:nvSpPr>
-          <p:cNvPr id="77" name="Shape 75"/>
-          <p:cNvSpPr/>
-          <p:nvPr/>
-        </p:nvSpPr>
-        <p:spPr>
-          <a:xfrm>
-            <a:off x="3383280" y="5038344"/>
-            <a:ext cx="3108960" cy="393192"/>
-          </a:xfrm>
-          <a:prstGeom prst="rect">
-            <a:avLst/>
-          </a:prstGeom>
-          <a:solidFill>
-            <a:srgbClr val="F4F2ED"/>
-          </a:solidFill>
-          <a:ln/>
-        </p:spPr>
-      </p:sp>
-      <p:sp>
-        <p:nvSpPr>
-          <p:cNvPr id="78" name="Text 76"/>
-          <p:cNvSpPr/>
-          <p:nvPr/>
-        </p:nvSpPr>
-        <p:spPr>
-          <a:xfrm>
-            <a:off x="3383280" y="5038344"/>
-            <a:ext cx="3108960" cy="393192"/>
-          </a:xfrm>
-          <a:prstGeom prst="rect">
-            <a:avLst/>
-          </a:prstGeom>
-          <a:noFill/>
-          <a:ln/>
-        </p:spPr>
-        <p:txBody>
-          <a:bodyPr wrap="square" lIns="25400" tIns="76200" rIns="76200" bIns="25400" rtlCol="0" anchor="ctr"/>
-          <a:lstStyle/>
-          <a:p>
-            <a:pPr algn="l" indent="0" marL="0">
-              <a:buNone/>
-            </a:pPr>
-            <a:r>
-              <a:rPr lang="en-US" sz="950" dirty="0">
-                <a:solidFill>
-                  <a:srgbClr val="6B5A6B"/>
-                </a:solidFill>
-                <a:latin typeface="DM Sans" pitchFamily="34" charset="0"/>
-                <a:ea typeface="DM Sans" pitchFamily="34" charset="-122"/>
-                <a:cs typeface="DM Sans" pitchFamily="34" charset="-120"/>
-              </a:rPr>
-              <a:t>entitlement · legal · broker</a:t>
-            </a:r>
-            <a:endParaRPr lang="en-US" sz="950" dirty="0"/>
-          </a:p>
-        </p:txBody>
-      </p:sp>
-      <p:sp>
-        <p:nvSpPr>
-          <p:cNvPr id="79" name="Shape 77"/>
-          <p:cNvSpPr/>
-          <p:nvPr/>
-        </p:nvSpPr>
-        <p:spPr>
-          <a:xfrm>
-            <a:off x="6492240" y="5038344"/>
-            <a:ext cx="2651760" cy="393192"/>
-          </a:xfrm>
-          <a:prstGeom prst="rect">
-            <a:avLst/>
-          </a:prstGeom>
-          <a:solidFill>
-            <a:srgbClr val="F4F2ED"/>
-          </a:solidFill>
-          <a:ln/>
-        </p:spPr>
-      </p:sp>
-      <p:sp>
-        <p:nvSpPr>
-          <p:cNvPr id="80" name="Text 78"/>
-          <p:cNvSpPr/>
-          <p:nvPr/>
-        </p:nvSpPr>
-        <p:spPr>
-          <a:xfrm>
-            <a:off x="6492240" y="5038344"/>
-            <a:ext cx="2651760" cy="393192"/>
-          </a:xfrm>
-          <a:prstGeom prst="rect">
-            <a:avLst/>
-          </a:prstGeom>
-          <a:noFill/>
-          <a:ln/>
-        </p:spPr>
-        <p:txBody>
-          <a:bodyPr wrap="square" lIns="25400" tIns="76200" rIns="76200" bIns="25400" rtlCol="0" anchor="ctr"/>
-          <a:lstStyle/>
-          <a:p>
-            <a:pPr algn="l" indent="0" marL="0">
-              <a:buNone/>
-            </a:pPr>
-            <a:r>
-              <a:rPr lang="en-US" sz="900" dirty="0">
-                <a:solidFill>
-                  <a:srgbClr val="6B5A6B"/>
-                </a:solidFill>
-                <a:latin typeface="DM Sans" pitchFamily="34" charset="0"/>
-                <a:ea typeface="DM Sans" pitchFamily="34" charset="-122"/>
-                <a:cs typeface="DM Sans" pitchFamily="34" charset="-120"/>
-              </a:rPr>
-              <a:t>× 0.90</a:t>
-            </a:r>
-            <a:endParaRPr lang="en-US" sz="900" dirty="0"/>
-          </a:p>
-        </p:txBody>
-      </p:sp>
-      <p:sp>
-        <p:nvSpPr>
-          <p:cNvPr id="81" name="Shape 79"/>
-          <p:cNvSpPr/>
-          <p:nvPr/>
-        </p:nvSpPr>
-        <p:spPr>
-          <a:xfrm>
-            <a:off x="9144000" y="5038344"/>
-            <a:ext cx="2587752" cy="393192"/>
-          </a:xfrm>
-          <a:prstGeom prst="rect">
-            <a:avLst/>
-          </a:prstGeom>
-          <a:solidFill>
-            <a:srgbClr val="F4F2ED"/>
-          </a:solidFill>
-          <a:ln/>
-        </p:spPr>
-      </p:sp>
-      <p:sp>
-        <p:nvSpPr>
-          <p:cNvPr id="82" name="Text 80"/>
-          <p:cNvSpPr/>
-          <p:nvPr/>
-        </p:nvSpPr>
-        <p:spPr>
-          <a:xfrm>
-            <a:off x="9144000" y="5038344"/>
-            <a:ext cx="2587752" cy="393192"/>
-          </a:xfrm>
-          <a:prstGeom prst="rect">
-            <a:avLst/>
-          </a:prstGeom>
-          <a:noFill/>
-          <a:ln/>
-        </p:spPr>
-        <p:txBody>
-          <a:bodyPr wrap="square" lIns="25400" tIns="76200" rIns="76200" bIns="25400" rtlCol="0" anchor="ctr"/>
-          <a:lstStyle/>
-          <a:p>
-            <a:pPr algn="r" indent="0" marL="0">
-              <a:buNone/>
-            </a:pPr>
-            <a:r>
-              <a:rPr lang="en-US" sz="1100" b="1" dirty="0">
-                <a:solidFill>
-                  <a:srgbClr val="3A243A"/>
-                </a:solidFill>
-                <a:latin typeface="Montserrat" pitchFamily="34" charset="0"/>
-                <a:ea typeface="Montserrat" pitchFamily="34" charset="-122"/>
-                <a:cs typeface="Montserrat" pitchFamily="34" charset="-120"/>
-              </a:rPr>
-              <a:t>≈ $17M</a:t>
+              <a:t>$42.0M gross finished-lot revenue — we develop and deliver finished lots; builders just build. Net profit &amp; returns on the pro forma.</a:t>
             </a:r>
             <a:endParaRPr lang="en-US" sz="1100" dirty="0"/>
           </a:p>
@@ -25044,66 +24867,7 @@
       </p:sp>
       <p:sp>
         <p:nvSpPr>
-          <p:cNvPr id="83" name="Shape 81"/>
-          <p:cNvSpPr/>
-          <p:nvPr/>
-        </p:nvSpPr>
-        <p:spPr>
-          <a:xfrm>
-            <a:off x="457200" y="5486400"/>
-            <a:ext cx="11274552" cy="411480"/>
-          </a:xfrm>
-          <a:prstGeom prst="rect">
-            <a:avLst/>
-          </a:prstGeom>
-          <a:solidFill>
-            <a:srgbClr val="0B163C"/>
-          </a:solidFill>
-          <a:ln/>
-        </p:spPr>
-      </p:sp>
-      <p:sp>
-        <p:nvSpPr>
-          <p:cNvPr id="84" name="Text 82"/>
-          <p:cNvSpPr/>
-          <p:nvPr/>
-        </p:nvSpPr>
-        <p:spPr>
-          <a:xfrm>
-            <a:off x="640080" y="5486400"/>
-            <a:ext cx="10908792" cy="411480"/>
-          </a:xfrm>
-          <a:prstGeom prst="rect">
-            <a:avLst/>
-          </a:prstGeom>
-          <a:noFill/>
-          <a:ln/>
-        </p:spPr>
-        <p:txBody>
-          <a:bodyPr wrap="square" lIns="0" tIns="0" rIns="0" bIns="0" rtlCol="0" anchor="ctr"/>
-          <a:lstStyle/>
-          <a:p>
-            <a:pPr algn="ctr" indent="0" marL="0">
-              <a:buNone/>
-            </a:pPr>
-            <a:r>
-              <a:rPr lang="en-US" sz="1150" b="1" dirty="0">
-                <a:solidFill>
-                  <a:srgbClr val="FFFFFF"/>
-                </a:solidFill>
-                <a:latin typeface="Montserrat" pitchFamily="34" charset="0"/>
-                <a:ea typeface="Montserrat" pitchFamily="34" charset="-122"/>
-                <a:cs typeface="Montserrat" pitchFamily="34" charset="-120"/>
-              </a:rPr>
-              <a:t>≈ $17M net to the JV — capital-light: the homebuilder funds the horizontal, so only entitlement &amp; soft costs come out.</a:t>
-            </a:r>
-            <a:endParaRPr lang="en-US" sz="1150" dirty="0"/>
-          </a:p>
-        </p:txBody>
-      </p:sp>
-      <p:sp>
-        <p:nvSpPr>
-          <p:cNvPr id="85" name="Text 83"/>
+          <p:cNvPr id="77" name="Text 75"/>
           <p:cNvSpPr/>
           <p:nvPr/>
         </p:nvSpPr>
@@ -28421,7 +28185,7 @@
                 <a:ea typeface="Montserrat" pitchFamily="34" charset="-122"/>
                 <a:cs typeface="Montserrat" pitchFamily="34" charset="-120"/>
               </a:rPr>
-              <a:t>CAPITAL STRATEGY</a:t>
+              <a:t>DEVELOPMENT PLAN</a:t>
             </a:r>
             <a:endParaRPr lang="en-US" sz="1000" dirty="0"/>
           </a:p>
@@ -28460,7 +28224,7 @@
                 <a:ea typeface="Montserrat" pitchFamily="34" charset="-122"/>
                 <a:cs typeface="Montserrat" pitchFamily="34" charset="-120"/>
               </a:rPr>
-              <a:t>Capital-light by design.</a:t>
+              <a:t>Entitle, develop, deliver finished lots.</a:t>
             </a:r>
             <a:endParaRPr lang="en-US" sz="2500" dirty="0"/>
           </a:p>
@@ -28502,7 +28266,7 @@
                 <a:ea typeface="DM Sans" pitchFamily="34" charset="-122"/>
                 <a:cs typeface="DM Sans" pitchFamily="34" charset="-120"/>
               </a:rPr>
-              <a:t>The land bank barely needs capital: soft costs to entitle, then builders fund the horizontal work and buy the lots. Cash in is small; proceeds come fast.</a:t>
+              <a:t>Start light with entitlement (soft costs), then fund the horizontal — roads, sewer and utilities — and deliver finished lots. The builder just builds the homes, so we capture the full lot value.</a:t>
             </a:r>
             <a:endParaRPr lang="en-US" sz="1300" dirty="0"/>
           </a:p>
@@ -28605,7 +28369,7 @@
                 <a:ea typeface="Montserrat" pitchFamily="34" charset="-122"/>
                 <a:cs typeface="Montserrat" pitchFamily="34" charset="-120"/>
               </a:rPr>
-              <a:t>Soft costs to start</a:t>
+              <a:t>To entitle (Phase 1)</a:t>
             </a:r>
             <a:endParaRPr lang="en-US" sz="1200" dirty="0"/>
           </a:p>
@@ -28644,7 +28408,7 @@
                 <a:ea typeface="DM Sans" pitchFamily="34" charset="-122"/>
                 <a:cs typeface="DM Sans" pitchFamily="34" charset="-120"/>
               </a:rPr>
-              <a:t>Entitlements, planning &amp; approvals</a:t>
+              <a:t>Light to start — before the horizontal</a:t>
             </a:r>
             <a:endParaRPr lang="en-US" sz="1000" dirty="0"/>
           </a:p>
@@ -28700,7 +28464,7 @@
               <a:buNone/>
             </a:pPr>
             <a:r>
-              <a:rPr lang="en-US" sz="2700" b="1" dirty="0">
+              <a:rPr lang="en-US" sz="1900" b="1" dirty="0">
                 <a:solidFill>
                   <a:srgbClr val="0B163C"/>
                 </a:solidFill>
@@ -28708,9 +28472,9 @@
                 <a:ea typeface="Montserrat" pitchFamily="34" charset="-122"/>
                 <a:cs typeface="Montserrat" pitchFamily="34" charset="-120"/>
               </a:rPr>
-              <a:t>Land</a:t>
-            </a:r>
-            <a:endParaRPr lang="en-US" sz="2700" dirty="0"/>
+              <a:t>$60K / lot</a:t>
+            </a:r>
+            <a:endParaRPr lang="en-US" sz="1900" dirty="0"/>
           </a:p>
         </p:txBody>
       </p:sp>
@@ -28747,7 +28511,7 @@
                 <a:ea typeface="Montserrat" pitchFamily="34" charset="-122"/>
                 <a:cs typeface="Montserrat" pitchFamily="34" charset="-120"/>
               </a:rPr>
-              <a:t>= the equity</a:t>
+              <a:t>Horizontal we fund</a:t>
             </a:r>
             <a:endParaRPr lang="en-US" sz="1200" dirty="0"/>
           </a:p>
@@ -28786,7 +28550,7 @@
                 <a:ea typeface="DM Sans" pitchFamily="34" charset="-122"/>
                 <a:cs typeface="DM Sans" pitchFamily="34" charset="-120"/>
               </a:rPr>
-              <a:t>Acreage held by Capital H6 — already acquired</a:t>
+              <a:t>Roads, sewer &amp; utilities — lots delivered finished</a:t>
             </a:r>
             <a:endParaRPr lang="en-US" sz="1000" dirty="0"/>
           </a:p>
@@ -28904,7 +28668,7 @@
                 <a:ea typeface="Montserrat" pitchFamily="34" charset="-122"/>
                 <a:cs typeface="Montserrat" pitchFamily="34" charset="-120"/>
               </a:rPr>
-              <a:t>You carry approvals, not construction.</a:t>
+              <a:t>We control and capture the full lot.</a:t>
             </a:r>
             <a:endParaRPr lang="en-US" sz="1300" dirty="0"/>
           </a:p>
@@ -28946,7 +28710,7 @@
                 <a:ea typeface="DM Sans" pitchFamily="34" charset="-122"/>
                 <a:cs typeface="DM Sans" pitchFamily="34" charset="-120"/>
               </a:rPr>
-              <a:t>Builders take the infrastructure burden — sewer, roads, utilities — and pay for finished lots. Your cash at risk stays small and staged.</a:t>
+              <a:t>We fund the roads, sewer and utilities and sell finished lots — capturing the builder's development margin and controlling quality, timing and absorption.</a:t>
             </a:r>
             <a:endParaRPr lang="en-US" sz="1050" dirty="0"/>
           </a:p>
@@ -29123,7 +28887,7 @@
                 <a:ea typeface="Montserrat" pitchFamily="34" charset="-122"/>
                 <a:cs typeface="Montserrat" pitchFamily="34" charset="-120"/>
               </a:rPr>
-              <a:t>Your capital</a:t>
+              <a:t>Capital</a:t>
             </a:r>
             <a:endParaRPr lang="en-US" sz="900" dirty="0"/>
           </a:p>
@@ -29418,7 +29182,7 @@
                 <a:ea typeface="DM Sans" pitchFamily="34" charset="-122"/>
                 <a:cs typeface="DM Sans" pitchFamily="34" charset="-120"/>
               </a:rPr>
-              <a:t>JAL + H6 dev co (skin in the game)</a:t>
+              <a:t>JAL + H6 (soft costs, light)</a:t>
             </a:r>
             <a:endParaRPr lang="en-US" sz="900" dirty="0"/>
           </a:p>
@@ -29477,7 +29241,7 @@
                 <a:ea typeface="Montserrat" pitchFamily="34" charset="-122"/>
                 <a:cs typeface="Montserrat" pitchFamily="34" charset="-120"/>
               </a:rPr>
-              <a:t>Phase 2 — Builder takedown</a:t>
+              <a:t>Phase 2 — Develop</a:t>
             </a:r>
             <a:endParaRPr lang="en-US" sz="1000" dirty="0"/>
           </a:p>
@@ -29536,7 +29300,7 @@
                 <a:ea typeface="DM Sans" pitchFamily="34" charset="-122"/>
                 <a:cs typeface="DM Sans" pitchFamily="34" charset="-120"/>
               </a:rPr>
-              <a:t>Horizontal + lot purchase</a:t>
+              <a:t>Roads, sewer &amp; utilities</a:t>
             </a:r>
             <a:endParaRPr lang="en-US" sz="950" dirty="0"/>
           </a:p>
@@ -29595,7 +29359,7 @@
                 <a:ea typeface="Montserrat" pitchFamily="34" charset="-122"/>
                 <a:cs typeface="Montserrat" pitchFamily="34" charset="-120"/>
               </a:rPr>
-              <a:t>~$0 to you</a:t>
+              <a:t>~$16.8M</a:t>
             </a:r>
             <a:endParaRPr lang="en-US" sz="1000" dirty="0"/>
           </a:p>
@@ -29654,7 +29418,7 @@
                 <a:ea typeface="DM Sans" pitchFamily="34" charset="-122"/>
                 <a:cs typeface="DM Sans" pitchFamily="34" charset="-120"/>
               </a:rPr>
-              <a:t>Regional homebuilder funds &amp; buys</a:t>
+              <a:t>Development loan + equity (we fund)</a:t>
             </a:r>
             <a:endParaRPr lang="en-US" sz="900" dirty="0"/>
           </a:p>
@@ -29713,7 +29477,7 @@
                 <a:ea typeface="Montserrat" pitchFamily="34" charset="-122"/>
                 <a:cs typeface="Montserrat" pitchFamily="34" charset="-120"/>
               </a:rPr>
-              <a:t>Phase 3 — Recycle</a:t>
+              <a:t>Phase 3 — Deliver</a:t>
             </a:r>
             <a:endParaRPr lang="en-US" sz="1000" dirty="0"/>
           </a:p>
@@ -29772,7 +29536,7 @@
                 <a:ea typeface="DM Sans" pitchFamily="34" charset="-122"/>
                 <a:cs typeface="DM Sans" pitchFamily="34" charset="-120"/>
               </a:rPr>
-              <a:t>Proceeds redeployed</a:t>
+              <a:t>Sell finished lots</a:t>
             </a:r>
             <a:endParaRPr lang="en-US" sz="950" dirty="0"/>
           </a:p>
@@ -29890,7 +29654,7 @@
                 <a:ea typeface="DM Sans" pitchFamily="34" charset="-122"/>
                 <a:cs typeface="DM Sans" pitchFamily="34" charset="-120"/>
               </a:rPr>
-              <a:t>Next parcel / South River / H6 program</a:t>
+              <a:t>Builders build homes; proceeds recycle</a:t>
             </a:r>
             <a:endParaRPr lang="en-US" sz="900" dirty="0"/>
           </a:p>
@@ -29949,7 +29713,7 @@
                 <a:ea typeface="DM Sans" pitchFamily="34" charset="-122"/>
                 <a:cs typeface="DM Sans" pitchFamily="34" charset="-120"/>
               </a:rPr>
-              <a:t>Minimal capital at risk — and the land bank seeds everything that comes after.</a:t>
+              <a:t>We carry the development to finished lots — capturing the builder's margin and controlling quality, timing &amp; absorption.</a:t>
             </a:r>
             <a:endParaRPr lang="en-US" sz="1100" dirty="0"/>
           </a:p>

</xml_diff>

<commit_message>
Push Phase 1 to ~32% (levered) and add Phase 2 build-to-core ~28%
Model (source of truth):
- Phase 1: add levered equity return — ~60% LTC dev loan, phased lot
  sales -> ~32% levered equity IRR (vs ~24% unlevered). Clears the 30% bar.
- Phase 2: add BUILD-TO-CORE case — premium NOI (VIVAMEE), 7.5% exit cap,
  65% LTC, recap/sell at stabilization (~Yr 4) -> ~27.6% IRR / ~2.28x EM
  (vs ~12% hold). Captures the development spread from the contributed land.

Deck: slide 10 returns -> ~32% levered equity IRR; slide 13 (Phase 2) ->
build-to-core (~.7M premium NOI, ~2M @ 7.5% cap, ~2.3x / ~28%), with
the income-hold ~12% noted as the floor. README updated.
</commit_message>
<xml_diff>
--- a/JAL_Queenstown_Harbor_Proposal.pptx
+++ b/JAL_Queenstown_Harbor_Proposal.pptx
@@ -608,7 +608,7 @@
           <a:p>
             <a:r>
               <a:rPr lang="en-US" dirty="0"/>
-              <a:t>Finished-lot development pro forma, consistent with slide 6. $42.0M revenue − $27.5M cost ≈ $14.5M profit. Funded ~60% by a development loan; equity ~$11M (land $4M + cash $7M) → ~2.3x / ~24% project IRR (phased); LP ~20% after an 8% pref + JAL co-GP promote. We capture the builder's margin but take horizontal risk. All illustrative.</a:t>
+              <a:t>Finished-lot development pro forma, consistent with slide 6. $42.0M revenue − $27.5M cost ≈ $14.5M profit. Funded ~60% by a development loan; equity ~$11M (land $4M + cash $7M) → ~2.3x equity, ~32% levered equity IRR (~24% unlevered); LP ~24% after an 8% pref + JAL co-GP promote. Leverage + phased lot sales drive the equity IRR past 30%. All illustrative.</a:t>
             </a:r>
             <a:endParaRPr lang="en-US" dirty="0"/>
           </a:p>
@@ -872,7 +872,7 @@
           <a:p>
             <a:r>
               <a:rPr lang="en-US" dirty="0"/>
-              <a:t>Phase 2 is the hospitality upside — VIVÂMEE-led (their wheelhouse), JAL as capital partner. Income / hold play: develops to ~cost, so the return is durable cash flow + appreciation (~8% yield on cost, ~1.9x / ~12% IRR over 7 yr) — lower IRR than the Phase 1 land but bigger, recurring, and it lifts lot values. Numbers are the model's source of truth.</a:t>
+              <a:t>Phase 2 = hospitality upside, VIVÂMEE-led, JAL as capital partner. Two cases in the model: hold for income (~8% YoC, ~12% IRR — the floor) or BUILD-TO-CORE — recap/sell at stabilization (~Yr 4) at a 7.5% cap, capturing the development spread from the contributed land + premium NOI → ~28% IRR / ~2.3x. Build-to-core lets JAL earn the development return while VIVÂMEE keeps and operates the resort. Model is source of truth.</a:t>
             </a:r>
             <a:endParaRPr lang="en-US" dirty="0"/>
           </a:p>
@@ -5257,7 +5257,7 @@
                 <a:ea typeface="Montserrat" pitchFamily="34" charset="-122"/>
                 <a:cs typeface="Montserrat" pitchFamily="34" charset="-120"/>
               </a:rPr>
-              <a:t>~24%</a:t>
+              <a:t>~32%</a:t>
             </a:r>
             <a:endParaRPr lang="en-US" sz="1700" dirty="0"/>
           </a:p>
@@ -5296,7 +5296,7 @@
                 <a:ea typeface="DM Sans" pitchFamily="34" charset="-122"/>
                 <a:cs typeface="DM Sans" pitchFamily="34" charset="-120"/>
               </a:rPr>
-              <a:t>Project IRR (phased)</a:t>
+              <a:t>Equity IRR (levered)</a:t>
             </a:r>
             <a:endParaRPr lang="en-US" sz="850" dirty="0"/>
           </a:p>
@@ -5335,7 +5335,7 @@
                 <a:ea typeface="Montserrat" pitchFamily="34" charset="-122"/>
                 <a:cs typeface="Montserrat" pitchFamily="34" charset="-120"/>
               </a:rPr>
-              <a:t>~20%</a:t>
+              <a:t>~24%</a:t>
             </a:r>
             <a:endParaRPr lang="en-US" sz="1700" dirty="0"/>
           </a:p>
@@ -5433,7 +5433,7 @@
                 <a:ea typeface="DM Sans" pitchFamily="34" charset="-122"/>
                 <a:cs typeface="DM Sans" pitchFamily="34" charset="-120"/>
               </a:rPr>
-              <a:t>Illustrative: ~$14.5M profit on ~$27.5M cost — ~2.3× equity, ~24% project IRR. We deliver finished lots; builders just build.</a:t>
+              <a:t>Illustrative: ~$14.5M profit on ~$27.5M cost — ~2.3× equity, ~32% levered IRR (24% unlevered). We deliver finished lots; builders just build.</a:t>
             </a:r>
             <a:endParaRPr lang="en-US" sz="1050" dirty="0"/>
           </a:p>
@@ -9959,7 +9959,7 @@
                 <a:ea typeface="DM Sans" pitchFamily="34" charset="-122"/>
                 <a:cs typeface="DM Sans" pitchFamily="34" charset="-120"/>
               </a:rPr>
-              <a:t>VIVÂMEE-led resort; JAL as capital partner. An income / hold play — durable cash flow and a stabilized-value exit (lower IRR than the land, longer hold). The Phase 1 lots help fund and de-risk it; the resort lifts lot values.</a:t>
+              <a:t>VIVÂMEE-led resort; JAL as capital partner. Held for income it yields ~8% / ~12% IRR — to clear a mid-to-high-20s return, build to core: the contributed land + VIVÂMEE's premium NOI create a development spread, captured by recapitalizing at stabilization (~Yr 4).</a:t>
             </a:r>
             <a:endParaRPr lang="en-US" sz="1300" dirty="0"/>
           </a:p>
@@ -10940,7 +10940,7 @@
                 <a:ea typeface="Montserrat" pitchFamily="34" charset="-122"/>
                 <a:cs typeface="Montserrat" pitchFamily="34" charset="-120"/>
               </a:rPr>
-              <a:t>$2.8M</a:t>
+              <a:t>$3.4M</a:t>
             </a:r>
             <a:endParaRPr lang="en-US" sz="900" dirty="0"/>
           </a:p>
@@ -10999,7 +10999,7 @@
                 <a:ea typeface="DM Sans" pitchFamily="34" charset="-122"/>
                 <a:cs typeface="DM Sans" pitchFamily="34" charset="-120"/>
               </a:rPr>
-              <a:t>8.6%</a:t>
+              <a:t>10%</a:t>
             </a:r>
             <a:endParaRPr lang="en-US" sz="800" dirty="0"/>
           </a:p>
@@ -11117,7 +11117,7 @@
                 <a:ea typeface="Montserrat" pitchFamily="34" charset="-122"/>
                 <a:cs typeface="Montserrat" pitchFamily="34" charset="-120"/>
               </a:rPr>
-              <a:t>$1.0M</a:t>
+              <a:t>$1.2M</a:t>
             </a:r>
             <a:endParaRPr lang="en-US" sz="900" dirty="0"/>
           </a:p>
@@ -11176,7 +11176,7 @@
                 <a:ea typeface="DM Sans" pitchFamily="34" charset="-122"/>
                 <a:cs typeface="DM Sans" pitchFamily="34" charset="-120"/>
               </a:rPr>
-              <a:t>11%</a:t>
+              <a:t>14%</a:t>
             </a:r>
             <a:endParaRPr lang="en-US" sz="800" dirty="0"/>
           </a:p>
@@ -11294,7 +11294,7 @@
                 <a:ea typeface="Montserrat" pitchFamily="34" charset="-122"/>
                 <a:cs typeface="Montserrat" pitchFamily="34" charset="-120"/>
               </a:rPr>
-              <a:t>$3.8M</a:t>
+              <a:t>$4.7M</a:t>
             </a:r>
             <a:endParaRPr lang="en-US" sz="900" dirty="0"/>
           </a:p>
@@ -11353,7 +11353,7 @@
                 <a:ea typeface="DM Sans" pitchFamily="34" charset="-122"/>
                 <a:cs typeface="DM Sans" pitchFamily="34" charset="-120"/>
               </a:rPr>
-              <a:t>8.1%</a:t>
+              <a:t>9.9%</a:t>
             </a:r>
             <a:endParaRPr lang="en-US" sz="800" dirty="0"/>
           </a:p>
@@ -11474,7 +11474,7 @@
                 <a:ea typeface="DM Sans" pitchFamily="34" charset="-122"/>
                 <a:cs typeface="DM Sans" pitchFamily="34" charset="-120"/>
               </a:rPr>
-              <a:t>Yield on cost 8.1%  ·  cash-on-cash ~9.8%  ·  exit ~$54M @ 8% cap  ·  ~60% LTC  ·  VIVÂMEE operates, JAL = capital</a:t>
+              <a:t>Build-to-core: recap / sell ~Yr 4  ·  7.5% exit cap → ~$62M  ·  65% LTC  ·  premium NOI (VIVÂMEE)  ·  ~2.4-pt development spread  ·  land contributed</a:t>
             </a:r>
             <a:endParaRPr lang="en-US" sz="850" dirty="0"/>
           </a:p>
@@ -11670,7 +11670,7 @@
                 <a:ea typeface="Montserrat" pitchFamily="34" charset="-122"/>
                 <a:cs typeface="Montserrat" pitchFamily="34" charset="-120"/>
               </a:rPr>
-              <a:t>$3.8M</a:t>
+              <a:t>$4.7M</a:t>
             </a:r>
             <a:endParaRPr lang="en-US" sz="1700" dirty="0"/>
           </a:p>
@@ -11709,7 +11709,7 @@
                 <a:ea typeface="DM Sans" pitchFamily="34" charset="-122"/>
                 <a:cs typeface="DM Sans" pitchFamily="34" charset="-120"/>
               </a:rPr>
-              <a:t>Stabilized NOI</a:t>
+              <a:t>Stabilized NOI (premium)</a:t>
             </a:r>
             <a:endParaRPr lang="en-US" sz="850" dirty="0"/>
           </a:p>
@@ -11748,7 +11748,7 @@
                 <a:ea typeface="Montserrat" pitchFamily="34" charset="-122"/>
                 <a:cs typeface="Montserrat" pitchFamily="34" charset="-120"/>
               </a:rPr>
-              <a:t>8.1%</a:t>
+              <a:t>9.9%</a:t>
             </a:r>
             <a:endParaRPr lang="en-US" sz="1700" dirty="0"/>
           </a:p>
@@ -11826,7 +11826,7 @@
                 <a:ea typeface="Montserrat" pitchFamily="34" charset="-122"/>
                 <a:cs typeface="Montserrat" pitchFamily="34" charset="-120"/>
               </a:rPr>
-              <a:t>~1.9×</a:t>
+              <a:t>~2.3×</a:t>
             </a:r>
             <a:endParaRPr lang="en-US" sz="1700" dirty="0"/>
           </a:p>
@@ -11865,7 +11865,7 @@
                 <a:ea typeface="DM Sans" pitchFamily="34" charset="-122"/>
                 <a:cs typeface="DM Sans" pitchFamily="34" charset="-120"/>
               </a:rPr>
-              <a:t>Equity multiple (7-yr)</a:t>
+              <a:t>Equity multiple (~4-yr)</a:t>
             </a:r>
             <a:endParaRPr lang="en-US" sz="850" dirty="0"/>
           </a:p>
@@ -11904,7 +11904,7 @@
                 <a:ea typeface="Montserrat" pitchFamily="34" charset="-122"/>
                 <a:cs typeface="Montserrat" pitchFamily="34" charset="-120"/>
               </a:rPr>
-              <a:t>~12%</a:t>
+              <a:t>~28%</a:t>
             </a:r>
             <a:endParaRPr lang="en-US" sz="1700" dirty="0"/>
           </a:p>
@@ -11943,7 +11943,7 @@
                 <a:ea typeface="DM Sans" pitchFamily="34" charset="-122"/>
                 <a:cs typeface="DM Sans" pitchFamily="34" charset="-120"/>
               </a:rPr>
-              <a:t>Project IRR (7-yr)</a:t>
+              <a:t>Build-to-core IRR</a:t>
             </a:r>
             <a:endParaRPr lang="en-US" sz="850" dirty="0"/>
           </a:p>
@@ -12002,7 +12002,7 @@
                 <a:ea typeface="DM Sans" pitchFamily="34" charset="-122"/>
                 <a:cs typeface="DM Sans" pitchFamily="34" charset="-120"/>
               </a:rPr>
-              <a:t>Illustrative: ~$47M resort at ~8.1% yield on cost — ~1.9× / ~12% IRR over a 7-yr hold. VIVÂMEE operates; JAL brings the capital.</a:t>
+              <a:t>Built to core (recap at stabilization), the hotel clears ~28% IRR / ~2.3×. Held for income it's ~12% — the spread is the contributed land + VIVÂMEE's premium NOI.</a:t>
             </a:r>
             <a:endParaRPr lang="en-US" sz="1050" dirty="0"/>
           </a:p>

</xml_diff>

<commit_message>
Soft-reference JAL capital commitment into the GP; remove named lender
- Structure slide: JAL is a GP member and intends to invest in the GP,
  amount sized in diligence and final structure (soft reference, TBD)
- Capital access: remove the named national-debt lender; keep the
  network framing (national bank platforms + specialty construction lenders)

https://claude.ai/code/session_01BHWC2bwKRSfRRWtpGYSNwZ
</commit_message>
<xml_diff>
--- a/JAL_Queenstown_Harbor_Proposal.pptx
+++ b/JAL_Queenstown_Harbor_Proposal.pptx
@@ -1581,7 +1581,7 @@
           <a:p>
             <a:r>
               <a:rPr lang="en-US" dirty="0"/>
-              <a:t>Nails Bob's exact role: H6 GP / development lead. H6 contributes the developable land; JAL runs entitlement + capital formation + lot sales. VIVÂMEE keeps operating the resort.</a:t>
+              <a:t>Nails Bob's exact role: H6 GP / development lead. H6 contributes the developable land; JAL runs entitlement + capital formation + lot sales. VIVÂMEE keeps operating the resort. I also intend to put capital into the GP — amount TBD, to be sized once we've done diligence and set the structure.</a:t>
             </a:r>
             <a:endParaRPr lang="en-US" dirty="0"/>
           </a:p>
@@ -24469,7 +24469,7 @@
                 <a:ea typeface="DM Sans" pitchFamily="34" charset="-122"/>
                 <a:cs typeface="DM Sans" pitchFamily="34" charset="-120"/>
               </a:rPr>
-              <a:t>National debt — Goldman Sachs (met two weeks ago; national platform, Dallas team) + specialty lenders.</a:t>
+              <a:t>National debt — relationships across national bank platforms and specialty construction lenders.</a:t>
             </a:r>
             <a:endParaRPr lang="en-US" sz="1000" dirty="0"/>
           </a:p>
@@ -27239,7 +27239,7 @@
                 <a:ea typeface="DM Sans" pitchFamily="34" charset="-122"/>
                 <a:cs typeface="DM Sans" pitchFamily="34" charset="-120"/>
               </a:rPr>
-              <a:t>JAL is a GP member — sharing the promote alongside Capital H6 and Bob, not just advising.</a:t>
+              <a:t>JAL is a GP member — sharing the promote with Capital H6 and Bob, and intends to invest in the GP, sized in diligence and structure.</a:t>
             </a:r>
             <a:endParaRPr lang="en-US" sz="1100" dirty="0"/>
           </a:p>

</xml_diff>

<commit_message>
Tie Phase 2 deck to the model; add Accountable Equity to the GP; comp edits
- Phase 2 (slide 15) now ties to the model: the NOI table shows the
  STABILIZED (base) NOI $3.8M / 8.1% YoC; the $4.7M premium NOI is labeled
  build-to-core (it drives the ~28% IRR). Model remains the source of truth.
- Name Accountable Equity as part of the GP throughout (waterfall, structure,
  engagement, model GP note)
- Capital Access (p19): headline reads "Mid-high 20s" development IRR
- Engagement (p21): equity placement fee = 2% of equity raised (was 3%);
  add that JAL intends to contribute capital to the GP (amount TBD in diligence)
- README updated to match

https://claude.ai/code/session_01BHWC2bwKRSfRRWtpGYSNwZ
</commit_message>
<xml_diff>
--- a/JAL_Queenstown_Harbor_Proposal.pptx
+++ b/JAL_Queenstown_Harbor_Proposal.pptx
@@ -789,7 +789,7 @@
           <a:p>
             <a:r>
               <a:rPr lang="en-US" dirty="0"/>
-              <a:t>Shows how the LP IRR is derived. Project equity IRR (60% LTC) ~31%; through an 8% pref + tiered promote (80/20 to a 15% IRR, 70/30 to 20%, 60/40 above), the LP nets ~27% and the GP group (Capital H6, Bob, JAL + partners) earns ~59% IRR / ~$4.1M carry on a small co-invest — JAL is one member with a share of the promote. Sensitized next. Model = source of truth.</a:t>
+              <a:t>Shows how the LP IRR is derived. Project equity IRR (60% LTC) ~31%; through an 8% pref + tiered promote (80/20 to a 15% IRR, 70/30 to 20%, 60/40 above), the LP nets ~27% and the GP group (Accountable Equity / Capital H6, Bob, JAL + partners) earns ~59% IRR / ~$4.1M carry on a small co-invest — JAL is one member with a share of the promote. Sensitized next. Model = source of truth.</a:t>
             </a:r>
             <a:endParaRPr lang="en-US" dirty="0"/>
           </a:p>
@@ -8395,7 +8395,7 @@
                 <a:ea typeface="DM Sans" pitchFamily="34" charset="-122"/>
                 <a:cs typeface="DM Sans" pitchFamily="34" charset="-120"/>
               </a:rPr>
-              <a:t>A market structure: 8% preferred return, then a tiered promote. At 60% LTC the LP (90% of equity) nets ~27% after the promote; reaching the 30%+ range takes higher leverage or pricing (see the sensitivity). The GP — Capital H6, Bob &amp; JAL + partners — earns the carry; JAL shares in it.</a:t>
+              <a:t>A market structure: 8% preferred return, then a tiered promote. At 60% LTC the LP (90% of equity) nets ~27% after the promote; reaching the 30%+ range takes higher leverage or pricing (see the sensitivity). The GP — Accountable Equity / Capital H6, Bob &amp; JAL + partners — earns the carry; JAL shares in it.</a:t>
             </a:r>
             <a:endParaRPr lang="en-US" sz="1300" dirty="0"/>
           </a:p>
@@ -9118,7 +9118,7 @@
                 <a:ea typeface="DM Sans" pitchFamily="34" charset="-122"/>
                 <a:cs typeface="DM Sans" pitchFamily="34" charset="-120"/>
               </a:rPr>
-              <a:t>$27.5M cost  =  $16.5M development loan (60%)  +  $11M equity.  Equity: LP 90% ($9.9M)  ·  GP — H6 · Bob · JAL + partners 10% ($1.1M).</a:t>
+              <a:t>$27.5M cost  =  $16.5M development loan (60%)  +  $11M equity.  Equity: LP 90% ($9.9M)  ·  GP — Accountable Equity · Bob · JAL + partners 10% ($1.1M).</a:t>
             </a:r>
             <a:endParaRPr lang="en-US" sz="1000" dirty="0"/>
           </a:p>
@@ -9420,7 +9420,7 @@
         <p:spPr>
           <a:xfrm>
             <a:off x="6492240" y="4041648"/>
-            <a:ext cx="5120640" cy="274320"/>
+            <a:ext cx="5212080" cy="274320"/>
           </a:xfrm>
           <a:prstGeom prst="rect">
             <a:avLst/>
@@ -9436,7 +9436,7 @@
               <a:buNone/>
             </a:pPr>
             <a:r>
-              <a:rPr lang="en-US" sz="950" b="1" spc="100" kern="0" dirty="0">
+              <a:rPr lang="en-US" sz="900" b="1" spc="50" kern="0" dirty="0">
                 <a:solidFill>
                   <a:srgbClr val="3A243A"/>
                 </a:solidFill>
@@ -9444,9 +9444,9 @@
                 <a:ea typeface="Montserrat" pitchFamily="34" charset="-122"/>
                 <a:cs typeface="Montserrat" pitchFamily="34" charset="-120"/>
               </a:rPr>
-              <a:t>GP — SPONSOR GROUP  (Capital H6 · Bob · JAL + partners)</a:t>
-            </a:r>
-            <a:endParaRPr lang="en-US" sz="950" dirty="0"/>
+              <a:t>GP — SPONSOR GROUP  (Accountable Equity · Bob · JAL + partners)</a:t>
+            </a:r>
+            <a:endParaRPr lang="en-US" sz="900" dirty="0"/>
           </a:p>
         </p:txBody>
       </p:sp>
@@ -9663,7 +9663,7 @@
                 <a:ea typeface="DM Sans" pitchFamily="34" charset="-122"/>
                 <a:cs typeface="DM Sans" pitchFamily="34" charset="-120"/>
               </a:rPr>
-              <a:t>Market 8% pref + tiered promote → the LP nets ~27% at 60% LTC; the GP (H6 · Bob · JAL + partners) earns ~$4.1M of carry — JAL takes a share.</a:t>
+              <a:t>Market 8% pref + tiered promote → the LP nets ~27% at 60% LTC; the GP (Accountable Equity · Bob · JAL + partners) earns ~$4.1M of carry — JAL takes a share.</a:t>
             </a:r>
             <a:endParaRPr lang="en-US" sz="1100" dirty="0"/>
           </a:p>
@@ -14627,7 +14627,7 @@
                 <a:ea typeface="Montserrat" pitchFamily="34" charset="-122"/>
                 <a:cs typeface="Montserrat" pitchFamily="34" charset="-120"/>
               </a:rPr>
-              <a:t>$3.4M</a:t>
+              <a:t>$2.8M</a:t>
             </a:r>
             <a:endParaRPr lang="en-US" sz="900" dirty="0"/>
           </a:p>
@@ -14686,7 +14686,7 @@
                 <a:ea typeface="DM Sans" pitchFamily="34" charset="-122"/>
                 <a:cs typeface="DM Sans" pitchFamily="34" charset="-120"/>
               </a:rPr>
-              <a:t>10%</a:t>
+              <a:t>8.6%</a:t>
             </a:r>
             <a:endParaRPr lang="en-US" sz="800" dirty="0"/>
           </a:p>
@@ -14804,7 +14804,7 @@
                 <a:ea typeface="Montserrat" pitchFamily="34" charset="-122"/>
                 <a:cs typeface="Montserrat" pitchFamily="34" charset="-120"/>
               </a:rPr>
-              <a:t>$1.2M</a:t>
+              <a:t>$1.0M</a:t>
             </a:r>
             <a:endParaRPr lang="en-US" sz="900" dirty="0"/>
           </a:p>
@@ -14863,7 +14863,7 @@
                 <a:ea typeface="DM Sans" pitchFamily="34" charset="-122"/>
                 <a:cs typeface="DM Sans" pitchFamily="34" charset="-120"/>
               </a:rPr>
-              <a:t>14%</a:t>
+              <a:t>11.5%</a:t>
             </a:r>
             <a:endParaRPr lang="en-US" sz="800" dirty="0"/>
           </a:p>
@@ -14981,7 +14981,7 @@
                 <a:ea typeface="Montserrat" pitchFamily="34" charset="-122"/>
                 <a:cs typeface="Montserrat" pitchFamily="34" charset="-120"/>
               </a:rPr>
-              <a:t>$4.7M</a:t>
+              <a:t>$3.8M</a:t>
             </a:r>
             <a:endParaRPr lang="en-US" sz="900" dirty="0"/>
           </a:p>
@@ -15040,7 +15040,7 @@
                 <a:ea typeface="DM Sans" pitchFamily="34" charset="-122"/>
                 <a:cs typeface="DM Sans" pitchFamily="34" charset="-120"/>
               </a:rPr>
-              <a:t>9.9%</a:t>
+              <a:t>8.1%</a:t>
             </a:r>
             <a:endParaRPr lang="en-US" sz="800" dirty="0"/>
           </a:p>
@@ -15396,7 +15396,7 @@
                 <a:ea typeface="DM Sans" pitchFamily="34" charset="-122"/>
                 <a:cs typeface="DM Sans" pitchFamily="34" charset="-120"/>
               </a:rPr>
-              <a:t>Stabilized NOI (premium)</a:t>
+              <a:t>Premium NOI (build-to-core)</a:t>
             </a:r>
             <a:endParaRPr lang="en-US" sz="850" dirty="0"/>
           </a:p>
@@ -15474,7 +15474,7 @@
                 <a:ea typeface="DM Sans" pitchFamily="34" charset="-122"/>
                 <a:cs typeface="DM Sans" pitchFamily="34" charset="-120"/>
               </a:rPr>
-              <a:t>Yield on cost</a:t>
+              <a:t>Yield on cost (premium)</a:t>
             </a:r>
             <a:endParaRPr lang="en-US" sz="850" dirty="0"/>
           </a:p>
@@ -23994,7 +23994,7 @@
               <a:buNone/>
             </a:pPr>
             <a:r>
-              <a:rPr lang="en-US" sz="2200" b="1" dirty="0">
+              <a:rPr lang="en-US" sz="1900" b="1" dirty="0">
                 <a:solidFill>
                   <a:srgbClr val="0B163C"/>
                 </a:solidFill>
@@ -24002,9 +24002,9 @@
                 <a:ea typeface="Montserrat" pitchFamily="34" charset="-122"/>
                 <a:cs typeface="Montserrat" pitchFamily="34" charset="-120"/>
               </a:rPr>
-              <a:t>Mid-20s%</a:t>
-            </a:r>
-            <a:endParaRPr lang="en-US" sz="2200" dirty="0"/>
+              <a:t>Mid–high 20s</a:t>
+            </a:r>
+            <a:endParaRPr lang="en-US" sz="1900" dirty="0"/>
           </a:p>
         </p:txBody>
       </p:sp>
@@ -26159,7 +26159,7 @@
                 <a:ea typeface="DM Sans" pitchFamily="34" charset="-122"/>
                 <a:cs typeface="DM Sans" pitchFamily="34" charset="-120"/>
               </a:rPr>
-              <a:t>Capital H6 owns the land. Spin the developable parcels into a land-development entity — H6 contributes the acreage as equity; JAL runs entitlement, capital formation and lot sales alongside your team.</a:t>
+              <a:t>Accountable Equity's Capital H6 owns the land. Spin the developable parcels into a land-development entity — H6 contributes the acreage as equity; JAL runs entitlement, capital formation and lot sales alongside your team.</a:t>
             </a:r>
             <a:endParaRPr lang="en-US" sz="1300" dirty="0"/>
           </a:p>
@@ -27057,7 +27057,7 @@
                 <a:ea typeface="Montserrat" pitchFamily="34" charset="-122"/>
                 <a:cs typeface="Montserrat" pitchFamily="34" charset="-120"/>
               </a:rPr>
-              <a:t>Bob Connell / Capital H6</a:t>
+              <a:t>Bob Connell / Accountable Equity</a:t>
             </a:r>
             <a:endParaRPr lang="en-US" sz="1050" dirty="0"/>
           </a:p>
@@ -27099,7 +27099,7 @@
                 <a:ea typeface="DM Sans" pitchFamily="34" charset="-122"/>
                 <a:cs typeface="DM Sans" pitchFamily="34" charset="-120"/>
               </a:rPr>
-              <a:t>Development lead (H6 GP)</a:t>
+              <a:t>Development lead · Capital H6 GP</a:t>
             </a:r>
             <a:endParaRPr lang="en-US" sz="950" dirty="0"/>
           </a:p>
@@ -27239,7 +27239,7 @@
                 <a:ea typeface="DM Sans" pitchFamily="34" charset="-122"/>
                 <a:cs typeface="DM Sans" pitchFamily="34" charset="-120"/>
               </a:rPr>
-              <a:t>JAL is a GP member — sharing the promote with Capital H6 and Bob, and intends to invest in the GP, sized in diligence and structure.</a:t>
+              <a:t>JAL is a GP member — sharing the promote with Accountable Equity, Bob &amp; partners, and intends to invest in the GP, sized in diligence and structure.</a:t>
             </a:r>
             <a:endParaRPr lang="en-US" sz="1100" dirty="0"/>
           </a:p>
@@ -27719,20 +27719,23 @@
         </p:nvSpPr>
         <p:spPr>
           <a:xfrm>
-            <a:off x="3291840" y="2249424"/>
-            <a:ext cx="5349240" cy="320040"/>
-          </a:xfrm>
-          <a:prstGeom prst="rect">
-            <a:avLst/>
-          </a:prstGeom>
-          <a:noFill/>
-          <a:ln/>
-        </p:spPr>
-        <p:txBody>
-          <a:bodyPr wrap="square" lIns="0" tIns="0" rIns="0" bIns="0" rtlCol="0" anchor="ctr"/>
-          <a:lstStyle/>
-          <a:p>
-            <a:pPr algn="l" indent="0" marL="0">
+            <a:off x="3291840" y="2231136"/>
+            <a:ext cx="5349240" cy="384048"/>
+          </a:xfrm>
+          <a:prstGeom prst="rect">
+            <a:avLst/>
+          </a:prstGeom>
+          <a:noFill/>
+          <a:ln/>
+        </p:spPr>
+        <p:txBody>
+          <a:bodyPr wrap="square" lIns="0" tIns="0" rIns="0" bIns="0" rtlCol="0" anchor="t"/>
+          <a:lstStyle/>
+          <a:p>
+            <a:pPr algn="l" indent="0" marL="0">
+              <a:lnSpc>
+                <a:spcPts val="1200"/>
+              </a:lnSpc>
               <a:buNone/>
             </a:pPr>
             <a:r>
@@ -27744,7 +27747,7 @@
                 <a:ea typeface="DM Sans" pitchFamily="34" charset="-122"/>
                 <a:cs typeface="DM Sans" pitchFamily="34" charset="-120"/>
               </a:rPr>
-              <a:t>Aligned to lot-sale value created — not a flat consulting check.</a:t>
+              <a:t>Aligned to value created — and I intend to contribute capital to the GP myself (amount sized in diligence).</a:t>
             </a:r>
             <a:endParaRPr lang="en-US" sz="1000" dirty="0"/>
           </a:p>
@@ -28461,7 +28464,7 @@
                 <a:ea typeface="Montserrat" pitchFamily="34" charset="-122"/>
                 <a:cs typeface="Montserrat" pitchFamily="34" charset="-120"/>
               </a:rPr>
-              <a:t>1% debt · 3% equity</a:t>
+              <a:t>1% debt · 2% equity</a:t>
             </a:r>
             <a:endParaRPr lang="en-US" sz="1100" dirty="0"/>
           </a:p>
@@ -28523,7 +28526,7 @@
                 <a:ea typeface="DM Sans" pitchFamily="34" charset="-122"/>
                 <a:cs typeface="DM Sans" pitchFamily="34" charset="-120"/>
               </a:rPr>
-              <a:t>Success fee if and when we place debt or equity for a parcel</a:t>
+              <a:t>Success fee — 2% of equity raised (1% of debt placed) for a parcel</a:t>
             </a:r>
             <a:endParaRPr lang="en-US" sz="950" dirty="0"/>
           </a:p>
@@ -28703,7 +28706,7 @@
                 <a:ea typeface="DM Sans" pitchFamily="34" charset="-122"/>
                 <a:cs typeface="DM Sans" pitchFamily="34" charset="-120"/>
               </a:rPr>
-              <a:t>JAL's share of the GP promote (alongside H6, Bob &amp; partners)</a:t>
+              <a:t>JAL's share of the GP promote (alongside Accountable Equity, Bob &amp; partners)</a:t>
             </a:r>
             <a:endParaRPr lang="en-US" sz="950" dirty="0"/>
           </a:p>

</xml_diff>

<commit_message>
Make Phase 2 cash-flow slide tie to the model (build-to-core equity view)
Slide 18 showed an unlevered PROJECT cash flow (dev cost $15/$20/$12M, net
$26.3M) but quoted the LEVERED IRR (~28%) — you couldn't derive 28% from the
rows shown, and those rows weren't in the model.

Rebuild slide 18 as the build-to-core LEVERED EQUITY cash flow, which ties
cell-for-cell to the model's build-to-core section:
- Equity invested $16.4M (bcEq, split Yr 0–1)
- Operating cash flow after debt ~$2.5M (bcStabLevCF; Yr 2 ramps ~40%)
- Recap equity $31.5M (bcXEq = $62M recap − loan)
- Net equity CF [-8.2, -8.2, 1.0, 2.5, 34.0] (bcf) → ~28% IRR / ~2.3x
The project economics (~$47M cost → ~$62M recap @ 7.5% cap) stay in the
description + callout. README updated.

https://claude.ai/code/session_01BHWC2bwKRSfRRWtpGYSNwZ
</commit_message>
<xml_diff>
--- a/JAL_Queenstown_Harbor_Proposal.pptx
+++ b/JAL_Queenstown_Harbor_Proposal.pptx
@@ -1317,7 +1317,7 @@
           <a:p>
             <a:r>
               <a:rPr lang="en-US" dirty="0"/>
-              <a:t>Phase 2 build-to-core annual cash flow. Develop $47M Yr 0–2; NOI ramps Yr 2–4; recap / sell ~$62M @ a 7.5% cap at Yr 4. Levered build-to-core IRR ~28% (65% LTC).</a:t>
+              <a:t>Phase 2 build-to-core LEVERED EQUITY cash flow — ties cell-for-cell to the model's Phase 2 sheet: equity $16.4M (bcEq, split Yr 0–1), stabilized levered CF ~$2.5M (NOI − debt; Yr 2 ramps at ~40%), exit equity $31.5M (recap $62M − loan), net equity CF [-8.2, -8.2, 1.0, 2.5, 34.0], IRR ~28% / ~2.3×. Project develops to ~$47M cost, recaps ~$62M @ a 7.5% cap.</a:t>
             </a:r>
             <a:endParaRPr lang="en-US" dirty="0"/>
           </a:p>
@@ -20660,7 +20660,7 @@
                 <a:ea typeface="Montserrat" pitchFamily="34" charset="-122"/>
                 <a:cs typeface="Montserrat" pitchFamily="34" charset="-120"/>
               </a:rPr>
-              <a:t>PHASE 2  ·  PRO FORMA CASH FLOW</a:t>
+              <a:t>PHASE 2  ·  BUILD-TO-CORE CASH FLOW</a:t>
             </a:r>
             <a:endParaRPr lang="en-US" sz="1000" dirty="0"/>
           </a:p>
@@ -20699,7 +20699,7 @@
                 <a:ea typeface="Montserrat" pitchFamily="34" charset="-122"/>
                 <a:cs typeface="Montserrat" pitchFamily="34" charset="-120"/>
               </a:rPr>
-              <a:t>Phase 2 — pro forma cash flow.</a:t>
+              <a:t>Phase 2 — build-to-core equity cash flow.</a:t>
             </a:r>
             <a:endParaRPr lang="en-US" sz="2500" dirty="0"/>
           </a:p>
@@ -20741,7 +20741,7 @@
                 <a:ea typeface="DM Sans" pitchFamily="34" charset="-122"/>
                 <a:cs typeface="DM Sans" pitchFamily="34" charset="-120"/>
               </a:rPr>
-              <a:t>Hospitality build-to-core, project cash flow ($M). Develop Yr 0–2; stabilize, then recap / sell at ~Yr 4 (~$62M @ a 7.5% cap). VIVÂMEE operates. Illustrative.</a:t>
+              <a:t>Hospitality build-to-core, levered equity cash flow ($M). Build to ~$47M cost at 65% LTC; stabilize at the premium NOI; recap / sell at ~Yr 4 (~$62M @ a 7.5% cap). VIVÂMEE operates. Illustrative.</a:t>
             </a:r>
             <a:endParaRPr lang="en-US" sz="1300" dirty="0"/>
           </a:p>
@@ -20756,7 +20756,7 @@
         <p:spPr>
           <a:xfrm>
             <a:off x="457200" y="2057400"/>
-            <a:ext cx="2743200" cy="365760"/>
+            <a:ext cx="3108960" cy="365760"/>
           </a:xfrm>
           <a:prstGeom prst="rect">
             <a:avLst/>
@@ -20776,7 +20776,7 @@
         <p:spPr>
           <a:xfrm>
             <a:off x="457200" y="2057400"/>
-            <a:ext cx="2743200" cy="365760"/>
+            <a:ext cx="3108960" cy="365760"/>
           </a:xfrm>
           <a:prstGeom prst="rect">
             <a:avLst/>
@@ -20814,8 +20814,8 @@
         </p:nvSpPr>
         <p:spPr>
           <a:xfrm>
-            <a:off x="3200400" y="2057400"/>
-            <a:ext cx="1371600" cy="365760"/>
+            <a:off x="3566160" y="2057400"/>
+            <a:ext cx="1298448" cy="365760"/>
           </a:xfrm>
           <a:prstGeom prst="rect">
             <a:avLst/>
@@ -20834,8 +20834,8 @@
         </p:nvSpPr>
         <p:spPr>
           <a:xfrm>
-            <a:off x="3200400" y="2057400"/>
-            <a:ext cx="1371600" cy="365760"/>
+            <a:off x="3566160" y="2057400"/>
+            <a:ext cx="1298448" cy="365760"/>
           </a:xfrm>
           <a:prstGeom prst="rect">
             <a:avLst/>
@@ -20873,8 +20873,8 @@
         </p:nvSpPr>
         <p:spPr>
           <a:xfrm>
-            <a:off x="4572000" y="2057400"/>
-            <a:ext cx="1371600" cy="365760"/>
+            <a:off x="4864608" y="2057400"/>
+            <a:ext cx="1298448" cy="365760"/>
           </a:xfrm>
           <a:prstGeom prst="rect">
             <a:avLst/>
@@ -20893,8 +20893,8 @@
         </p:nvSpPr>
         <p:spPr>
           <a:xfrm>
-            <a:off x="4572000" y="2057400"/>
-            <a:ext cx="1371600" cy="365760"/>
+            <a:off x="4864608" y="2057400"/>
+            <a:ext cx="1298448" cy="365760"/>
           </a:xfrm>
           <a:prstGeom prst="rect">
             <a:avLst/>
@@ -20932,8 +20932,8 @@
         </p:nvSpPr>
         <p:spPr>
           <a:xfrm>
-            <a:off x="5943600" y="2057400"/>
-            <a:ext cx="1371600" cy="365760"/>
+            <a:off x="6163056" y="2057400"/>
+            <a:ext cx="1298448" cy="365760"/>
           </a:xfrm>
           <a:prstGeom prst="rect">
             <a:avLst/>
@@ -20952,8 +20952,8 @@
         </p:nvSpPr>
         <p:spPr>
           <a:xfrm>
-            <a:off x="5943600" y="2057400"/>
-            <a:ext cx="1371600" cy="365760"/>
+            <a:off x="6163056" y="2057400"/>
+            <a:ext cx="1298448" cy="365760"/>
           </a:xfrm>
           <a:prstGeom prst="rect">
             <a:avLst/>
@@ -20991,8 +20991,8 @@
         </p:nvSpPr>
         <p:spPr>
           <a:xfrm>
-            <a:off x="7315200" y="2057400"/>
-            <a:ext cx="1371600" cy="365760"/>
+            <a:off x="7461504" y="2057400"/>
+            <a:ext cx="1298448" cy="365760"/>
           </a:xfrm>
           <a:prstGeom prst="rect">
             <a:avLst/>
@@ -21011,8 +21011,8 @@
         </p:nvSpPr>
         <p:spPr>
           <a:xfrm>
-            <a:off x="7315200" y="2057400"/>
-            <a:ext cx="1371600" cy="365760"/>
+            <a:off x="7461504" y="2057400"/>
+            <a:ext cx="1298448" cy="365760"/>
           </a:xfrm>
           <a:prstGeom prst="rect">
             <a:avLst/>
@@ -21050,8 +21050,8 @@
         </p:nvSpPr>
         <p:spPr>
           <a:xfrm>
-            <a:off x="8686800" y="2057400"/>
-            <a:ext cx="1371600" cy="365760"/>
+            <a:off x="8759952" y="2057400"/>
+            <a:ext cx="1298448" cy="365760"/>
           </a:xfrm>
           <a:prstGeom prst="rect">
             <a:avLst/>
@@ -21070,8 +21070,8 @@
         </p:nvSpPr>
         <p:spPr>
           <a:xfrm>
-            <a:off x="8686800" y="2057400"/>
-            <a:ext cx="1371600" cy="365760"/>
+            <a:off x="8759952" y="2057400"/>
+            <a:ext cx="1298448" cy="365760"/>
           </a:xfrm>
           <a:prstGeom prst="rect">
             <a:avLst/>
@@ -21110,7 +21110,7 @@
         <p:spPr>
           <a:xfrm>
             <a:off x="10058400" y="2057400"/>
-            <a:ext cx="1645920" cy="365760"/>
+            <a:ext cx="1627632" cy="365760"/>
           </a:xfrm>
           <a:prstGeom prst="rect">
             <a:avLst/>
@@ -21130,7 +21130,7 @@
         <p:spPr>
           <a:xfrm>
             <a:off x="10058400" y="2057400"/>
-            <a:ext cx="1645920" cy="365760"/>
+            <a:ext cx="1627632" cy="365760"/>
           </a:xfrm>
           <a:prstGeom prst="rect">
             <a:avLst/>
@@ -21169,7 +21169,7 @@
         <p:spPr>
           <a:xfrm>
             <a:off x="457200" y="2423160"/>
-            <a:ext cx="2743200" cy="548640"/>
+            <a:ext cx="3108960" cy="548640"/>
           </a:xfrm>
           <a:prstGeom prst="rect">
             <a:avLst/>
@@ -21189,7 +21189,7 @@
         <p:spPr>
           <a:xfrm>
             <a:off x="457200" y="2423160"/>
-            <a:ext cx="2743200" cy="548640"/>
+            <a:ext cx="3108960" cy="548640"/>
           </a:xfrm>
           <a:prstGeom prst="rect">
             <a:avLst/>
@@ -21213,7 +21213,7 @@
                 <a:ea typeface="Montserrat" pitchFamily="34" charset="-122"/>
                 <a:cs typeface="Montserrat" pitchFamily="34" charset="-120"/>
               </a:rPr>
-              <a:t>Net operating income</a:t>
+              <a:t>Equity invested</a:t>
             </a:r>
             <a:endParaRPr lang="en-US" sz="950" dirty="0"/>
           </a:p>
@@ -21227,8 +21227,8 @@
         </p:nvSpPr>
         <p:spPr>
           <a:xfrm>
-            <a:off x="3200400" y="2423160"/>
-            <a:ext cx="1371600" cy="548640"/>
+            <a:off x="3566160" y="2423160"/>
+            <a:ext cx="1298448" cy="548640"/>
           </a:xfrm>
           <a:prstGeom prst="rect">
             <a:avLst/>
@@ -21247,8 +21247,8 @@
         </p:nvSpPr>
         <p:spPr>
           <a:xfrm>
-            <a:off x="3200400" y="2423160"/>
-            <a:ext cx="1371600" cy="548640"/>
+            <a:off x="3566160" y="2423160"/>
+            <a:ext cx="1298448" cy="548640"/>
           </a:xfrm>
           <a:prstGeom prst="rect">
             <a:avLst/>
@@ -21272,7 +21272,7 @@
                 <a:ea typeface="DM Sans" pitchFamily="34" charset="-122"/>
                 <a:cs typeface="DM Sans" pitchFamily="34" charset="-120"/>
               </a:rPr>
-              <a:t>—</a:t>
+              <a:t>(8.2)</a:t>
             </a:r>
             <a:endParaRPr lang="en-US" sz="1000" dirty="0"/>
           </a:p>
@@ -21286,8 +21286,8 @@
         </p:nvSpPr>
         <p:spPr>
           <a:xfrm>
-            <a:off x="4572000" y="2423160"/>
-            <a:ext cx="1371600" cy="548640"/>
+            <a:off x="4864608" y="2423160"/>
+            <a:ext cx="1298448" cy="548640"/>
           </a:xfrm>
           <a:prstGeom prst="rect">
             <a:avLst/>
@@ -21306,8 +21306,8 @@
         </p:nvSpPr>
         <p:spPr>
           <a:xfrm>
-            <a:off x="4572000" y="2423160"/>
-            <a:ext cx="1371600" cy="548640"/>
+            <a:off x="4864608" y="2423160"/>
+            <a:ext cx="1298448" cy="548640"/>
           </a:xfrm>
           <a:prstGeom prst="rect">
             <a:avLst/>
@@ -21331,7 +21331,7 @@
                 <a:ea typeface="DM Sans" pitchFamily="34" charset="-122"/>
                 <a:cs typeface="DM Sans" pitchFamily="34" charset="-120"/>
               </a:rPr>
-              <a:t>—</a:t>
+              <a:t>(8.2)</a:t>
             </a:r>
             <a:endParaRPr lang="en-US" sz="1000" dirty="0"/>
           </a:p>
@@ -21345,8 +21345,8 @@
         </p:nvSpPr>
         <p:spPr>
           <a:xfrm>
-            <a:off x="5943600" y="2423160"/>
-            <a:ext cx="1371600" cy="548640"/>
+            <a:off x="6163056" y="2423160"/>
+            <a:ext cx="1298448" cy="548640"/>
           </a:xfrm>
           <a:prstGeom prst="rect">
             <a:avLst/>
@@ -21365,8 +21365,8 @@
         </p:nvSpPr>
         <p:spPr>
           <a:xfrm>
-            <a:off x="5943600" y="2423160"/>
-            <a:ext cx="1371600" cy="548640"/>
+            <a:off x="6163056" y="2423160"/>
+            <a:ext cx="1298448" cy="548640"/>
           </a:xfrm>
           <a:prstGeom prst="rect">
             <a:avLst/>
@@ -21390,7 +21390,7 @@
                 <a:ea typeface="DM Sans" pitchFamily="34" charset="-122"/>
                 <a:cs typeface="DM Sans" pitchFamily="34" charset="-120"/>
               </a:rPr>
-              <a:t>1.9</a:t>
+              <a:t>—</a:t>
             </a:r>
             <a:endParaRPr lang="en-US" sz="1000" dirty="0"/>
           </a:p>
@@ -21404,8 +21404,8 @@
         </p:nvSpPr>
         <p:spPr>
           <a:xfrm>
-            <a:off x="7315200" y="2423160"/>
-            <a:ext cx="1371600" cy="548640"/>
+            <a:off x="7461504" y="2423160"/>
+            <a:ext cx="1298448" cy="548640"/>
           </a:xfrm>
           <a:prstGeom prst="rect">
             <a:avLst/>
@@ -21424,8 +21424,8 @@
         </p:nvSpPr>
         <p:spPr>
           <a:xfrm>
-            <a:off x="7315200" y="2423160"/>
-            <a:ext cx="1371600" cy="548640"/>
+            <a:off x="7461504" y="2423160"/>
+            <a:ext cx="1298448" cy="548640"/>
           </a:xfrm>
           <a:prstGeom prst="rect">
             <a:avLst/>
@@ -21449,7 +21449,7 @@
                 <a:ea typeface="DM Sans" pitchFamily="34" charset="-122"/>
                 <a:cs typeface="DM Sans" pitchFamily="34" charset="-120"/>
               </a:rPr>
-              <a:t>4.7</a:t>
+              <a:t>—</a:t>
             </a:r>
             <a:endParaRPr lang="en-US" sz="1000" dirty="0"/>
           </a:p>
@@ -21463,8 +21463,8 @@
         </p:nvSpPr>
         <p:spPr>
           <a:xfrm>
-            <a:off x="8686800" y="2423160"/>
-            <a:ext cx="1371600" cy="548640"/>
+            <a:off x="8759952" y="2423160"/>
+            <a:ext cx="1298448" cy="548640"/>
           </a:xfrm>
           <a:prstGeom prst="rect">
             <a:avLst/>
@@ -21483,8 +21483,8 @@
         </p:nvSpPr>
         <p:spPr>
           <a:xfrm>
-            <a:off x="8686800" y="2423160"/>
-            <a:ext cx="1371600" cy="548640"/>
+            <a:off x="8759952" y="2423160"/>
+            <a:ext cx="1298448" cy="548640"/>
           </a:xfrm>
           <a:prstGeom prst="rect">
             <a:avLst/>
@@ -21508,7 +21508,7 @@
                 <a:ea typeface="DM Sans" pitchFamily="34" charset="-122"/>
                 <a:cs typeface="DM Sans" pitchFamily="34" charset="-120"/>
               </a:rPr>
-              <a:t>4.7</a:t>
+              <a:t>—</a:t>
             </a:r>
             <a:endParaRPr lang="en-US" sz="1000" dirty="0"/>
           </a:p>
@@ -21523,7 +21523,7 @@
         <p:spPr>
           <a:xfrm>
             <a:off x="10058400" y="2423160"/>
-            <a:ext cx="1645920" cy="548640"/>
+            <a:ext cx="1627632" cy="548640"/>
           </a:xfrm>
           <a:prstGeom prst="rect">
             <a:avLst/>
@@ -21543,7 +21543,7 @@
         <p:spPr>
           <a:xfrm>
             <a:off x="10058400" y="2423160"/>
-            <a:ext cx="1645920" cy="548640"/>
+            <a:ext cx="1627632" cy="548640"/>
           </a:xfrm>
           <a:prstGeom prst="rect">
             <a:avLst/>
@@ -21567,7 +21567,7 @@
                 <a:ea typeface="Montserrat" pitchFamily="34" charset="-122"/>
                 <a:cs typeface="Montserrat" pitchFamily="34" charset="-120"/>
               </a:rPr>
-              <a:t>11.3</a:t>
+              <a:t>(16.4)</a:t>
             </a:r>
             <a:endParaRPr lang="en-US" sz="1000" dirty="0"/>
           </a:p>
@@ -21582,7 +21582,7 @@
         <p:spPr>
           <a:xfrm>
             <a:off x="457200" y="2971800"/>
-            <a:ext cx="2743200" cy="548640"/>
+            <a:ext cx="3108960" cy="548640"/>
           </a:xfrm>
           <a:prstGeom prst="rect">
             <a:avLst/>
@@ -21602,7 +21602,7 @@
         <p:spPr>
           <a:xfrm>
             <a:off x="457200" y="2971800"/>
-            <a:ext cx="2743200" cy="548640"/>
+            <a:ext cx="3108960" cy="548640"/>
           </a:xfrm>
           <a:prstGeom prst="rect">
             <a:avLst/>
@@ -21626,7 +21626,7 @@
                 <a:ea typeface="Montserrat" pitchFamily="34" charset="-122"/>
                 <a:cs typeface="Montserrat" pitchFamily="34" charset="-120"/>
               </a:rPr>
-              <a:t>Recap / sale proceeds</a:t>
+              <a:t>Operating cash flow (after debt)</a:t>
             </a:r>
             <a:endParaRPr lang="en-US" sz="950" dirty="0"/>
           </a:p>
@@ -21640,8 +21640,8 @@
         </p:nvSpPr>
         <p:spPr>
           <a:xfrm>
-            <a:off x="3200400" y="2971800"/>
-            <a:ext cx="1371600" cy="548640"/>
+            <a:off x="3566160" y="2971800"/>
+            <a:ext cx="1298448" cy="548640"/>
           </a:xfrm>
           <a:prstGeom prst="rect">
             <a:avLst/>
@@ -21660,8 +21660,8 @@
         </p:nvSpPr>
         <p:spPr>
           <a:xfrm>
-            <a:off x="3200400" y="2971800"/>
-            <a:ext cx="1371600" cy="548640"/>
+            <a:off x="3566160" y="2971800"/>
+            <a:ext cx="1298448" cy="548640"/>
           </a:xfrm>
           <a:prstGeom prst="rect">
             <a:avLst/>
@@ -21699,8 +21699,8 @@
         </p:nvSpPr>
         <p:spPr>
           <a:xfrm>
-            <a:off x="4572000" y="2971800"/>
-            <a:ext cx="1371600" cy="548640"/>
+            <a:off x="4864608" y="2971800"/>
+            <a:ext cx="1298448" cy="548640"/>
           </a:xfrm>
           <a:prstGeom prst="rect">
             <a:avLst/>
@@ -21719,8 +21719,8 @@
         </p:nvSpPr>
         <p:spPr>
           <a:xfrm>
-            <a:off x="4572000" y="2971800"/>
-            <a:ext cx="1371600" cy="548640"/>
+            <a:off x="4864608" y="2971800"/>
+            <a:ext cx="1298448" cy="548640"/>
           </a:xfrm>
           <a:prstGeom prst="rect">
             <a:avLst/>
@@ -21758,8 +21758,8 @@
         </p:nvSpPr>
         <p:spPr>
           <a:xfrm>
-            <a:off x="5943600" y="2971800"/>
-            <a:ext cx="1371600" cy="548640"/>
+            <a:off x="6163056" y="2971800"/>
+            <a:ext cx="1298448" cy="548640"/>
           </a:xfrm>
           <a:prstGeom prst="rect">
             <a:avLst/>
@@ -21778,8 +21778,8 @@
         </p:nvSpPr>
         <p:spPr>
           <a:xfrm>
-            <a:off x="5943600" y="2971800"/>
-            <a:ext cx="1371600" cy="548640"/>
+            <a:off x="6163056" y="2971800"/>
+            <a:ext cx="1298448" cy="548640"/>
           </a:xfrm>
           <a:prstGeom prst="rect">
             <a:avLst/>
@@ -21803,7 +21803,7 @@
                 <a:ea typeface="DM Sans" pitchFamily="34" charset="-122"/>
                 <a:cs typeface="DM Sans" pitchFamily="34" charset="-120"/>
               </a:rPr>
-              <a:t>—</a:t>
+              <a:t>1.0</a:t>
             </a:r>
             <a:endParaRPr lang="en-US" sz="1000" dirty="0"/>
           </a:p>
@@ -21817,8 +21817,8 @@
         </p:nvSpPr>
         <p:spPr>
           <a:xfrm>
-            <a:off x="7315200" y="2971800"/>
-            <a:ext cx="1371600" cy="548640"/>
+            <a:off x="7461504" y="2971800"/>
+            <a:ext cx="1298448" cy="548640"/>
           </a:xfrm>
           <a:prstGeom prst="rect">
             <a:avLst/>
@@ -21837,8 +21837,8 @@
         </p:nvSpPr>
         <p:spPr>
           <a:xfrm>
-            <a:off x="7315200" y="2971800"/>
-            <a:ext cx="1371600" cy="548640"/>
+            <a:off x="7461504" y="2971800"/>
+            <a:ext cx="1298448" cy="548640"/>
           </a:xfrm>
           <a:prstGeom prst="rect">
             <a:avLst/>
@@ -21862,7 +21862,7 @@
                 <a:ea typeface="DM Sans" pitchFamily="34" charset="-122"/>
                 <a:cs typeface="DM Sans" pitchFamily="34" charset="-120"/>
               </a:rPr>
-              <a:t>—</a:t>
+              <a:t>2.5</a:t>
             </a:r>
             <a:endParaRPr lang="en-US" sz="1000" dirty="0"/>
           </a:p>
@@ -21876,8 +21876,8 @@
         </p:nvSpPr>
         <p:spPr>
           <a:xfrm>
-            <a:off x="8686800" y="2971800"/>
-            <a:ext cx="1371600" cy="548640"/>
+            <a:off x="8759952" y="2971800"/>
+            <a:ext cx="1298448" cy="548640"/>
           </a:xfrm>
           <a:prstGeom prst="rect">
             <a:avLst/>
@@ -21896,8 +21896,8 @@
         </p:nvSpPr>
         <p:spPr>
           <a:xfrm>
-            <a:off x="8686800" y="2971800"/>
-            <a:ext cx="1371600" cy="548640"/>
+            <a:off x="8759952" y="2971800"/>
+            <a:ext cx="1298448" cy="548640"/>
           </a:xfrm>
           <a:prstGeom prst="rect">
             <a:avLst/>
@@ -21921,7 +21921,7 @@
                 <a:ea typeface="DM Sans" pitchFamily="34" charset="-122"/>
                 <a:cs typeface="DM Sans" pitchFamily="34" charset="-120"/>
               </a:rPr>
-              <a:t>62.0</a:t>
+              <a:t>2.5</a:t>
             </a:r>
             <a:endParaRPr lang="en-US" sz="1000" dirty="0"/>
           </a:p>
@@ -21936,7 +21936,7 @@
         <p:spPr>
           <a:xfrm>
             <a:off x="10058400" y="2971800"/>
-            <a:ext cx="1645920" cy="548640"/>
+            <a:ext cx="1627632" cy="548640"/>
           </a:xfrm>
           <a:prstGeom prst="rect">
             <a:avLst/>
@@ -21956,7 +21956,7 @@
         <p:spPr>
           <a:xfrm>
             <a:off x="10058400" y="2971800"/>
-            <a:ext cx="1645920" cy="548640"/>
+            <a:ext cx="1627632" cy="548640"/>
           </a:xfrm>
           <a:prstGeom prst="rect">
             <a:avLst/>
@@ -21980,7 +21980,7 @@
                 <a:ea typeface="Montserrat" pitchFamily="34" charset="-122"/>
                 <a:cs typeface="Montserrat" pitchFamily="34" charset="-120"/>
               </a:rPr>
-              <a:t>62.0</a:t>
+              <a:t>6.0</a:t>
             </a:r>
             <a:endParaRPr lang="en-US" sz="1000" dirty="0"/>
           </a:p>
@@ -21995,7 +21995,7 @@
         <p:spPr>
           <a:xfrm>
             <a:off x="457200" y="3520440"/>
-            <a:ext cx="2743200" cy="548640"/>
+            <a:ext cx="3108960" cy="548640"/>
           </a:xfrm>
           <a:prstGeom prst="rect">
             <a:avLst/>
@@ -22015,7 +22015,7 @@
         <p:spPr>
           <a:xfrm>
             <a:off x="457200" y="3520440"/>
-            <a:ext cx="2743200" cy="548640"/>
+            <a:ext cx="3108960" cy="548640"/>
           </a:xfrm>
           <a:prstGeom prst="rect">
             <a:avLst/>
@@ -22039,7 +22039,7 @@
                 <a:ea typeface="Montserrat" pitchFamily="34" charset="-122"/>
                 <a:cs typeface="Montserrat" pitchFamily="34" charset="-120"/>
               </a:rPr>
-              <a:t>Less: development cost</a:t>
+              <a:t>Recap equity (sale − loan)</a:t>
             </a:r>
             <a:endParaRPr lang="en-US" sz="950" dirty="0"/>
           </a:p>
@@ -22053,8 +22053,8 @@
         </p:nvSpPr>
         <p:spPr>
           <a:xfrm>
-            <a:off x="3200400" y="3520440"/>
-            <a:ext cx="1371600" cy="548640"/>
+            <a:off x="3566160" y="3520440"/>
+            <a:ext cx="1298448" cy="548640"/>
           </a:xfrm>
           <a:prstGeom prst="rect">
             <a:avLst/>
@@ -22073,8 +22073,8 @@
         </p:nvSpPr>
         <p:spPr>
           <a:xfrm>
-            <a:off x="3200400" y="3520440"/>
-            <a:ext cx="1371600" cy="548640"/>
+            <a:off x="3566160" y="3520440"/>
+            <a:ext cx="1298448" cy="548640"/>
           </a:xfrm>
           <a:prstGeom prst="rect">
             <a:avLst/>
@@ -22098,7 +22098,7 @@
                 <a:ea typeface="DM Sans" pitchFamily="34" charset="-122"/>
                 <a:cs typeface="DM Sans" pitchFamily="34" charset="-120"/>
               </a:rPr>
-              <a:t>(15.0)</a:t>
+              <a:t>—</a:t>
             </a:r>
             <a:endParaRPr lang="en-US" sz="1000" dirty="0"/>
           </a:p>
@@ -22112,8 +22112,8 @@
         </p:nvSpPr>
         <p:spPr>
           <a:xfrm>
-            <a:off x="4572000" y="3520440"/>
-            <a:ext cx="1371600" cy="548640"/>
+            <a:off x="4864608" y="3520440"/>
+            <a:ext cx="1298448" cy="548640"/>
           </a:xfrm>
           <a:prstGeom prst="rect">
             <a:avLst/>
@@ -22132,8 +22132,8 @@
         </p:nvSpPr>
         <p:spPr>
           <a:xfrm>
-            <a:off x="4572000" y="3520440"/>
-            <a:ext cx="1371600" cy="548640"/>
+            <a:off x="4864608" y="3520440"/>
+            <a:ext cx="1298448" cy="548640"/>
           </a:xfrm>
           <a:prstGeom prst="rect">
             <a:avLst/>
@@ -22157,7 +22157,7 @@
                 <a:ea typeface="DM Sans" pitchFamily="34" charset="-122"/>
                 <a:cs typeface="DM Sans" pitchFamily="34" charset="-120"/>
               </a:rPr>
-              <a:t>(20.0)</a:t>
+              <a:t>—</a:t>
             </a:r>
             <a:endParaRPr lang="en-US" sz="1000" dirty="0"/>
           </a:p>
@@ -22171,8 +22171,8 @@
         </p:nvSpPr>
         <p:spPr>
           <a:xfrm>
-            <a:off x="5943600" y="3520440"/>
-            <a:ext cx="1371600" cy="548640"/>
+            <a:off x="6163056" y="3520440"/>
+            <a:ext cx="1298448" cy="548640"/>
           </a:xfrm>
           <a:prstGeom prst="rect">
             <a:avLst/>
@@ -22191,8 +22191,8 @@
         </p:nvSpPr>
         <p:spPr>
           <a:xfrm>
-            <a:off x="5943600" y="3520440"/>
-            <a:ext cx="1371600" cy="548640"/>
+            <a:off x="6163056" y="3520440"/>
+            <a:ext cx="1298448" cy="548640"/>
           </a:xfrm>
           <a:prstGeom prst="rect">
             <a:avLst/>
@@ -22216,7 +22216,7 @@
                 <a:ea typeface="DM Sans" pitchFamily="34" charset="-122"/>
                 <a:cs typeface="DM Sans" pitchFamily="34" charset="-120"/>
               </a:rPr>
-              <a:t>(12.0)</a:t>
+              <a:t>—</a:t>
             </a:r>
             <a:endParaRPr lang="en-US" sz="1000" dirty="0"/>
           </a:p>
@@ -22230,8 +22230,8 @@
         </p:nvSpPr>
         <p:spPr>
           <a:xfrm>
-            <a:off x="7315200" y="3520440"/>
-            <a:ext cx="1371600" cy="548640"/>
+            <a:off x="7461504" y="3520440"/>
+            <a:ext cx="1298448" cy="548640"/>
           </a:xfrm>
           <a:prstGeom prst="rect">
             <a:avLst/>
@@ -22250,8 +22250,8 @@
         </p:nvSpPr>
         <p:spPr>
           <a:xfrm>
-            <a:off x="7315200" y="3520440"/>
-            <a:ext cx="1371600" cy="548640"/>
+            <a:off x="7461504" y="3520440"/>
+            <a:ext cx="1298448" cy="548640"/>
           </a:xfrm>
           <a:prstGeom prst="rect">
             <a:avLst/>
@@ -22289,8 +22289,8 @@
         </p:nvSpPr>
         <p:spPr>
           <a:xfrm>
-            <a:off x="8686800" y="3520440"/>
-            <a:ext cx="1371600" cy="548640"/>
+            <a:off x="8759952" y="3520440"/>
+            <a:ext cx="1298448" cy="548640"/>
           </a:xfrm>
           <a:prstGeom prst="rect">
             <a:avLst/>
@@ -22309,8 +22309,8 @@
         </p:nvSpPr>
         <p:spPr>
           <a:xfrm>
-            <a:off x="8686800" y="3520440"/>
-            <a:ext cx="1371600" cy="548640"/>
+            <a:off x="8759952" y="3520440"/>
+            <a:ext cx="1298448" cy="548640"/>
           </a:xfrm>
           <a:prstGeom prst="rect">
             <a:avLst/>
@@ -22334,7 +22334,7 @@
                 <a:ea typeface="DM Sans" pitchFamily="34" charset="-122"/>
                 <a:cs typeface="DM Sans" pitchFamily="34" charset="-120"/>
               </a:rPr>
-              <a:t>—</a:t>
+              <a:t>31.5</a:t>
             </a:r>
             <a:endParaRPr lang="en-US" sz="1000" dirty="0"/>
           </a:p>
@@ -22349,7 +22349,7 @@
         <p:spPr>
           <a:xfrm>
             <a:off x="10058400" y="3520440"/>
-            <a:ext cx="1645920" cy="548640"/>
+            <a:ext cx="1627632" cy="548640"/>
           </a:xfrm>
           <a:prstGeom prst="rect">
             <a:avLst/>
@@ -22369,7 +22369,7 @@
         <p:spPr>
           <a:xfrm>
             <a:off x="10058400" y="3520440"/>
-            <a:ext cx="1645920" cy="548640"/>
+            <a:ext cx="1627632" cy="548640"/>
           </a:xfrm>
           <a:prstGeom prst="rect">
             <a:avLst/>
@@ -22393,7 +22393,7 @@
                 <a:ea typeface="Montserrat" pitchFamily="34" charset="-122"/>
                 <a:cs typeface="Montserrat" pitchFamily="34" charset="-120"/>
               </a:rPr>
-              <a:t>(47.0)</a:t>
+              <a:t>31.5</a:t>
             </a:r>
             <a:endParaRPr lang="en-US" sz="1000" dirty="0"/>
           </a:p>
@@ -22408,7 +22408,7 @@
         <p:spPr>
           <a:xfrm>
             <a:off x="457200" y="4069080"/>
-            <a:ext cx="2743200" cy="548640"/>
+            <a:ext cx="3108960" cy="548640"/>
           </a:xfrm>
           <a:prstGeom prst="rect">
             <a:avLst/>
@@ -22428,7 +22428,7 @@
         <p:spPr>
           <a:xfrm>
             <a:off x="457200" y="4069080"/>
-            <a:ext cx="2743200" cy="548640"/>
+            <a:ext cx="3108960" cy="548640"/>
           </a:xfrm>
           <a:prstGeom prst="rect">
             <a:avLst/>
@@ -22452,7 +22452,7 @@
                 <a:ea typeface="Montserrat" pitchFamily="34" charset="-122"/>
                 <a:cs typeface="Montserrat" pitchFamily="34" charset="-120"/>
               </a:rPr>
-              <a:t>Net project cash flow</a:t>
+              <a:t>Net equity cash flow</a:t>
             </a:r>
             <a:endParaRPr lang="en-US" sz="950" dirty="0"/>
           </a:p>
@@ -22466,8 +22466,8 @@
         </p:nvSpPr>
         <p:spPr>
           <a:xfrm>
-            <a:off x="3200400" y="4069080"/>
-            <a:ext cx="1371600" cy="548640"/>
+            <a:off x="3566160" y="4069080"/>
+            <a:ext cx="1298448" cy="548640"/>
           </a:xfrm>
           <a:prstGeom prst="rect">
             <a:avLst/>
@@ -22486,8 +22486,8 @@
         </p:nvSpPr>
         <p:spPr>
           <a:xfrm>
-            <a:off x="3200400" y="4069080"/>
-            <a:ext cx="1371600" cy="548640"/>
+            <a:off x="3566160" y="4069080"/>
+            <a:ext cx="1298448" cy="548640"/>
           </a:xfrm>
           <a:prstGeom prst="rect">
             <a:avLst/>
@@ -22511,7 +22511,7 @@
                 <a:ea typeface="Montserrat" pitchFamily="34" charset="-122"/>
                 <a:cs typeface="Montserrat" pitchFamily="34" charset="-120"/>
               </a:rPr>
-              <a:t>(15.0)</a:t>
+              <a:t>(8.2)</a:t>
             </a:r>
             <a:endParaRPr lang="en-US" sz="1000" dirty="0"/>
           </a:p>
@@ -22525,8 +22525,8 @@
         </p:nvSpPr>
         <p:spPr>
           <a:xfrm>
-            <a:off x="4572000" y="4069080"/>
-            <a:ext cx="1371600" cy="548640"/>
+            <a:off x="4864608" y="4069080"/>
+            <a:ext cx="1298448" cy="548640"/>
           </a:xfrm>
           <a:prstGeom prst="rect">
             <a:avLst/>
@@ -22545,8 +22545,8 @@
         </p:nvSpPr>
         <p:spPr>
           <a:xfrm>
-            <a:off x="4572000" y="4069080"/>
-            <a:ext cx="1371600" cy="548640"/>
+            <a:off x="4864608" y="4069080"/>
+            <a:ext cx="1298448" cy="548640"/>
           </a:xfrm>
           <a:prstGeom prst="rect">
             <a:avLst/>
@@ -22570,7 +22570,7 @@
                 <a:ea typeface="Montserrat" pitchFamily="34" charset="-122"/>
                 <a:cs typeface="Montserrat" pitchFamily="34" charset="-120"/>
               </a:rPr>
-              <a:t>(20.0)</a:t>
+              <a:t>(8.2)</a:t>
             </a:r>
             <a:endParaRPr lang="en-US" sz="1000" dirty="0"/>
           </a:p>
@@ -22584,8 +22584,8 @@
         </p:nvSpPr>
         <p:spPr>
           <a:xfrm>
-            <a:off x="5943600" y="4069080"/>
-            <a:ext cx="1371600" cy="548640"/>
+            <a:off x="6163056" y="4069080"/>
+            <a:ext cx="1298448" cy="548640"/>
           </a:xfrm>
           <a:prstGeom prst="rect">
             <a:avLst/>
@@ -22604,8 +22604,8 @@
         </p:nvSpPr>
         <p:spPr>
           <a:xfrm>
-            <a:off x="5943600" y="4069080"/>
-            <a:ext cx="1371600" cy="548640"/>
+            <a:off x="6163056" y="4069080"/>
+            <a:ext cx="1298448" cy="548640"/>
           </a:xfrm>
           <a:prstGeom prst="rect">
             <a:avLst/>
@@ -22629,7 +22629,7 @@
                 <a:ea typeface="Montserrat" pitchFamily="34" charset="-122"/>
                 <a:cs typeface="Montserrat" pitchFamily="34" charset="-120"/>
               </a:rPr>
-              <a:t>(10.1)</a:t>
+              <a:t>1.0</a:t>
             </a:r>
             <a:endParaRPr lang="en-US" sz="1000" dirty="0"/>
           </a:p>
@@ -22643,8 +22643,8 @@
         </p:nvSpPr>
         <p:spPr>
           <a:xfrm>
-            <a:off x="7315200" y="4069080"/>
-            <a:ext cx="1371600" cy="548640"/>
+            <a:off x="7461504" y="4069080"/>
+            <a:ext cx="1298448" cy="548640"/>
           </a:xfrm>
           <a:prstGeom prst="rect">
             <a:avLst/>
@@ -22663,8 +22663,8 @@
         </p:nvSpPr>
         <p:spPr>
           <a:xfrm>
-            <a:off x="7315200" y="4069080"/>
-            <a:ext cx="1371600" cy="548640"/>
+            <a:off x="7461504" y="4069080"/>
+            <a:ext cx="1298448" cy="548640"/>
           </a:xfrm>
           <a:prstGeom prst="rect">
             <a:avLst/>
@@ -22688,7 +22688,7 @@
                 <a:ea typeface="Montserrat" pitchFamily="34" charset="-122"/>
                 <a:cs typeface="Montserrat" pitchFamily="34" charset="-120"/>
               </a:rPr>
-              <a:t>4.7</a:t>
+              <a:t>2.5</a:t>
             </a:r>
             <a:endParaRPr lang="en-US" sz="1000" dirty="0"/>
           </a:p>
@@ -22702,8 +22702,8 @@
         </p:nvSpPr>
         <p:spPr>
           <a:xfrm>
-            <a:off x="8686800" y="4069080"/>
-            <a:ext cx="1371600" cy="548640"/>
+            <a:off x="8759952" y="4069080"/>
+            <a:ext cx="1298448" cy="548640"/>
           </a:xfrm>
           <a:prstGeom prst="rect">
             <a:avLst/>
@@ -22722,8 +22722,8 @@
         </p:nvSpPr>
         <p:spPr>
           <a:xfrm>
-            <a:off x="8686800" y="4069080"/>
-            <a:ext cx="1371600" cy="548640"/>
+            <a:off x="8759952" y="4069080"/>
+            <a:ext cx="1298448" cy="548640"/>
           </a:xfrm>
           <a:prstGeom prst="rect">
             <a:avLst/>
@@ -22747,7 +22747,7 @@
                 <a:ea typeface="Montserrat" pitchFamily="34" charset="-122"/>
                 <a:cs typeface="Montserrat" pitchFamily="34" charset="-120"/>
               </a:rPr>
-              <a:t>66.7</a:t>
+              <a:t>34.0</a:t>
             </a:r>
             <a:endParaRPr lang="en-US" sz="1000" dirty="0"/>
           </a:p>
@@ -22762,7 +22762,7 @@
         <p:spPr>
           <a:xfrm>
             <a:off x="10058400" y="4069080"/>
-            <a:ext cx="1645920" cy="548640"/>
+            <a:ext cx="1627632" cy="548640"/>
           </a:xfrm>
           <a:prstGeom prst="rect">
             <a:avLst/>
@@ -22782,7 +22782,7 @@
         <p:spPr>
           <a:xfrm>
             <a:off x="10058400" y="4069080"/>
-            <a:ext cx="1645920" cy="548640"/>
+            <a:ext cx="1627632" cy="548640"/>
           </a:xfrm>
           <a:prstGeom prst="rect">
             <a:avLst/>
@@ -22806,7 +22806,7 @@
                 <a:ea typeface="Montserrat" pitchFamily="34" charset="-122"/>
                 <a:cs typeface="Montserrat" pitchFamily="34" charset="-120"/>
               </a:rPr>
-              <a:t>26.3</a:t>
+              <a:t>21.1</a:t>
             </a:r>
             <a:endParaRPr lang="en-US" sz="1000" dirty="0"/>
           </a:p>
@@ -22821,7 +22821,7 @@
         <p:spPr>
           <a:xfrm>
             <a:off x="457200" y="4617720"/>
-            <a:ext cx="2743200" cy="548640"/>
+            <a:ext cx="3108960" cy="548640"/>
           </a:xfrm>
           <a:prstGeom prst="rect">
             <a:avLst/>
@@ -22841,7 +22841,7 @@
         <p:spPr>
           <a:xfrm>
             <a:off x="457200" y="4617720"/>
-            <a:ext cx="2743200" cy="548640"/>
+            <a:ext cx="3108960" cy="548640"/>
           </a:xfrm>
           <a:prstGeom prst="rect">
             <a:avLst/>
@@ -22879,8 +22879,8 @@
         </p:nvSpPr>
         <p:spPr>
           <a:xfrm>
-            <a:off x="3200400" y="4617720"/>
-            <a:ext cx="1371600" cy="548640"/>
+            <a:off x="3566160" y="4617720"/>
+            <a:ext cx="1298448" cy="548640"/>
           </a:xfrm>
           <a:prstGeom prst="rect">
             <a:avLst/>
@@ -22899,8 +22899,8 @@
         </p:nvSpPr>
         <p:spPr>
           <a:xfrm>
-            <a:off x="3200400" y="4617720"/>
-            <a:ext cx="1371600" cy="548640"/>
+            <a:off x="3566160" y="4617720"/>
+            <a:ext cx="1298448" cy="548640"/>
           </a:xfrm>
           <a:prstGeom prst="rect">
             <a:avLst/>
@@ -22924,7 +22924,7 @@
                 <a:ea typeface="DM Sans" pitchFamily="34" charset="-122"/>
                 <a:cs typeface="DM Sans" pitchFamily="34" charset="-120"/>
               </a:rPr>
-              <a:t>(15.0)</a:t>
+              <a:t>(8.2)</a:t>
             </a:r>
             <a:endParaRPr lang="en-US" sz="1000" dirty="0"/>
           </a:p>
@@ -22938,8 +22938,8 @@
         </p:nvSpPr>
         <p:spPr>
           <a:xfrm>
-            <a:off x="4572000" y="4617720"/>
-            <a:ext cx="1371600" cy="548640"/>
+            <a:off x="4864608" y="4617720"/>
+            <a:ext cx="1298448" cy="548640"/>
           </a:xfrm>
           <a:prstGeom prst="rect">
             <a:avLst/>
@@ -22958,8 +22958,8 @@
         </p:nvSpPr>
         <p:spPr>
           <a:xfrm>
-            <a:off x="4572000" y="4617720"/>
-            <a:ext cx="1371600" cy="548640"/>
+            <a:off x="4864608" y="4617720"/>
+            <a:ext cx="1298448" cy="548640"/>
           </a:xfrm>
           <a:prstGeom prst="rect">
             <a:avLst/>
@@ -22983,7 +22983,7 @@
                 <a:ea typeface="DM Sans" pitchFamily="34" charset="-122"/>
                 <a:cs typeface="DM Sans" pitchFamily="34" charset="-120"/>
               </a:rPr>
-              <a:t>(35.0)</a:t>
+              <a:t>(16.4)</a:t>
             </a:r>
             <a:endParaRPr lang="en-US" sz="1000" dirty="0"/>
           </a:p>
@@ -22997,8 +22997,8 @@
         </p:nvSpPr>
         <p:spPr>
           <a:xfrm>
-            <a:off x="5943600" y="4617720"/>
-            <a:ext cx="1371600" cy="548640"/>
+            <a:off x="6163056" y="4617720"/>
+            <a:ext cx="1298448" cy="548640"/>
           </a:xfrm>
           <a:prstGeom prst="rect">
             <a:avLst/>
@@ -23017,8 +23017,8 @@
         </p:nvSpPr>
         <p:spPr>
           <a:xfrm>
-            <a:off x="5943600" y="4617720"/>
-            <a:ext cx="1371600" cy="548640"/>
+            <a:off x="6163056" y="4617720"/>
+            <a:ext cx="1298448" cy="548640"/>
           </a:xfrm>
           <a:prstGeom prst="rect">
             <a:avLst/>
@@ -23042,7 +23042,7 @@
                 <a:ea typeface="DM Sans" pitchFamily="34" charset="-122"/>
                 <a:cs typeface="DM Sans" pitchFamily="34" charset="-120"/>
               </a:rPr>
-              <a:t>(45.1)</a:t>
+              <a:t>(15.4)</a:t>
             </a:r>
             <a:endParaRPr lang="en-US" sz="1000" dirty="0"/>
           </a:p>
@@ -23056,8 +23056,8 @@
         </p:nvSpPr>
         <p:spPr>
           <a:xfrm>
-            <a:off x="7315200" y="4617720"/>
-            <a:ext cx="1371600" cy="548640"/>
+            <a:off x="7461504" y="4617720"/>
+            <a:ext cx="1298448" cy="548640"/>
           </a:xfrm>
           <a:prstGeom prst="rect">
             <a:avLst/>
@@ -23076,8 +23076,8 @@
         </p:nvSpPr>
         <p:spPr>
           <a:xfrm>
-            <a:off x="7315200" y="4617720"/>
-            <a:ext cx="1371600" cy="548640"/>
+            <a:off x="7461504" y="4617720"/>
+            <a:ext cx="1298448" cy="548640"/>
           </a:xfrm>
           <a:prstGeom prst="rect">
             <a:avLst/>
@@ -23101,7 +23101,7 @@
                 <a:ea typeface="DM Sans" pitchFamily="34" charset="-122"/>
                 <a:cs typeface="DM Sans" pitchFamily="34" charset="-120"/>
               </a:rPr>
-              <a:t>(40.4)</a:t>
+              <a:t>(12.9)</a:t>
             </a:r>
             <a:endParaRPr lang="en-US" sz="1000" dirty="0"/>
           </a:p>
@@ -23115,8 +23115,8 @@
         </p:nvSpPr>
         <p:spPr>
           <a:xfrm>
-            <a:off x="8686800" y="4617720"/>
-            <a:ext cx="1371600" cy="548640"/>
+            <a:off x="8759952" y="4617720"/>
+            <a:ext cx="1298448" cy="548640"/>
           </a:xfrm>
           <a:prstGeom prst="rect">
             <a:avLst/>
@@ -23135,8 +23135,8 @@
         </p:nvSpPr>
         <p:spPr>
           <a:xfrm>
-            <a:off x="8686800" y="4617720"/>
-            <a:ext cx="1371600" cy="548640"/>
+            <a:off x="8759952" y="4617720"/>
+            <a:ext cx="1298448" cy="548640"/>
           </a:xfrm>
           <a:prstGeom prst="rect">
             <a:avLst/>
@@ -23160,7 +23160,7 @@
                 <a:ea typeface="DM Sans" pitchFamily="34" charset="-122"/>
                 <a:cs typeface="DM Sans" pitchFamily="34" charset="-120"/>
               </a:rPr>
-              <a:t>26.3</a:t>
+              <a:t>21.1</a:t>
             </a:r>
             <a:endParaRPr lang="en-US" sz="1000" dirty="0"/>
           </a:p>
@@ -23175,7 +23175,7 @@
         <p:spPr>
           <a:xfrm>
             <a:off x="10058400" y="4617720"/>
-            <a:ext cx="1645920" cy="548640"/>
+            <a:ext cx="1627632" cy="548640"/>
           </a:xfrm>
           <a:prstGeom prst="rect">
             <a:avLst/>
@@ -23195,7 +23195,7 @@
         <p:spPr>
           <a:xfrm>
             <a:off x="10058400" y="4617720"/>
-            <a:ext cx="1645920" cy="548640"/>
+            <a:ext cx="1627632" cy="548640"/>
           </a:xfrm>
           <a:prstGeom prst="rect">
             <a:avLst/>
@@ -23267,7 +23267,7 @@
                 <a:ea typeface="DM Sans" pitchFamily="34" charset="-122"/>
                 <a:cs typeface="DM Sans" pitchFamily="34" charset="-120"/>
               </a:rPr>
-              <a:t>Develops to ~cost; value is created at the recap / sale. Build-to-core (65% LTC) levered IRR ~28% / ~2.3× — see the Phase 2 sensitivity.</a:t>
+              <a:t>~$16.4M equity → ~$21M net; build-to-core (65% LTC) levered IRR ~28% / ~2.3× at the Yr-4 recap (~$62M on ~$47M cost). Ties to the model's build-to-core sheet.</a:t>
             </a:r>
             <a:endParaRPr lang="en-US" sz="1100" dirty="0"/>
           </a:p>
@@ -23306,7 +23306,7 @@
                 <a:ea typeface="DM Sans" pitchFamily="34" charset="-122"/>
                 <a:cs typeface="DM Sans" pitchFamily="34" charset="-120"/>
               </a:rPr>
-              <a:t>Project-level cash flow; illustrative phasing. A 120-key resort &amp; spa is already designed (FILLAT+). Figures subject to confirmation.</a:t>
+              <a:t>Levered equity cash flow — the line that drives the ~28% IRR; recap / sale at stabilization. A 120-key resort &amp; spa is already designed (FILLAT+). Illustrative.</a:t>
             </a:r>
             <a:endParaRPr lang="en-US" sz="750" dirty="0"/>
           </a:p>

</xml_diff>

<commit_message>
Show the Phase 1 project IRR (~86%) on the pro forma and cash-flow slides
- Pro Forma returns box adds '~86% Project IRR (unlevered)'
- Pro Forma + Phase 1 cash-flow callouts cite ~86% unlevered IRR on a
  near-zero land basis (alongside the ~2.7x on cost)

https://claude.ai/code/session_01BHWC2bwKRSfRRWtpGYSNwZ
</commit_message>
<xml_diff>
--- a/JAL_Queenstown_Harbor_Proposal.pptx
+++ b/JAL_Queenstown_Harbor_Proposal.pptx
@@ -8626,7 +8626,7 @@
         </p:nvSpPr>
         <p:spPr>
           <a:xfrm>
-            <a:off x="8732520" y="2331720"/>
+            <a:off x="8732520" y="2286000"/>
             <a:ext cx="2834640" cy="292608"/>
           </a:xfrm>
           <a:prstGeom prst="rect">
@@ -8665,7 +8665,7 @@
         </p:nvSpPr>
         <p:spPr>
           <a:xfrm>
-            <a:off x="8732520" y="2615184"/>
+            <a:off x="8732520" y="2569464"/>
             <a:ext cx="2834640" cy="201168"/>
           </a:xfrm>
           <a:prstGeom prst="rect">
@@ -8704,7 +8704,7 @@
         </p:nvSpPr>
         <p:spPr>
           <a:xfrm>
-            <a:off x="8732520" y="3008376"/>
+            <a:off x="8732520" y="2852928"/>
             <a:ext cx="2834640" cy="292608"/>
           </a:xfrm>
           <a:prstGeom prst="rect">
@@ -8743,7 +8743,7 @@
         </p:nvSpPr>
         <p:spPr>
           <a:xfrm>
-            <a:off x="8732520" y="3291840"/>
+            <a:off x="8732520" y="3136392"/>
             <a:ext cx="2834640" cy="201168"/>
           </a:xfrm>
           <a:prstGeom prst="rect">
@@ -8782,7 +8782,7 @@
         </p:nvSpPr>
         <p:spPr>
           <a:xfrm>
-            <a:off x="8732520" y="3685032"/>
+            <a:off x="8732520" y="3419856"/>
             <a:ext cx="2834640" cy="292608"/>
           </a:xfrm>
           <a:prstGeom prst="rect">
@@ -8807,7 +8807,7 @@
                 <a:ea typeface="Montserrat" pitchFamily="34" charset="-122"/>
                 <a:cs typeface="Montserrat" pitchFamily="34" charset="-120"/>
               </a:rPr>
-              <a:t>2.7×</a:t>
+              <a:t>~86%</a:t>
             </a:r>
             <a:endParaRPr lang="en-US" sz="1700" dirty="0"/>
           </a:p>
@@ -8821,7 +8821,7 @@
         </p:nvSpPr>
         <p:spPr>
           <a:xfrm>
-            <a:off x="8732520" y="3968496"/>
+            <a:off x="8732520" y="3703320"/>
             <a:ext cx="2834640" cy="201168"/>
           </a:xfrm>
           <a:prstGeom prst="rect">
@@ -8846,7 +8846,7 @@
                 <a:ea typeface="DM Sans" pitchFamily="34" charset="-122"/>
                 <a:cs typeface="DM Sans" pitchFamily="34" charset="-120"/>
               </a:rPr>
-              <a:t>Return on cost (~$5.3M)</a:t>
+              <a:t>Project IRR (unlevered)</a:t>
             </a:r>
             <a:endParaRPr lang="en-US" sz="850" dirty="0"/>
           </a:p>
@@ -8860,7 +8860,7 @@
         </p:nvSpPr>
         <p:spPr>
           <a:xfrm>
-            <a:off x="8732520" y="4361688"/>
+            <a:off x="8732520" y="3986784"/>
             <a:ext cx="2834640" cy="292608"/>
           </a:xfrm>
           <a:prstGeom prst="rect">
@@ -8885,7 +8885,7 @@
                 <a:ea typeface="Montserrat" pitchFamily="34" charset="-122"/>
                 <a:cs typeface="Montserrat" pitchFamily="34" charset="-120"/>
               </a:rPr>
-              <a:t>$7.2M</a:t>
+              <a:t>2.7×</a:t>
             </a:r>
             <a:endParaRPr lang="en-US" sz="1700" dirty="0"/>
           </a:p>
@@ -8899,7 +8899,7 @@
         </p:nvSpPr>
         <p:spPr>
           <a:xfrm>
-            <a:off x="8732520" y="4645152"/>
+            <a:off x="8732520" y="4270248"/>
             <a:ext cx="2834640" cy="201168"/>
           </a:xfrm>
           <a:prstGeom prst="rect">
@@ -8924,7 +8924,7 @@
                 <a:ea typeface="DM Sans" pitchFamily="34" charset="-122"/>
                 <a:cs typeface="DM Sans" pitchFamily="34" charset="-120"/>
               </a:rPr>
-              <a:t>Development co (50%)</a:t>
+              <a:t>Return on cost (~$5.3M)</a:t>
             </a:r>
             <a:endParaRPr lang="en-US" sz="850" dirty="0"/>
           </a:p>
@@ -8938,7 +8938,7 @@
         </p:nvSpPr>
         <p:spPr>
           <a:xfrm>
-            <a:off x="8732520" y="5038344"/>
+            <a:off x="8732520" y="4553712"/>
             <a:ext cx="2834640" cy="292608"/>
           </a:xfrm>
           <a:prstGeom prst="rect">
@@ -8977,7 +8977,7 @@
         </p:nvSpPr>
         <p:spPr>
           <a:xfrm>
-            <a:off x="8732520" y="5321808"/>
+            <a:off x="8732520" y="4837176"/>
             <a:ext cx="2834640" cy="201168"/>
           </a:xfrm>
           <a:prstGeom prst="rect">
@@ -9002,7 +9002,7 @@
                 <a:ea typeface="DM Sans" pitchFamily="34" charset="-122"/>
                 <a:cs typeface="DM Sans" pitchFamily="34" charset="-120"/>
               </a:rPr>
-              <a:t>Property / investors (50%)</a:t>
+              <a:t>Development co (50%)</a:t>
             </a:r>
             <a:endParaRPr lang="en-US" sz="850" dirty="0"/>
           </a:p>
@@ -9010,23 +9010,42 @@
       </p:sp>
       <p:sp>
         <p:nvSpPr>
-          <p:cNvPr id="62" name="Shape 60"/>
-          <p:cNvSpPr/>
-          <p:nvPr/>
-        </p:nvSpPr>
-        <p:spPr>
-          <a:xfrm>
-            <a:off x="457200" y="5989320"/>
-            <a:ext cx="11274552" cy="420624"/>
-          </a:xfrm>
-          <a:prstGeom prst="rect">
-            <a:avLst/>
-          </a:prstGeom>
-          <a:solidFill>
-            <a:srgbClr val="3A243A"/>
-          </a:solidFill>
-          <a:ln/>
-        </p:spPr>
+          <p:cNvPr id="62" name="Text 60"/>
+          <p:cNvSpPr/>
+          <p:nvPr/>
+        </p:nvSpPr>
+        <p:spPr>
+          <a:xfrm>
+            <a:off x="8732520" y="5120640"/>
+            <a:ext cx="2834640" cy="292608"/>
+          </a:xfrm>
+          <a:prstGeom prst="rect">
+            <a:avLst/>
+          </a:prstGeom>
+          <a:noFill/>
+          <a:ln/>
+        </p:spPr>
+        <p:txBody>
+          <a:bodyPr wrap="square" lIns="0" tIns="0" rIns="0" bIns="0" rtlCol="0" anchor="ctr"/>
+          <a:lstStyle/>
+          <a:p>
+            <a:pPr algn="l" indent="0" marL="0">
+              <a:buNone/>
+            </a:pPr>
+            <a:r>
+              <a:rPr lang="en-US" sz="1700" b="1" dirty="0">
+                <a:solidFill>
+                  <a:srgbClr val="FFFFFF"/>
+                </a:solidFill>
+                <a:latin typeface="Montserrat" pitchFamily="34" charset="0"/>
+                <a:ea typeface="Montserrat" pitchFamily="34" charset="-122"/>
+                <a:cs typeface="Montserrat" pitchFamily="34" charset="-120"/>
+              </a:rPr>
+              <a:t>$7.2M</a:t>
+            </a:r>
+            <a:endParaRPr lang="en-US" sz="1700" dirty="0"/>
+          </a:p>
+        </p:txBody>
       </p:sp>
       <p:sp>
         <p:nvSpPr>
@@ -9036,8 +9055,8 @@
         </p:nvSpPr>
         <p:spPr>
           <a:xfrm>
-            <a:off x="640080" y="5989320"/>
-            <a:ext cx="10908792" cy="420624"/>
+            <a:off x="8732520" y="5404104"/>
+            <a:ext cx="2834640" cy="201168"/>
           </a:xfrm>
           <a:prstGeom prst="rect">
             <a:avLst/>
@@ -9049,19 +9068,78 @@
           <a:bodyPr wrap="square" lIns="0" tIns="0" rIns="0" bIns="0" rtlCol="0" anchor="ctr"/>
           <a:lstStyle/>
           <a:p>
-            <a:pPr algn="ctr" indent="0" marL="0">
-              <a:buNone/>
-            </a:pPr>
-            <a:r>
-              <a:rPr lang="en-US" sz="1100" b="1" dirty="0">
-                <a:solidFill>
-                  <a:srgbClr val="FFFFFF"/>
+            <a:pPr algn="l" indent="0" marL="0">
+              <a:buNone/>
+            </a:pPr>
+            <a:r>
+              <a:rPr lang="en-US" sz="850" dirty="0">
+                <a:solidFill>
+                  <a:srgbClr val="C4B8C4"/>
                 </a:solidFill>
                 <a:latin typeface="DM Sans" pitchFamily="34" charset="0"/>
                 <a:ea typeface="DM Sans" pitchFamily="34" charset="-122"/>
                 <a:cs typeface="DM Sans" pitchFamily="34" charset="-120"/>
               </a:rPr>
-              <a:t>Illustrative: ~$14.3M profit on ~$5.3M of soft cost (~2.7× on cost). Builder funds the horizontal. Costs repaid, then a straight 50/50 — half returns capital to your investors.</a:t>
+              <a:t>Property / investors (50%)</a:t>
+            </a:r>
+            <a:endParaRPr lang="en-US" sz="850" dirty="0"/>
+          </a:p>
+        </p:txBody>
+      </p:sp>
+      <p:sp>
+        <p:nvSpPr>
+          <p:cNvPr id="64" name="Shape 62"/>
+          <p:cNvSpPr/>
+          <p:nvPr/>
+        </p:nvSpPr>
+        <p:spPr>
+          <a:xfrm>
+            <a:off x="457200" y="5989320"/>
+            <a:ext cx="11274552" cy="420624"/>
+          </a:xfrm>
+          <a:prstGeom prst="rect">
+            <a:avLst/>
+          </a:prstGeom>
+          <a:solidFill>
+            <a:srgbClr val="3A243A"/>
+          </a:solidFill>
+          <a:ln/>
+        </p:spPr>
+      </p:sp>
+      <p:sp>
+        <p:nvSpPr>
+          <p:cNvPr id="65" name="Text 63"/>
+          <p:cNvSpPr/>
+          <p:nvPr/>
+        </p:nvSpPr>
+        <p:spPr>
+          <a:xfrm>
+            <a:off x="640080" y="5989320"/>
+            <a:ext cx="10908792" cy="420624"/>
+          </a:xfrm>
+          <a:prstGeom prst="rect">
+            <a:avLst/>
+          </a:prstGeom>
+          <a:noFill/>
+          <a:ln/>
+        </p:spPr>
+        <p:txBody>
+          <a:bodyPr wrap="square" lIns="0" tIns="0" rIns="0" bIns="0" rtlCol="0" anchor="ctr"/>
+          <a:lstStyle/>
+          <a:p>
+            <a:pPr algn="ctr" indent="0" marL="0">
+              <a:buNone/>
+            </a:pPr>
+            <a:r>
+              <a:rPr lang="en-US" sz="1100" b="1" dirty="0">
+                <a:solidFill>
+                  <a:srgbClr val="FFFFFF"/>
+                </a:solidFill>
+                <a:latin typeface="DM Sans" pitchFamily="34" charset="0"/>
+                <a:ea typeface="DM Sans" pitchFamily="34" charset="-122"/>
+                <a:cs typeface="DM Sans" pitchFamily="34" charset="-120"/>
+              </a:rPr>
+              <a:t>Illustrative: ~$14.3M profit on ~$5.3M of soft cost — ~2.7× on cost and a ~86% unlevered IRR on a near-zero land basis. Builder funds the horizontal; costs repaid, then a straight 50/50.</a:t>
             </a:r>
             <a:endParaRPr lang="en-US" sz="1100" dirty="0"/>
           </a:p>
@@ -22444,7 +22522,7 @@
                 <a:ea typeface="DM Sans" pitchFamily="34" charset="-122"/>
                 <a:cs typeface="DM Sans" pitchFamily="34" charset="-120"/>
               </a:rPr>
-              <a:t>Net profit ~$14.3M on ~$5.3M of soft cost (~2.7× on cost); the builder funds the horizontal. Costs repaid, then a straight 50/50.</a:t>
+              <a:t>Net profit ~$14.3M on ~$5.3M of soft cost — ~2.7× on cost, ~86% unlevered project IRR; the builder funds the horizontal. Costs repaid, then a straight 50/50.</a:t>
             </a:r>
             <a:endParaRPr lang="en-US" sz="1100" dirty="0"/>
           </a:p>

</xml_diff>

<commit_message>
Anchor JAL's promote share (~1/3 of the dev-co 50% ≈ ~$2.4M) and show how the comp stacks
- Model: add jalShareOfDevCo (1/3) + jalTake; the split section now shows
  'of which JAL (~1/3 of dev co)' ≈ $2.4M (~17% of profit), live off INPUTS
- 50/50 slide: dev-co box shows 'JAL's share ~1/3 → ~$2.4M' (sweat equity, no capital)
- Engagement slide: 4 numbered layers + a callout on how they interplay —
  retainer funds the work; placement fee only on OUTSIDE capital raised (small on
  capital-light Queenstown, real on the pipeline's acquisition equity); ~1/3 of the
  dev-co 50% is the carry (~$2.4M base); co-invest earns alongside. No double-dip.

https://claude.ai/code/session_01BHWC2bwKRSfRRWtpGYSNwZ
</commit_message>
<xml_diff>
--- a/JAL_Queenstown_Harbor_Proposal.pptx
+++ b/JAL_Queenstown_Harbor_Proposal.pptx
@@ -1847,7 +1847,7 @@
           <a:p>
             <a:r>
               <a:rPr lang="en-US" dirty="0"/>
-              <a:t>Answers Bob's comp question — he pushed for skin in the game over a big retainer. Hybrid: a modest $15K/mo retainer (≈ one day/week) + expenses, then the real upside is a share of the development company's 50% of profit. Plus I intend to put capital into the dev co (amount TBD). Lead with alignment — the retainer is a floor, the profit share is the prize.</a:t>
+              <a:t>Answers Bob's comp question (skin in the game over a big retainer) and shows how the pieces interplay — they stack, but don't double-dip: (1) $15K/mo retainer funds the work (a cost); (2) expenses reimbursed; (3) a placement fee ONLY on outside capital I raise (waived on my own co-invest; small on capital-light Queenstown, meaningful on the pipeline's acquisition equity); (4) the carry — ~1/3 of the dev-co 50% ≈ ~$2.4M on the base case (~17% of profit). If I co-invest, that capital earns alongside everyone else's, separate from the carry. The retainer is a floor; the carry is the prize.</a:t>
             </a:r>
             <a:endParaRPr lang="en-US" dirty="0"/>
           </a:p>
@@ -12174,8 +12174,8 @@
         </p:nvSpPr>
         <p:spPr>
           <a:xfrm>
-            <a:off x="6446520" y="4114800"/>
-            <a:ext cx="5120640" cy="548640"/>
+            <a:off x="6446520" y="4078224"/>
+            <a:ext cx="5120640" cy="502920"/>
           </a:xfrm>
           <a:prstGeom prst="rect">
             <a:avLst/>
@@ -12191,7 +12191,7 @@
               <a:buNone/>
             </a:pPr>
             <a:r>
-              <a:rPr lang="en-US" sz="3400" b="1" dirty="0">
+              <a:rPr lang="en-US" sz="3200" b="1" dirty="0">
                 <a:solidFill>
                   <a:srgbClr val="0B163C"/>
                 </a:solidFill>
@@ -12201,7 +12201,7 @@
               </a:rPr>
               <a:t>$7.2M</a:t>
             </a:r>
-            <a:endParaRPr lang="en-US" sz="3400" dirty="0"/>
+            <a:endParaRPr lang="en-US" sz="3200" dirty="0"/>
           </a:p>
         </p:txBody>
       </p:sp>
@@ -12213,8 +12213,47 @@
         </p:nvSpPr>
         <p:spPr>
           <a:xfrm>
-            <a:off x="6446520" y="4773168"/>
-            <a:ext cx="5120640" cy="731520"/>
+            <a:off x="6446520" y="4608576"/>
+            <a:ext cx="5120640" cy="274320"/>
+          </a:xfrm>
+          <a:prstGeom prst="rect">
+            <a:avLst/>
+          </a:prstGeom>
+          <a:noFill/>
+          <a:ln/>
+        </p:spPr>
+        <p:txBody>
+          <a:bodyPr wrap="square" lIns="0" tIns="0" rIns="0" bIns="0" rtlCol="0" anchor="ctr"/>
+          <a:lstStyle/>
+          <a:p>
+            <a:pPr algn="l" indent="0" marL="0">
+              <a:buNone/>
+            </a:pPr>
+            <a:r>
+              <a:rPr lang="en-US" sz="1400" b="1" dirty="0">
+                <a:solidFill>
+                  <a:srgbClr val="3A243A"/>
+                </a:solidFill>
+                <a:latin typeface="Montserrat" pitchFamily="34" charset="0"/>
+                <a:ea typeface="Montserrat" pitchFamily="34" charset="-122"/>
+                <a:cs typeface="Montserrat" pitchFamily="34" charset="-120"/>
+              </a:rPr>
+              <a:t>JAL's share  ~1/3  →  ~$2.4M</a:t>
+            </a:r>
+            <a:endParaRPr lang="en-US" sz="1400" dirty="0"/>
+          </a:p>
+        </p:txBody>
+      </p:sp>
+      <p:sp>
+        <p:nvSpPr>
+          <p:cNvPr id="34" name="Text 32"/>
+          <p:cNvSpPr/>
+          <p:nvPr/>
+        </p:nvSpPr>
+        <p:spPr>
+          <a:xfrm>
+            <a:off x="6446520" y="4901184"/>
+            <a:ext cx="5120640" cy="603504"/>
           </a:xfrm>
           <a:prstGeom prst="rect">
             <a:avLst/>
@@ -12228,12 +12267,12 @@
           <a:p>
             <a:pPr algn="l" indent="0" marL="0">
               <a:lnSpc>
-                <a:spcPts val="1300"/>
+                <a:spcPts val="1150"/>
               </a:lnSpc>
               <a:buNone/>
             </a:pPr>
             <a:r>
-              <a:rPr lang="en-US" sz="1000" dirty="0">
+              <a:rPr lang="en-US" sz="900" dirty="0">
                 <a:solidFill>
                   <a:srgbClr val="6B5A6B"/>
                 </a:solidFill>
@@ -12241,15 +12280,15 @@
                 <a:ea typeface="DM Sans" pitchFamily="34" charset="-122"/>
                 <a:cs typeface="DM Sans" pitchFamily="34" charset="-120"/>
               </a:rPr>
-              <a:t>Accountable Equity / Capital H6 · Bob · JAL + partners. JAL earns a share of this 50% (plus a $15K/mo retainer) — sweat equity, real skin in the game.</a:t>
-            </a:r>
-            <a:endParaRPr lang="en-US" sz="1000" dirty="0"/>
-          </a:p>
-        </p:txBody>
-      </p:sp>
-      <p:sp>
-        <p:nvSpPr>
-          <p:cNvPr id="34" name="Shape 32"/>
+              <a:t>Accountable Equity / Capital H6 · Bob · partners take the balance. JAL = sweat equity + $15K/mo — no capital required.</a:t>
+            </a:r>
+            <a:endParaRPr lang="en-US" sz="900" dirty="0"/>
+          </a:p>
+        </p:txBody>
+      </p:sp>
+      <p:sp>
+        <p:nvSpPr>
+          <p:cNvPr id="35" name="Shape 33"/>
           <p:cNvSpPr/>
           <p:nvPr/>
         </p:nvSpPr>
@@ -12269,7 +12308,7 @@
       </p:sp>
       <p:sp>
         <p:nvSpPr>
-          <p:cNvPr id="35" name="Text 33"/>
+          <p:cNvPr id="36" name="Text 34"/>
           <p:cNvSpPr/>
           <p:nvPr/>
         </p:nvSpPr>
@@ -29865,7 +29904,7 @@
               <a:buNone/>
             </a:pPr>
             <a:r>
-              <a:rPr lang="en-US" sz="1350" b="1" dirty="0">
+              <a:rPr lang="en-US" sz="1300" b="1" dirty="0">
                 <a:solidFill>
                   <a:srgbClr val="FFFFFF"/>
                 </a:solidFill>
@@ -29873,9 +29912,9 @@
                 <a:ea typeface="Montserrat" pitchFamily="34" charset="-122"/>
                 <a:cs typeface="Montserrat" pitchFamily="34" charset="-120"/>
               </a:rPr>
-              <a:t>$15K/mo + expenses, then a share of the dev-co profit</a:t>
-            </a:r>
-            <a:endParaRPr lang="en-US" sz="1350" dirty="0"/>
+              <a:t>$15K/mo + expenses, then ~1/3 of the dev-co 50% (the carry)</a:t>
+            </a:r>
+            <a:endParaRPr lang="en-US" sz="1300" dirty="0"/>
           </a:p>
         </p:txBody>
       </p:sp>
@@ -30213,7 +30252,7 @@
                 <a:ea typeface="Montserrat" pitchFamily="34" charset="-122"/>
                 <a:cs typeface="Montserrat" pitchFamily="34" charset="-120"/>
               </a:rPr>
-              <a:t>Advisory retainer</a:t>
+              <a:t>1 · Advisory retainer</a:t>
             </a:r>
             <a:endParaRPr lang="en-US" sz="1100" dirty="0"/>
           </a:p>
@@ -30334,7 +30373,7 @@
                 <a:ea typeface="DM Sans" pitchFamily="34" charset="-122"/>
                 <a:cs typeface="DM Sans" pitchFamily="34" charset="-120"/>
               </a:rPr>
-              <a:t>Funds entitlement, underwriting &amp; capital sourcing during an initial term</a:t>
+              <a:t>Funds the work during entitlement — a floor; a cost to the deal, not netted from the carry</a:t>
             </a:r>
             <a:endParaRPr lang="en-US" sz="950" dirty="0"/>
           </a:p>
@@ -30393,7 +30432,7 @@
                 <a:ea typeface="Montserrat" pitchFamily="34" charset="-122"/>
                 <a:cs typeface="Montserrat" pitchFamily="34" charset="-120"/>
               </a:rPr>
-              <a:t>Expenses</a:t>
+              <a:t>2 · Expenses</a:t>
             </a:r>
             <a:endParaRPr lang="en-US" sz="1100" dirty="0"/>
           </a:p>
@@ -30514,7 +30553,7 @@
                 <a:ea typeface="DM Sans" pitchFamily="34" charset="-122"/>
                 <a:cs typeface="DM Sans" pitchFamily="34" charset="-120"/>
               </a:rPr>
-              <a:t>Travel, survey, market &amp; entitlement studies — billed separately, not netted from fees</a:t>
+              <a:t>Travel, survey, market &amp; entitlement studies — billed separately</a:t>
             </a:r>
             <a:endParaRPr lang="en-US" sz="950" dirty="0"/>
           </a:p>
@@ -30573,7 +30612,7 @@
                 <a:ea typeface="Montserrat" pitchFamily="34" charset="-122"/>
                 <a:cs typeface="Montserrat" pitchFamily="34" charset="-120"/>
               </a:rPr>
-              <a:t>Capital placement fee</a:t>
+              <a:t>3 · Capital placement fee</a:t>
             </a:r>
             <a:endParaRPr lang="en-US" sz="1100" dirty="0"/>
           </a:p>
@@ -30694,7 +30733,7 @@
                 <a:ea typeface="DM Sans" pitchFamily="34" charset="-122"/>
                 <a:cs typeface="DM Sans" pitchFamily="34" charset="-120"/>
               </a:rPr>
-              <a:t>Success fee — 2% of equity raised (1% of debt placed) for a parcel</a:t>
+              <a:t>On outside capital I place — small on capital-light Queenstown, real on the pipeline's acquisition equity</a:t>
             </a:r>
             <a:endParaRPr lang="en-US" sz="950" dirty="0"/>
           </a:p>
@@ -30753,7 +30792,7 @@
                 <a:ea typeface="Montserrat" pitchFamily="34" charset="-122"/>
                 <a:cs typeface="Montserrat" pitchFamily="34" charset="-120"/>
               </a:rPr>
-              <a:t>Profit share</a:t>
+              <a:t>4 · Profit share (carry)</a:t>
             </a:r>
             <a:endParaRPr lang="en-US" sz="1100" dirty="0"/>
           </a:p>
@@ -30812,7 +30851,7 @@
                 <a:ea typeface="Montserrat" pitchFamily="34" charset="-122"/>
                 <a:cs typeface="Montserrat" pitchFamily="34" charset="-120"/>
               </a:rPr>
-              <a:t>Share of dev-co 50%</a:t>
+              <a:t>~1/3 of dev-co 50%</a:t>
             </a:r>
             <a:endParaRPr lang="en-US" sz="1100" dirty="0"/>
           </a:p>
@@ -30874,7 +30913,7 @@
                 <a:ea typeface="DM Sans" pitchFamily="34" charset="-122"/>
                 <a:cs typeface="DM Sans" pitchFamily="34" charset="-120"/>
               </a:rPr>
-              <a:t>A share of the development company's 50% of profit (with Accountable Equity, Bob &amp; partners)</a:t>
+              <a:t>≈ ~$2.4M on the Queenstown base case (~17% of profit); Bob &amp; partners take the balance</a:t>
             </a:r>
             <a:endParaRPr lang="en-US" sz="950" dirty="0"/>
           </a:p>
@@ -30933,7 +30972,7 @@
                 <a:ea typeface="DM Sans" pitchFamily="34" charset="-122"/>
                 <a:cs typeface="DM Sans" pitchFamily="34" charset="-120"/>
               </a:rPr>
-              <a:t>The structure flexes to the deal — the point is alignment: I win when you win.</a:t>
+              <a:t>They stack cleanly: retainer funds the work · placement fee only on outside capital I raise · ~1/3 of the dev-co 50% (~$2.4M base) is the carry · any co-invest earns alongside. No double-dip.</a:t>
             </a:r>
             <a:endParaRPr lang="en-US" sz="1100" dirty="0"/>
           </a:p>

</xml_diff>

<commit_message>
Show JAL's illustrative all-in take (~$2.9M) — carry + retainer
- Model: add retainerMo/engMonths inputs; compute retainerTotal + jalAllIn; the
  split section now shows carry (~$2.4M) + retainer (~$0.5M) = all-in (~$2.9M)
- Engagement slide: add a total-take row — '= Illustrative all-in (base case)
  ~$2.9M' (~20% of profit, mostly the contingent carry); callout reframed to
  'aligned, not double-dipping; most of the ~$2.9M is contingent on the upside'
- Keeps the $15K/mo floor + the 1/3 carry; the all-in is shown transparently

https://claude.ai/code/session_01BHWC2bwKRSfRRWtpGYSNwZ
</commit_message>
<xml_diff>
--- a/JAL_Queenstown_Harbor_Proposal.pptx
+++ b/JAL_Queenstown_Harbor_Proposal.pptx
@@ -30208,7 +30208,7 @@
         <p:spPr>
           <a:xfrm>
             <a:off x="457200" y="3218688"/>
-            <a:ext cx="3108960" cy="640080"/>
+            <a:ext cx="3108960" cy="530352"/>
           </a:xfrm>
           <a:prstGeom prst="rect">
             <a:avLst/>
@@ -30228,7 +30228,7 @@
         <p:spPr>
           <a:xfrm>
             <a:off x="457200" y="3218688"/>
-            <a:ext cx="3108960" cy="640080"/>
+            <a:ext cx="3108960" cy="530352"/>
           </a:xfrm>
           <a:prstGeom prst="rect">
             <a:avLst/>
@@ -30267,7 +30267,7 @@
         <p:spPr>
           <a:xfrm>
             <a:off x="3566160" y="3218688"/>
-            <a:ext cx="2743200" cy="640080"/>
+            <a:ext cx="2743200" cy="530352"/>
           </a:xfrm>
           <a:prstGeom prst="rect">
             <a:avLst/>
@@ -30287,7 +30287,7 @@
         <p:spPr>
           <a:xfrm>
             <a:off x="3566160" y="3218688"/>
-            <a:ext cx="2743200" cy="640080"/>
+            <a:ext cx="2743200" cy="530352"/>
           </a:xfrm>
           <a:prstGeom prst="rect">
             <a:avLst/>
@@ -30326,7 +30326,7 @@
         <p:spPr>
           <a:xfrm>
             <a:off x="6309360" y="3218688"/>
-            <a:ext cx="5422392" cy="640080"/>
+            <a:ext cx="5422392" cy="530352"/>
           </a:xfrm>
           <a:prstGeom prst="rect">
             <a:avLst/>
@@ -30346,7 +30346,7 @@
         <p:spPr>
           <a:xfrm>
             <a:off x="6309360" y="3218688"/>
-            <a:ext cx="5422392" cy="640080"/>
+            <a:ext cx="5422392" cy="530352"/>
           </a:xfrm>
           <a:prstGeom prst="rect">
             <a:avLst/>
@@ -30387,8 +30387,8 @@
         </p:nvSpPr>
         <p:spPr>
           <a:xfrm>
-            <a:off x="457200" y="3858768"/>
-            <a:ext cx="3108960" cy="640080"/>
+            <a:off x="457200" y="3749040"/>
+            <a:ext cx="3108960" cy="530352"/>
           </a:xfrm>
           <a:prstGeom prst="rect">
             <a:avLst/>
@@ -30407,8 +30407,8 @@
         </p:nvSpPr>
         <p:spPr>
           <a:xfrm>
-            <a:off x="457200" y="3858768"/>
-            <a:ext cx="3108960" cy="640080"/>
+            <a:off x="457200" y="3749040"/>
+            <a:ext cx="3108960" cy="530352"/>
           </a:xfrm>
           <a:prstGeom prst="rect">
             <a:avLst/>
@@ -30446,8 +30446,8 @@
         </p:nvSpPr>
         <p:spPr>
           <a:xfrm>
-            <a:off x="3566160" y="3858768"/>
-            <a:ext cx="2743200" cy="640080"/>
+            <a:off x="3566160" y="3749040"/>
+            <a:ext cx="2743200" cy="530352"/>
           </a:xfrm>
           <a:prstGeom prst="rect">
             <a:avLst/>
@@ -30466,8 +30466,8 @@
         </p:nvSpPr>
         <p:spPr>
           <a:xfrm>
-            <a:off x="3566160" y="3858768"/>
-            <a:ext cx="2743200" cy="640080"/>
+            <a:off x="3566160" y="3749040"/>
+            <a:ext cx="2743200" cy="530352"/>
           </a:xfrm>
           <a:prstGeom prst="rect">
             <a:avLst/>
@@ -30505,8 +30505,8 @@
         </p:nvSpPr>
         <p:spPr>
           <a:xfrm>
-            <a:off x="6309360" y="3858768"/>
-            <a:ext cx="5422392" cy="640080"/>
+            <a:off x="6309360" y="3749040"/>
+            <a:ext cx="5422392" cy="530352"/>
           </a:xfrm>
           <a:prstGeom prst="rect">
             <a:avLst/>
@@ -30525,8 +30525,8 @@
         </p:nvSpPr>
         <p:spPr>
           <a:xfrm>
-            <a:off x="6309360" y="3858768"/>
-            <a:ext cx="5422392" cy="640080"/>
+            <a:off x="6309360" y="3749040"/>
+            <a:ext cx="5422392" cy="530352"/>
           </a:xfrm>
           <a:prstGeom prst="rect">
             <a:avLst/>
@@ -30567,8 +30567,8 @@
         </p:nvSpPr>
         <p:spPr>
           <a:xfrm>
-            <a:off x="457200" y="4498848"/>
-            <a:ext cx="3108960" cy="640080"/>
+            <a:off x="457200" y="4279392"/>
+            <a:ext cx="3108960" cy="530352"/>
           </a:xfrm>
           <a:prstGeom prst="rect">
             <a:avLst/>
@@ -30587,8 +30587,8 @@
         </p:nvSpPr>
         <p:spPr>
           <a:xfrm>
-            <a:off x="457200" y="4498848"/>
-            <a:ext cx="3108960" cy="640080"/>
+            <a:off x="457200" y="4279392"/>
+            <a:ext cx="3108960" cy="530352"/>
           </a:xfrm>
           <a:prstGeom prst="rect">
             <a:avLst/>
@@ -30626,8 +30626,8 @@
         </p:nvSpPr>
         <p:spPr>
           <a:xfrm>
-            <a:off x="3566160" y="4498848"/>
-            <a:ext cx="2743200" cy="640080"/>
+            <a:off x="3566160" y="4279392"/>
+            <a:ext cx="2743200" cy="530352"/>
           </a:xfrm>
           <a:prstGeom prst="rect">
             <a:avLst/>
@@ -30646,8 +30646,8 @@
         </p:nvSpPr>
         <p:spPr>
           <a:xfrm>
-            <a:off x="3566160" y="4498848"/>
-            <a:ext cx="2743200" cy="640080"/>
+            <a:off x="3566160" y="4279392"/>
+            <a:ext cx="2743200" cy="530352"/>
           </a:xfrm>
           <a:prstGeom prst="rect">
             <a:avLst/>
@@ -30685,8 +30685,8 @@
         </p:nvSpPr>
         <p:spPr>
           <a:xfrm>
-            <a:off x="6309360" y="4498848"/>
-            <a:ext cx="5422392" cy="640080"/>
+            <a:off x="6309360" y="4279392"/>
+            <a:ext cx="5422392" cy="530352"/>
           </a:xfrm>
           <a:prstGeom prst="rect">
             <a:avLst/>
@@ -30705,8 +30705,8 @@
         </p:nvSpPr>
         <p:spPr>
           <a:xfrm>
-            <a:off x="6309360" y="4498848"/>
-            <a:ext cx="5422392" cy="640080"/>
+            <a:off x="6309360" y="4279392"/>
+            <a:ext cx="5422392" cy="530352"/>
           </a:xfrm>
           <a:prstGeom prst="rect">
             <a:avLst/>
@@ -30747,8 +30747,8 @@
         </p:nvSpPr>
         <p:spPr>
           <a:xfrm>
-            <a:off x="457200" y="5138928"/>
-            <a:ext cx="3108960" cy="640080"/>
+            <a:off x="457200" y="4809744"/>
+            <a:ext cx="3108960" cy="530352"/>
           </a:xfrm>
           <a:prstGeom prst="rect">
             <a:avLst/>
@@ -30767,8 +30767,8 @@
         </p:nvSpPr>
         <p:spPr>
           <a:xfrm>
-            <a:off x="457200" y="5138928"/>
-            <a:ext cx="3108960" cy="640080"/>
+            <a:off x="457200" y="4809744"/>
+            <a:ext cx="3108960" cy="530352"/>
           </a:xfrm>
           <a:prstGeom prst="rect">
             <a:avLst/>
@@ -30806,8 +30806,8 @@
         </p:nvSpPr>
         <p:spPr>
           <a:xfrm>
-            <a:off x="3566160" y="5138928"/>
-            <a:ext cx="2743200" cy="640080"/>
+            <a:off x="3566160" y="4809744"/>
+            <a:ext cx="2743200" cy="530352"/>
           </a:xfrm>
           <a:prstGeom prst="rect">
             <a:avLst/>
@@ -30826,8 +30826,8 @@
         </p:nvSpPr>
         <p:spPr>
           <a:xfrm>
-            <a:off x="3566160" y="5138928"/>
-            <a:ext cx="2743200" cy="640080"/>
+            <a:off x="3566160" y="4809744"/>
+            <a:ext cx="2743200" cy="530352"/>
           </a:xfrm>
           <a:prstGeom prst="rect">
             <a:avLst/>
@@ -30865,8 +30865,8 @@
         </p:nvSpPr>
         <p:spPr>
           <a:xfrm>
-            <a:off x="6309360" y="5138928"/>
-            <a:ext cx="5422392" cy="640080"/>
+            <a:off x="6309360" y="4809744"/>
+            <a:ext cx="5422392" cy="530352"/>
           </a:xfrm>
           <a:prstGeom prst="rect">
             <a:avLst/>
@@ -30885,8 +30885,8 @@
         </p:nvSpPr>
         <p:spPr>
           <a:xfrm>
-            <a:off x="6309360" y="5138928"/>
-            <a:ext cx="5422392" cy="640080"/>
+            <a:off x="6309360" y="4809744"/>
+            <a:ext cx="5422392" cy="530352"/>
           </a:xfrm>
           <a:prstGeom prst="rect">
             <a:avLst/>
@@ -30927,14 +30927,14 @@
         </p:nvSpPr>
         <p:spPr>
           <a:xfrm>
-            <a:off x="457200" y="5943600"/>
-            <a:ext cx="11274552" cy="420624"/>
-          </a:xfrm>
-          <a:prstGeom prst="rect">
-            <a:avLst/>
-          </a:prstGeom>
-          <a:solidFill>
-            <a:srgbClr val="3A243A"/>
+            <a:off x="457200" y="5340096"/>
+            <a:ext cx="3108960" cy="530352"/>
+          </a:xfrm>
+          <a:prstGeom prst="rect">
+            <a:avLst/>
+          </a:prstGeom>
+          <a:solidFill>
+            <a:srgbClr val="FFFFFF"/>
           </a:solidFill>
           <a:ln/>
         </p:spPr>
@@ -30947,17 +30947,76 @@
         </p:nvSpPr>
         <p:spPr>
           <a:xfrm>
-            <a:off x="640080" y="5943600"/>
-            <a:ext cx="10908792" cy="420624"/>
-          </a:xfrm>
-          <a:prstGeom prst="rect">
-            <a:avLst/>
-          </a:prstGeom>
-          <a:noFill/>
-          <a:ln/>
-        </p:spPr>
-        <p:txBody>
-          <a:bodyPr wrap="square" lIns="0" tIns="0" rIns="0" bIns="0" rtlCol="0" anchor="ctr"/>
+            <a:off x="457200" y="5340096"/>
+            <a:ext cx="3108960" cy="530352"/>
+          </a:xfrm>
+          <a:prstGeom prst="rect">
+            <a:avLst/>
+          </a:prstGeom>
+          <a:noFill/>
+          <a:ln/>
+        </p:spPr>
+        <p:txBody>
+          <a:bodyPr wrap="square" lIns="25400" tIns="76200" rIns="76200" bIns="25400" rtlCol="0" anchor="ctr"/>
+          <a:lstStyle/>
+          <a:p>
+            <a:pPr algn="l" indent="0" marL="0">
+              <a:buNone/>
+            </a:pPr>
+            <a:r>
+              <a:rPr lang="en-US" sz="1100" b="1" dirty="0">
+                <a:solidFill>
+                  <a:srgbClr val="0B163C"/>
+                </a:solidFill>
+                <a:latin typeface="Montserrat" pitchFamily="34" charset="0"/>
+                <a:ea typeface="Montserrat" pitchFamily="34" charset="-122"/>
+                <a:cs typeface="Montserrat" pitchFamily="34" charset="-120"/>
+              </a:rPr>
+              <a:t>= Illustrative all-in (base case)</a:t>
+            </a:r>
+            <a:endParaRPr lang="en-US" sz="1100" dirty="0"/>
+          </a:p>
+        </p:txBody>
+      </p:sp>
+      <p:sp>
+        <p:nvSpPr>
+          <p:cNvPr id="49" name="Shape 47"/>
+          <p:cNvSpPr/>
+          <p:nvPr/>
+        </p:nvSpPr>
+        <p:spPr>
+          <a:xfrm>
+            <a:off x="3566160" y="5340096"/>
+            <a:ext cx="2743200" cy="530352"/>
+          </a:xfrm>
+          <a:prstGeom prst="rect">
+            <a:avLst/>
+          </a:prstGeom>
+          <a:solidFill>
+            <a:srgbClr val="FFFFFF"/>
+          </a:solidFill>
+          <a:ln/>
+        </p:spPr>
+      </p:sp>
+      <p:sp>
+        <p:nvSpPr>
+          <p:cNvPr id="50" name="Text 48"/>
+          <p:cNvSpPr/>
+          <p:nvPr/>
+        </p:nvSpPr>
+        <p:spPr>
+          <a:xfrm>
+            <a:off x="3566160" y="5340096"/>
+            <a:ext cx="2743200" cy="530352"/>
+          </a:xfrm>
+          <a:prstGeom prst="rect">
+            <a:avLst/>
+          </a:prstGeom>
+          <a:noFill/>
+          <a:ln/>
+        </p:spPr>
+        <p:txBody>
+          <a:bodyPr wrap="square" lIns="25400" tIns="76200" rIns="76200" bIns="25400" rtlCol="0" anchor="ctr"/>
           <a:lstStyle/>
           <a:p>
             <a:pPr algn="ctr" indent="0" marL="0">
@@ -30966,13 +31025,134 @@
             <a:r>
               <a:rPr lang="en-US" sz="1100" b="1" dirty="0">
                 <a:solidFill>
-                  <a:srgbClr val="FFFFFF"/>
+                  <a:srgbClr val="3A243A"/>
+                </a:solidFill>
+                <a:latin typeface="Montserrat" pitchFamily="34" charset="0"/>
+                <a:ea typeface="Montserrat" pitchFamily="34" charset="-122"/>
+                <a:cs typeface="Montserrat" pitchFamily="34" charset="-120"/>
+              </a:rPr>
+              <a:t>~$2.9M</a:t>
+            </a:r>
+            <a:endParaRPr lang="en-US" sz="1100" dirty="0"/>
+          </a:p>
+        </p:txBody>
+      </p:sp>
+      <p:sp>
+        <p:nvSpPr>
+          <p:cNvPr id="51" name="Shape 49"/>
+          <p:cNvSpPr/>
+          <p:nvPr/>
+        </p:nvSpPr>
+        <p:spPr>
+          <a:xfrm>
+            <a:off x="6309360" y="5340096"/>
+            <a:ext cx="5422392" cy="530352"/>
+          </a:xfrm>
+          <a:prstGeom prst="rect">
+            <a:avLst/>
+          </a:prstGeom>
+          <a:solidFill>
+            <a:srgbClr val="FFFFFF"/>
+          </a:solidFill>
+          <a:ln/>
+        </p:spPr>
+      </p:sp>
+      <p:sp>
+        <p:nvSpPr>
+          <p:cNvPr id="52" name="Text 50"/>
+          <p:cNvSpPr/>
+          <p:nvPr/>
+        </p:nvSpPr>
+        <p:spPr>
+          <a:xfrm>
+            <a:off x="6309360" y="5340096"/>
+            <a:ext cx="5422392" cy="530352"/>
+          </a:xfrm>
+          <a:prstGeom prst="rect">
+            <a:avLst/>
+          </a:prstGeom>
+          <a:noFill/>
+          <a:ln/>
+        </p:spPr>
+        <p:txBody>
+          <a:bodyPr wrap="square" lIns="25400" tIns="76200" rIns="76200" bIns="25400" rtlCol="0" anchor="ctr"/>
+          <a:lstStyle/>
+          <a:p>
+            <a:pPr algn="l" indent="0" marL="0">
+              <a:lnSpc>
+                <a:spcPts val="1200"/>
+              </a:lnSpc>
+              <a:buNone/>
+            </a:pPr>
+            <a:r>
+              <a:rPr lang="en-US" sz="950" dirty="0">
+                <a:solidFill>
+                  <a:srgbClr val="0B163C"/>
                 </a:solidFill>
                 <a:latin typeface="DM Sans" pitchFamily="34" charset="0"/>
                 <a:ea typeface="DM Sans" pitchFamily="34" charset="-122"/>
                 <a:cs typeface="DM Sans" pitchFamily="34" charset="-120"/>
               </a:rPr>
-              <a:t>They stack cleanly: retainer funds the work · placement fee only on outside capital I raise · ~1/3 of the dev-co 50% (~$2.4M base) is the carry · any co-invest earns alongside. No double-dip.</a:t>
+              <a:t>~$2.4M carry + ~$0.5M retainer (~3 yrs) — ~20% of profit, mostly the contingent carry</a:t>
+            </a:r>
+            <a:endParaRPr lang="en-US" sz="950" dirty="0"/>
+          </a:p>
+        </p:txBody>
+      </p:sp>
+      <p:sp>
+        <p:nvSpPr>
+          <p:cNvPr id="53" name="Shape 51"/>
+          <p:cNvSpPr/>
+          <p:nvPr/>
+        </p:nvSpPr>
+        <p:spPr>
+          <a:xfrm>
+            <a:off x="457200" y="5870448"/>
+            <a:ext cx="11274552" cy="420624"/>
+          </a:xfrm>
+          <a:prstGeom prst="rect">
+            <a:avLst/>
+          </a:prstGeom>
+          <a:solidFill>
+            <a:srgbClr val="3A243A"/>
+          </a:solidFill>
+          <a:ln/>
+        </p:spPr>
+      </p:sp>
+      <p:sp>
+        <p:nvSpPr>
+          <p:cNvPr id="54" name="Text 52"/>
+          <p:cNvSpPr/>
+          <p:nvPr/>
+        </p:nvSpPr>
+        <p:spPr>
+          <a:xfrm>
+            <a:off x="640080" y="5870448"/>
+            <a:ext cx="10908792" cy="420624"/>
+          </a:xfrm>
+          <a:prstGeom prst="rect">
+            <a:avLst/>
+          </a:prstGeom>
+          <a:noFill/>
+          <a:ln/>
+        </p:spPr>
+        <p:txBody>
+          <a:bodyPr wrap="square" lIns="0" tIns="0" rIns="0" bIns="0" rtlCol="0" anchor="ctr"/>
+          <a:lstStyle/>
+          <a:p>
+            <a:pPr algn="ctr" indent="0" marL="0">
+              <a:buNone/>
+            </a:pPr>
+            <a:r>
+              <a:rPr lang="en-US" sz="1100" b="1" dirty="0">
+                <a:solidFill>
+                  <a:srgbClr val="FFFFFF"/>
+                </a:solidFill>
+                <a:latin typeface="DM Sans" pitchFamily="34" charset="0"/>
+                <a:ea typeface="DM Sans" pitchFamily="34" charset="-122"/>
+                <a:cs typeface="DM Sans" pitchFamily="34" charset="-120"/>
+              </a:rPr>
+              <a:t>Aligned, not double-dipping: the retainer is a floor, placement fees only on outside capital I raise, and the carry (~1/3 of the dev-co 50%) is the prize — most of the ~$2.9M is contingent on the upside.</a:t>
             </a:r>
             <a:endParaRPr lang="en-US" sz="1100" dirty="0"/>
           </a:p>

</xml_diff>

<commit_message>
Set JAL economics to the clean market recommendation: 30% of the dev-co 50%
Final market call (flat, simple, defensible — and consistent with Bob's
'keep it simple / skin in the game'):
- Carry: 30% of the dev-co 50% (flat) ≈ ~$2.1M (~15% of profit) — down from 1/3;
  the generous $15K/mo floor sits alongside a solid-market (not top) carry
- Retainer: $15K/mo, non-creditable floor (kept)
- Placement fee: 1% debt / 2% equity, on OUTSIDE capital only
- Co-invest: optional, pari-passu
- All-in ≈ ~$2.7M (~19% of profit), mostly contingent carry
- Model recomputes (jalShareOfDevCo 1/3 -> 0.30); deck (50/50 + Engagement) and
  README updated to match

https://claude.ai/code/session_01BHWC2bwKRSfRRWtpGYSNwZ
</commit_message>
<xml_diff>
--- a/JAL_Queenstown_Harbor_Proposal.pptx
+++ b/JAL_Queenstown_Harbor_Proposal.pptx
@@ -1847,7 +1847,7 @@
           <a:p>
             <a:r>
               <a:rPr lang="en-US" dirty="0"/>
-              <a:t>Answers Bob's comp question (skin in the game over a big retainer) and shows how the pieces interplay — they stack, but don't double-dip: (1) $15K/mo retainer funds the work (a cost); (2) expenses reimbursed; (3) a placement fee ONLY on outside capital I raise (waived on my own co-invest; small on capital-light Queenstown, meaningful on the pipeline's acquisition equity); (4) the carry — ~1/3 of the dev-co 50% ≈ ~$2.4M on the base case (~17% of profit). If I co-invest, that capital earns alongside everyone else's, separate from the carry. The retainer is a floor; the carry is the prize.</a:t>
+              <a:t>Answers Bob's comp question (skin in the game over a big retainer) and shows how the pieces interplay — they stack, but don't double-dip: (1) $15K/mo retainer funds the work (a cost); (2) expenses reimbursed; (3) a placement fee ONLY on outside capital I raise (waived on my own co-invest; small on capital-light Queenstown, meaningful on the pipeline's acquisition equity); (4) the carry — 30% of the dev-co 50% ≈ ~$2.1M on the base case (~15% of profit). If I co-invest, that capital earns alongside everyone else's, separate from the carry. The retainer is a floor; the carry is the prize.</a:t>
             </a:r>
             <a:endParaRPr lang="en-US" dirty="0"/>
           </a:p>
@@ -12238,7 +12238,7 @@
                 <a:ea typeface="Montserrat" pitchFamily="34" charset="-122"/>
                 <a:cs typeface="Montserrat" pitchFamily="34" charset="-120"/>
               </a:rPr>
-              <a:t>JAL's share  ~1/3  →  ~$2.4M</a:t>
+              <a:t>JAL's share  30%  →  ~$2.1M</a:t>
             </a:r>
             <a:endParaRPr lang="en-US" sz="1400" dirty="0"/>
           </a:p>
@@ -29912,7 +29912,7 @@
                 <a:ea typeface="Montserrat" pitchFamily="34" charset="-122"/>
                 <a:cs typeface="Montserrat" pitchFamily="34" charset="-120"/>
               </a:rPr>
-              <a:t>$15K/mo + expenses, then ~1/3 of the dev-co 50% (the carry)</a:t>
+              <a:t>$15K/mo + expenses, then 30% of the dev-co 50% (the carry)</a:t>
             </a:r>
             <a:endParaRPr lang="en-US" sz="1300" dirty="0"/>
           </a:p>
@@ -30851,7 +30851,7 @@
                 <a:ea typeface="Montserrat" pitchFamily="34" charset="-122"/>
                 <a:cs typeface="Montserrat" pitchFamily="34" charset="-120"/>
               </a:rPr>
-              <a:t>~1/3 of dev-co 50%</a:t>
+              <a:t>30% of dev-co 50%</a:t>
             </a:r>
             <a:endParaRPr lang="en-US" sz="1100" dirty="0"/>
           </a:p>
@@ -30913,7 +30913,7 @@
                 <a:ea typeface="DM Sans" pitchFamily="34" charset="-122"/>
                 <a:cs typeface="DM Sans" pitchFamily="34" charset="-120"/>
               </a:rPr>
-              <a:t>≈ ~$2.4M on the Queenstown base case (~17% of profit); Bob &amp; partners take the balance</a:t>
+              <a:t>≈ ~$2.1M on the Queenstown base case (~15% of profit); Bob &amp; partners take the balance</a:t>
             </a:r>
             <a:endParaRPr lang="en-US" sz="950" dirty="0"/>
           </a:p>
@@ -31031,7 +31031,7 @@
                 <a:ea typeface="Montserrat" pitchFamily="34" charset="-122"/>
                 <a:cs typeface="Montserrat" pitchFamily="34" charset="-120"/>
               </a:rPr>
-              <a:t>~$2.9M</a:t>
+              <a:t>~$2.7M</a:t>
             </a:r>
             <a:endParaRPr lang="en-US" sz="1100" dirty="0"/>
           </a:p>
@@ -31093,7 +31093,7 @@
                 <a:ea typeface="DM Sans" pitchFamily="34" charset="-122"/>
                 <a:cs typeface="DM Sans" pitchFamily="34" charset="-120"/>
               </a:rPr>
-              <a:t>~$2.4M carry + ~$0.5M retainer (~3 yrs) — ~20% of profit, mostly the contingent carry</a:t>
+              <a:t>~$2.1M carry + ~$0.5M retainer (~3 yrs) — ~19% of profit, mostly the contingent carry</a:t>
             </a:r>
             <a:endParaRPr lang="en-US" sz="950" dirty="0"/>
           </a:p>
@@ -31152,7 +31152,7 @@
                 <a:ea typeface="DM Sans" pitchFamily="34" charset="-122"/>
                 <a:cs typeface="DM Sans" pitchFamily="34" charset="-120"/>
               </a:rPr>
-              <a:t>Aligned, not double-dipping: the retainer is a floor, placement fees only on outside capital I raise, and the carry (~1/3 of the dev-co 50%) is the prize — most of the ~$2.9M is contingent on the upside.</a:t>
+              <a:t>Aligned, not double-dipping: the retainer is a floor, placement fees only on outside capital I raise, and the carry (30% of the dev-co 50%) is the prize — most of the ~$2.7M is contingent on the upside.</a:t>
             </a:r>
             <a:endParaRPr lang="en-US" sz="1100" dirty="0"/>
           </a:p>

</xml_diff>

<commit_message>
Dynamically link the deck to the model — figures render from the engine, can't drift
generate.js now require()s model.js and renders every model-derived figure
(totals, 50/50 split, JAL carry/all-in, both cash-flow tables, both sensitivity
grids, plus the descs/callouts/notes that restate them) from the engine via a
small MV formatting layer. No financial number is hardcoded in the deck.

- model.js: export the engine; write the .xlsx only on direct run (require.main)
- generate.js: + MODEL link, formatters, cfRows/p2cfRows helpers, MV object
- Verified: rendered deck reproduces all figures byte-for-byte (29/29), 26
  slides, 0 OOB; dynamic test (entitledPx 70k->90k) flows through to revenue,
  profit, carry — and reverts clean. README documents the link.

https://claude.ai/code/session_01BHWC2bwKRSfRRWtpGYSNwZ
</commit_message>
<xml_diff>
--- a/JAL_Queenstown_Harbor_Proposal.pptx
+++ b/JAL_Queenstown_Harbor_Proposal.pptx
@@ -791,7 +791,7 @@
           <a:p>
             <a:r>
               <a:rPr lang="en-US" dirty="0"/>
-              <a:t>Capital-light entitled-lot pro forma, consistent with slide 6. $19.6M revenue − $5.3M soft cost ≈ $14.3M profit (~2.7× on cost, 73% margin) on a near-zero land basis; the builder funds the horizontal. Costs repaid first, then a straight 50/50 — $7.2M to the property (Josh ~$3.6M, returning capital to his investors) and $7.2M to the development company (Bob · JAL · partners). No pref, no promote. Model = source of truth. All illustrative.</a:t>
+              <a:t>Capital-light entitled-lot pro forma. Revenue − soft cost ≈ profit (~2.7× on cost, ~73% margin) on a near-zero land basis; the builder funds the horizontal. Costs repaid first, then a straight 50/50 — half to the property (Josh ~25%, returning capital to his investors) and half to the development company. Every figure renders from model.js (the source of truth).</a:t>
             </a:r>
             <a:endParaRPr lang="en-US" dirty="0"/>
           </a:p>
@@ -1231,7 +1231,7 @@
           <a:p>
             <a:r>
               <a:rPr lang="en-US" dirty="0"/>
-              <a:t>Phase 2 = hospitality upside, VIVÂMEE-led; JAL leads capital formation. A 120-key resort &amp; spa is already designed (FILLAT+ Architecture), validating the program. Two cases in the model: hold for income (~8% YoC, ~12% IRR — the floor) or BUILD-TO-CORE — recap/sell at stabilization (~Yr 4) at a 7.5% cap, capturing the development spread from the contributed land + premium NOI → ~28% IRR / ~2.3x. Build-to-core lets JAL earn the development return while VIVÂMEE keeps and operates the resort. Model is source of truth.</a:t>
+              <a:t>Phase 2 = hospitality upside, VIVÂMEE-led; JAL leads capital formation. A 120-key resort &amp; spa is already designed (FILLAT+ Architecture), validating the program. Two cases in the model: hold for income (~8% YoC, ~12% IRR — the floor) or BUILD-TO-CORE — recap/sell at stabilization (~Yr 4) at a 7.5% cap, capturing the development spread from the contributed land + premium NOI → ~28% IRR / ~2.3×. Build-to-core lets JAL earn the development return while VIVÂMEE keeps and operates the resort. Model is source of truth.</a:t>
             </a:r>
             <a:endParaRPr lang="en-US" dirty="0"/>
           </a:p>
@@ -1319,7 +1319,7 @@
           <a:p>
             <a:r>
               <a:rPr lang="en-US" dirty="0"/>
-              <a:t>Phase 2 build-to-core IRR sensitized to stabilized NOI × exit cap (the development spread). Base $4.65M NOI / 7.5% cap → ~28%. Premium NOI ($5.15M) or a 7% cap pushes it to the mid-30s; an 8.5% cap or soft NOI drops it to ~12–20%. 65% LTC, recap at stabilization. Model is the source of truth.</a:t>
+              <a:t>Phase 2 build-to-core IRR sensitized to stabilized NOI × exit cap (the development spread). Base $4.7M NOI / 7.5% cap → ~28%. Premium NOI or a 7% cap pushes it to the mid-30s; an 8.5% cap or soft NOI drops it to ~12–20%. 65% LTC, recap at stabilization. Model is the source of truth.</a:t>
             </a:r>
             <a:endParaRPr lang="en-US" dirty="0"/>
           </a:p>
@@ -1583,7 +1583,7 @@
           <a:p>
             <a:r>
               <a:rPr lang="en-US" dirty="0"/>
-              <a:t>Phase 2 build-to-core LEVERED EQUITY cash flow — ties cell-for-cell to the model's Phase 2 sheet: equity $16.4M (bcEq, split Yr 0–1), stabilized levered CF ~$2.5M (NOI − debt; Yr 2 ramps at ~40%), exit equity $31.5M (recap $62M − loan), net equity CF [-8.2, -8.2, 1.0, 2.5, 34.0], IRR ~28% / ~2.3×. Project develops to ~$47M cost, recaps ~$62M @ a 7.5% cap.</a:t>
+              <a:t>Phase 2 build-to-core LEVERED EQUITY cash flow — ties cell-for-cell to the model's Phase 2 sheet: equity $16.4M (split Yr 0–1), stabilized levered CF $2.5M (NOI − debt; Yr 2 ramps at ~40%), exit equity $31.5M (recap $62M − loan), net equity CF [(8.2), (8.2), 1.0, 2.5, 34.0], IRR ~28% / ~2.3×. Project develops to ~$47.0M cost, recaps ~$62M @ a 7.5% cap.</a:t>
             </a:r>
             <a:endParaRPr lang="en-US" dirty="0"/>
           </a:p>
@@ -18822,7 +18822,7 @@
                 <a:ea typeface="DM Sans" pitchFamily="34" charset="-122"/>
                 <a:cs typeface="DM Sans" pitchFamily="34" charset="-120"/>
               </a:rPr>
-              <a:t>Build-to-core IRR (65% LTC, recap at stabilization) across stabilized NOI and exit cap — the two biggest swing factors. Base ($4.65M NOI, 7.5% cap) → ~28%; it holds in the mid-20s+ as long as NOI lands and caps stay sub-8%.</a:t>
+              <a:t>Build-to-core IRR (65% LTC, recap at stabilization) across stabilized NOI and exit cap — the two biggest swing factors. Base ($4.7M NOI, 7.5% cap) → ~28%; it holds in the mid-20s+ as long as NOI lands and caps stay sub-8%.</a:t>
             </a:r>
             <a:endParaRPr lang="en-US" sz="1300" dirty="0"/>
           </a:p>
@@ -24248,7 +24248,7 @@
                 <a:ea typeface="DM Sans" pitchFamily="34" charset="-122"/>
                 <a:cs typeface="DM Sans" pitchFamily="34" charset="-120"/>
               </a:rPr>
-              <a:t>Hospitality build-to-core, levered equity cash flow ($M). Build to ~$47M cost at 65% LTC; stabilize at the premium NOI; recap / sell at ~Yr 4 (~$62M @ a 7.5% cap). VIVÂMEE operates. Illustrative.</a:t>
+              <a:t>Hospitality build-to-core, levered equity cash flow ($M). Build to ~$47.0M cost at 65% LTC; stabilize at the premium NOI; recap / sell at ~Yr 4 (~$62M @ a 7.5% cap). VIVÂMEE operates. Illustrative.</a:t>
             </a:r>
             <a:endParaRPr lang="en-US" sz="1300" dirty="0"/>
           </a:p>
@@ -26774,7 +26774,7 @@
                 <a:ea typeface="DM Sans" pitchFamily="34" charset="-122"/>
                 <a:cs typeface="DM Sans" pitchFamily="34" charset="-120"/>
               </a:rPr>
-              <a:t>~$16.4M equity → ~$21M net; build-to-core (65% LTC) levered IRR ~28% / ~2.3× at the Yr-4 recap (~$62M on ~$47M cost). Ties to the model's build-to-core sheet.</a:t>
+              <a:t>~$16.4M equity → ~$21M net; build-to-core (65% LTC) levered IRR ~28% / ~2.3× at the Yr-4 recap (~$62M on ~$47.0M cost). Ties to the model's build-to-core sheet.</a:t>
             </a:r>
             <a:endParaRPr lang="en-US" sz="1100" dirty="0"/>
           </a:p>

</xml_diff>

<commit_message>
Reposition Renault as Opportunity 2 (Queenstown is Opportunity 1)
- Renault slide: eyebrow/title/desc/panel reframed from 'the first deal' to
  'opportunity two' (still the in-person site visit)
- Pipeline: reorder so Queenstown leads (opportunity 1 · this proposal),
  Renault second (opportunity 2); notes updated
- README updated to match

https://claude.ai/code/session_01BHWC2bwKRSfRRWtpGYSNwZ
</commit_message>
<xml_diff>
--- a/JAL_Queenstown_Harbor_Proposal.pptx
+++ b/JAL_Queenstown_Harbor_Proposal.pptx
@@ -615,7 +615,7 @@
           <a:p>
             <a:r>
               <a:rPr lang="en-US" dirty="0"/>
-              <a:t>Bob: 'this isn't a one-off.' Pipeline — Renault (first), Queenstown, South River, Kent Island (Palantir), a Colorado course (off-website), 1–2 in Virginia, plus family-owned courses regularly offered to Josh. He's negotiating development rights across the properties. Buys are exceptional (South River at half appraisal; 90% to depreciable assets → ~50% bonus depreciation).</a:t>
+              <a:t>Bob: 'this isn't a one-off.' Pipeline — Queenstown (this proposal, opp 1), Renault (opp 2), South River, Kent Island (Palantir), a Colorado course (off-website), 1–2 in Virginia, plus family-owned courses regularly offered to Josh. He's negotiating development rights across the properties. Buys are exceptional (South River at half appraisal; 90% to depreciable assets → ~50% bonus depreciation).</a:t>
             </a:r>
             <a:endParaRPr lang="en-US" dirty="0"/>
           </a:p>
@@ -2727,7 +2727,7 @@
           <a:p>
             <a:r>
               <a:rPr lang="en-US" dirty="0"/>
-              <a:t>Renault (NJ) is the lead / first deal and the site-visit location (Bob: 'an expansion down at Reno, which is where I'd meet you'). Township offered ~34 lots; +100–200 hotel rooms planned; architect already mapping. The capital-light entitled-lot playbook applies here too.</a:t>
+              <a:t>Renault (NJ) is opportunity 2 (after Queenstown) and the site-visit location (Bob: 'an expansion down at Reno, which is where I'd meet you'). Township offered ~34 lots; +100–200 hotel rooms planned; architect already mapping. The capital-light entitled-lot playbook applies here too.</a:t>
             </a:r>
             <a:endParaRPr lang="en-US" dirty="0"/>
           </a:p>
@@ -4131,7 +4131,7 @@
                 <a:ea typeface="Montserrat" pitchFamily="34" charset="-122"/>
                 <a:cs typeface="Montserrat" pitchFamily="34" charset="-120"/>
               </a:rPr>
-              <a:t>Renault Winery</a:t>
+              <a:t>Queenstown Harbor</a:t>
             </a:r>
             <a:endParaRPr lang="en-US" sz="1000" dirty="0"/>
           </a:p>
@@ -4190,7 +4190,7 @@
                 <a:ea typeface="Montserrat" pitchFamily="34" charset="-122"/>
                 <a:cs typeface="Montserrat" pitchFamily="34" charset="-120"/>
               </a:rPr>
-              <a:t>NJ · first deal</a:t>
+              <a:t>MD · opportunity 1 (this proposal)</a:t>
             </a:r>
             <a:endParaRPr lang="en-US" sz="900" dirty="0"/>
           </a:p>
@@ -4252,7 +4252,7 @@
                 <a:ea typeface="DM Sans" pitchFamily="34" charset="-122"/>
                 <a:cs typeface="DM Sans" pitchFamily="34" charset="-120"/>
               </a:rPr>
-              <a:t>~34 township-offered lots + a +100–200-room hotel expansion</a:t>
+              <a:t>~280 entitled lots around the 36 holes (~1,000 ac, ~zero basis)</a:t>
             </a:r>
             <a:endParaRPr lang="en-US" sz="900" dirty="0"/>
           </a:p>
@@ -4311,7 +4311,7 @@
                 <a:ea typeface="Montserrat" pitchFamily="34" charset="-122"/>
                 <a:cs typeface="Montserrat" pitchFamily="34" charset="-120"/>
               </a:rPr>
-              <a:t>Queenstown Harbor</a:t>
+              <a:t>Renault Winery</a:t>
             </a:r>
             <a:endParaRPr lang="en-US" sz="1000" dirty="0"/>
           </a:p>
@@ -4370,7 +4370,7 @@
                 <a:ea typeface="Montserrat" pitchFamily="34" charset="-122"/>
                 <a:cs typeface="Montserrat" pitchFamily="34" charset="-120"/>
               </a:rPr>
-              <a:t>MD · this proposal</a:t>
+              <a:t>NJ · opportunity 2</a:t>
             </a:r>
             <a:endParaRPr lang="en-US" sz="900" dirty="0"/>
           </a:p>
@@ -4432,7 +4432,7 @@
                 <a:ea typeface="DM Sans" pitchFamily="34" charset="-122"/>
                 <a:cs typeface="DM Sans" pitchFamily="34" charset="-120"/>
               </a:rPr>
-              <a:t>~280 entitled lots around the 36 holes (~1,000 ac, ~zero basis)</a:t>
+              <a:t>~34 township-offered lots + a +100–200-room hotel expansion</a:t>
             </a:r>
             <a:endParaRPr lang="en-US" sz="900" dirty="0"/>
           </a:p>
@@ -44359,7 +44359,7 @@
                 <a:ea typeface="Montserrat" pitchFamily="34" charset="-122"/>
                 <a:cs typeface="Montserrat" pitchFamily="34" charset="-120"/>
               </a:rPr>
-              <a:t>THE FIRST DEAL  ·  RENAULT WINERY</a:t>
+              <a:t>OPPORTUNITY 2  ·  RENAULT WINERY</a:t>
             </a:r>
             <a:endParaRPr lang="en-US" sz="1000" dirty="0"/>
           </a:p>
@@ -44398,7 +44398,7 @@
                 <a:ea typeface="Montserrat" pitchFamily="34" charset="-122"/>
                 <a:cs typeface="Montserrat" pitchFamily="34" charset="-120"/>
               </a:rPr>
-              <a:t>Renault — the first deal, and the site visit.</a:t>
+              <a:t>Renault — opportunity two, and the site visit.</a:t>
             </a:r>
             <a:endParaRPr lang="en-US" sz="2500" dirty="0"/>
           </a:p>
@@ -44440,7 +44440,7 @@
                 <a:ea typeface="DM Sans" pitchFamily="34" charset="-122"/>
                 <a:cs typeface="DM Sans" pitchFamily="34" charset="-120"/>
               </a:rPr>
-              <a:t>Renault Winery (Egg Harbor City, NJ — ~25 min from Atlantic City) is the lead property and where we'll meet. The township has offered land for ~34 lots overlooking the course, a +100–200-room hotel expansion is planned, and the architect is already mapping lots.</a:t>
+              <a:t>Renault Winery (Egg Harbor City, NJ — ~25 min from Atlantic City) is the next opportunity after Queenstown, and where we'll meet in person. The township has offered land for ~34 lots overlooking the course, a +100–200-room hotel expansion is planned, and the architect is already mapping lots.</a:t>
             </a:r>
             <a:endParaRPr lang="en-US" sz="1300" dirty="0"/>
           </a:p>
@@ -45087,7 +45087,7 @@
                 <a:ea typeface="Montserrat" pitchFamily="34" charset="-122"/>
                 <a:cs typeface="Montserrat" pitchFamily="34" charset="-120"/>
               </a:rPr>
-              <a:t>WHY RENAULT FIRST</a:t>
+              <a:t>WHY RENAULT'S NEXT</a:t>
             </a:r>
             <a:endParaRPr lang="en-US" sz="1000" dirty="0"/>
           </a:p>
@@ -45297,7 +45297,7 @@
                 <a:ea typeface="DM Sans" pitchFamily="34" charset="-122"/>
                 <a:cs typeface="DM Sans" pitchFamily="34" charset="-120"/>
               </a:rPr>
-              <a:t>Closest asset to walk — ~25 minutes from Atlantic City airport; the natural place to start.</a:t>
+              <a:t>Closest asset to walk — ~25 minutes from Atlantic City airport; the natural place to meet and see the playbook on the ground.</a:t>
             </a:r>
             <a:endParaRPr lang="en-US" sz="1000" dirty="0"/>
           </a:p>

</xml_diff>

<commit_message>
Strengthen the skin-in-the-game signal (Bob's key ask)
- 50/50 slide: drop 'no capital required' (an own-goal) → 'sweat equity + a cash
  co-invest + $15K/mo — skin in the game'
- Firm the co-invest from 'intends to invest (TBD)' → 'will co-invest my own
  capital alongside you (amount sized in diligence)' on the structure + engagement slides
- Restore the 'Skin in the game' tag on the engagement slide (mirrors Bob's words)

Net: the deck now states plainly that JAL's pay is mostly contingent carry AND
JAL's own capital is in. Text-only; financials stay linked to the model.

https://claude.ai/code/session_01BHWC2bwKRSfRRWtpGYSNwZ
</commit_message>
<xml_diff>
--- a/JAL_Queenstown_Harbor_Proposal.pptx
+++ b/JAL_Queenstown_Harbor_Proposal.pptx
@@ -1759,7 +1759,7 @@
           <a:p>
             <a:r>
               <a:rPr lang="en-US" dirty="0"/>
-              <a:t>The structure (per Bob): the property contributes the land; the development company (Accountable Equity / Capital H6 · Bob · JAL · partners) entitles and sells the lots; costs repaid, then a straight 50/50. JAL runs entitlement + capital formation + lot sales for a share of the dev-co 50% plus a $15K/mo retainer, and intends to invest (amount TBD in diligence). VIVÂMEE operates the resort.</a:t>
+              <a:t>The structure (per Bob): the property contributes the land; the development company (Accountable Equity / Capital H6 · Bob · JAL · partners) entitles and sells the lots; costs repaid, then a straight 50/50. JAL runs entitlement + capital formation + lot sales for a share of the dev-co 50% plus a $15K/mo retainer, and will co-invest its own capital alongside you (amount sized in diligence). VIVÂMEE operates the resort.</a:t>
             </a:r>
             <a:endParaRPr lang="en-US" dirty="0"/>
           </a:p>
@@ -12280,7 +12280,7 @@
                 <a:ea typeface="DM Sans" pitchFamily="34" charset="-122"/>
                 <a:cs typeface="DM Sans" pitchFamily="34" charset="-120"/>
               </a:rPr>
-              <a:t>Accountable Equity / Capital H6 · Bob · partners take the balance. JAL = sweat equity + $15K/mo — no capital required.</a:t>
+              <a:t>Accountable Equity / Capital H6 · Bob · partners take the balance. JAL = sweat equity + a cash co-invest + $15K/mo — skin in the game.</a:t>
             </a:r>
             <a:endParaRPr lang="en-US" sz="900" dirty="0"/>
           </a:p>
@@ -29446,7 +29446,7 @@
                 <a:ea typeface="DM Sans" pitchFamily="34" charset="-122"/>
                 <a:cs typeface="DM Sans" pitchFamily="34" charset="-120"/>
               </a:rPr>
-              <a:t>JAL is a member of the development company — earning a share of its 50% (plus a $15K/mo retainer); intends to invest, sized in diligence.</a:t>
+              <a:t>JAL is a member of the development company — earning a share of its 50% (plus a $15K/mo retainer) and co-investing its own capital alongside you, sized in diligence.</a:t>
             </a:r>
             <a:endParaRPr lang="en-US" sz="1100" dirty="0"/>
           </a:p>
@@ -29954,7 +29954,7 @@
                 <a:ea typeface="DM Sans" pitchFamily="34" charset="-122"/>
                 <a:cs typeface="DM Sans" pitchFamily="34" charset="-120"/>
               </a:rPr>
-              <a:t>Aligned to value created — and I intend to contribute capital to the dev co myself (amount sized in diligence).</a:t>
+              <a:t>Aligned to value created — and I'll co-invest my own capital alongside you (amount sized in diligence).</a:t>
             </a:r>
             <a:endParaRPr lang="en-US" sz="1000" dirty="0"/>
           </a:p>
@@ -29996,7 +29996,7 @@
                 <a:ea typeface="Montserrat" pitchFamily="34" charset="-122"/>
                 <a:cs typeface="Montserrat" pitchFamily="34" charset="-120"/>
               </a:rPr>
-              <a:t>Aligned</a:t>
+              <a:t>Skin in</a:t>
             </a:r>
             <a:endParaRPr lang="en-US" sz="1300" dirty="0"/>
           </a:p>
@@ -30016,7 +30016,7 @@
                 <a:ea typeface="Montserrat" pitchFamily="34" charset="-122"/>
                 <a:cs typeface="Montserrat" pitchFamily="34" charset="-120"/>
               </a:rPr>
-              <a:t>upside</a:t>
+              <a:t>the game</a:t>
             </a:r>
             <a:endParaRPr lang="en-US" sz="1300" dirty="0"/>
           </a:p>

</xml_diff>